<commit_message>
docs: sync with Fleet 2 and tailoring; Enterpret mapping; deck v2
Every doc checked against the code: push-only webhooks with no API key,
PATCH config, bulk replay, 413 body limit, pull deadline and byte cap,
per-source sync lock, refused default bootstrap token, health status only
for threads, 10-page Discourse cap, FI_ settings, Postgres swap wording,
five-step add-a-source recipe with the custom connector as the example.
Q&A bank gains "How this maps to Enterpret"; debt ledger line refs
refreshed with a "Kept on purpose" section; requirements map names the
new DB-level, RFC 4231 and tenant-check tests. Deck regenerated: slides
1-10 corrected, new slide 11 "Where this sits in Enterpret's pipeline".

Co-Authored-By: Claude Fable 5.1 <noreply@anthropic.com>
</commit_message>
<xml_diff>
--- a/docs/slides/deck.pptx
+++ b/docs/slides/deck.pptx
@@ -15,9 +15,10 @@
     <p:sldId id="263" r:id="rId9"/>
     <p:sldId id="264" r:id="rId10"/>
     <p:sldId id="265" r:id="rId11"/>
+    <p:sldId id="266" r:id="rId12"/>
   </p:sldIdLst>
   <p:notesMasterIdLst>
-    <p:notesMasterId r:id="rId12"/>
+    <p:notesMasterId r:id="rId13"/>
   </p:notesMasterIdLst>
   <p:sldSz cx="12192000" cy="6858000"/>
   <p:notesSz cx="6858000" cy="12192000"/>
@@ -116,13 +117,13 @@
   <p:extLst>
     <p:ext uri="{521415D9-36F7-43E2-AB2F-B90AF26B5E84}">
       <p14:sectionLst xmlns:p14="http://schemas.microsoft.com/office/powerpoint/2010/main">
-        <p14:section name="Opening" id="{3b7f6467-3516-b048-2ab7-ab748f210a94}">
+        <p14:section name="Opening" id="{2f1400c7-5a62-928d-e8fe-b79d9af638fc}">
           <p14:sldIdLst>
             <p14:sldId id="256"/>
             <p14:sldId id="257"/>
           </p14:sldIdLst>
         </p14:section>
-        <p14:section name="How it works" id="{11e06800-6713-0c99-cc43-8a6976050635}">
+        <p14:section name="How it works" id="{9f90eb58-1d75-6f87-69c4-b72c4c2ff6b0}">
           <p14:sldIdLst>
             <p14:sldId id="258"/>
             <p14:sldId id="259"/>
@@ -130,16 +131,17 @@
             <p14:sldId id="261"/>
           </p14:sldIdLst>
         </p14:section>
-        <p14:section name="Why it holds" id="{9de4ed65-67a9-1d99-bde5-6e285bdea58d}">
+        <p14:section name="Why it holds" id="{d0b37b4a-c434-980d-bf6d-a6bdf20e040e}">
           <p14:sldIdLst>
             <p14:sldId id="262"/>
             <p14:sldId id="263"/>
           </p14:sldIdLst>
         </p14:section>
-        <p14:section name="Where it goes" id="{8c96e5fe-923a-a39c-0a9f-2c281cc3abee}">
+        <p14:section name="Where it goes" id="{a296eb9e-e3d3-8853-136a-7169731b8582}">
           <p14:sldIdLst>
             <p14:sldId id="264"/>
             <p14:sldId id="265"/>
+            <p14:sldId id="266"/>
           </p14:sldIdLst>
         </p14:section>
       </p14:sectionLst>
@@ -547,8 +549,8 @@
             <a:r>
               <a:rPr lang="en-US" dirty="0"/>
               <a:t>Say this before anything else (60-second opening, demo_script.md):
-"This is a feedback ingestion service. Feedback comes from four places: Playstore reviews, tweets, Intercom conversations and Discourse forum posts. Some sources push to us with signed webhooks; Discourse we pull on a timer. Many customers, called tenants, share the service, and each one only ever sees its own data.
-The design fits in one sentence: we save the raw payload to disk before we say yes, and everything after that is a retry or a replay. A webhook checks the API key, the source and the signature, writes one row to a raw_events table, and answers 202. A background worker takes rows from that table, asks the right connector to turn each one into a standard feedback record, and saves it keyed on source plus the source's own id. So duplicates collapse to one row, bad payloads go to a dead list, and anything can be replayed."
+"This is a feedback ingestion service. Feedback comes from five places: Play Store reviews, tweets, Intercom conversations, Discourse forum posts, and a custom webhook that takes the record shape Enterpret's public docs describe. Some sources push to us with signed webhooks; Discourse we pull on a timer. Many customers, called tenants, share the service, and each one only ever sees its own data.
+The design fits in one sentence: we save the raw payload to disk before we say yes, and everything after that is a retry or a replay. A webhook does two checks and one write. The source id in the URL picks the source, and that source's HMAC signature proves the sender. There is no API key on that route, because a third-party sender cannot add ours. Then one row goes into a raw_events table and we answer 202, which means accepted, not processed. A background worker takes rows from that table, asks the right connector to turn each one into a standard feedback record, and saves it keyed on source plus the source's own id. So duplicates collapse to one row, bad payloads go to a dead list, and anything can be replayed."
 The three guarantees (whiteboard.md, step 6): durable before ack; idempotent by key; replayable.</a:t>
             </a:r>
             <a:endParaRPr lang="en-US" dirty="0"/>
@@ -638,11 +640,11 @@
             <a:r>
               <a:rPr lang="en-US" dirty="0"/>
               <a:t>Debt ledger, top three (debt_ledger.md):
-1. #6, the Discourse 20-page cap (discourse_pull.py:26). "A hard cap with a loud error beats silently skipping posts, but a busy forum would get stuck until someone shrinks the window." Upgrade: split the window by date and page through each slice, or shrink the window on its own when the cap is hit.
-2. #1, migrations (db.py:30). "We fail fast on schema drift today; the first schema change on real data is when I add Alembic migrations."
+1. #6, the Discourse 10-page cap (discourse_pull.py:29). About 500 posts per day is the hard limit of Discourse search. "A hard cap with a loud error beats silently skipping posts, but a forum busier than about 500 posts a day would need date slicing." Today a person lowers window_days with PATCH. Upgrade: split the window by date and page through each slice, or shrink the window on its own when the cap is hit.
+2. #1, migrations (db.py:39). "We fail fast on schema drift today; the first schema change on real data is when I add Alembic migrations."
 3. #12, the shared bootstrap token (tenants.py:18). "A shared token is enough to bootstrap a take-home; production admin needs per-person identity and an audit trail."
-Demo (demo_script.md): nine steps, about two minutes. Watch for four things: a duplicate that is stored once, two apps of the same type, a tenant that sees nothing, and a kill -9 that loses nothing. Step 7 needs network (meta.discourse.org); without it run uv run pytest tests/e2e/test_pull_to_query.py -q.
-30-second close: "So, the four things: a duplicate stored once, two apps of the same type kept apart, a tenant that sees nothing of another, and a hard kill that lost nothing. Plus a bad payload parked with its reason and replayed, and a live pull through the same pipeline. All of it rests on one rule: save the raw payload before we say yes, then everything is a retry or a replay. Adding a new source is one connector file, one metadata model, one registry line and fixtures. Happy to add a field live, or to break something and show you where it lands."</a:t>
+Demo (demo_script.md): ten steps, about two minutes. demo.sh exports a random FI_BOOTSTRAP_TOKEN first, because the default token is refused. Two synthetic tenants: lumenote (a consumer app) and brightwave (B2B SaaS). Watch for five things: a duplicate that is stored once, two apps of the same type, a tenant that sees nothing, one custom batch that becomes three records of three kinds, and a kill -9 that loses nothing. Step 8 needs network (meta.discourse.org); without it run uv run pytest tests/e2e/test_pull_to_query.py -q.
+30-second close: "So, the four things: a duplicate stored once, two apps of the same type kept apart, a tenant that sees nothing of another, and a hard kill that lost nothing. Plus a bad payload parked with its reason and replayed, and a live pull through the same pipeline. All of it rests on one rule: save the raw payload before we say yes, then everything is a retry or a replay. Adding a new source is an enum value, a metadata model, one connector file, one registry entry and fixtures, and the custom connector shows it. Happy to add a field live, or to break something and show you where it lands."</a:t>
             </a:r>
             <a:endParaRPr lang="en-US" dirty="0"/>
           </a:p>
@@ -666,6 +668,102 @@
             <a:fld id="{F7021451-1387-4CA6-816F-3879F97B5CBC}" type="slidenum">
               <a:rPr lang="en-US"/>
               <a:t>10</a:t>
+            </a:fld>
+            <a:endParaRPr lang="en-US"/>
+          </a:p>
+        </p:txBody>
+      </p:sp>
+    </p:spTree>
+    <p:extLst>
+      <p:ext uri="{BB962C8B-B14F-4D97-AF65-F5344CB8AC3E}">
+        <p14:creationId xmlns:p14="http://schemas.microsoft.com/office/powerpoint/2010/main" val="1024086991"/>
+      </p:ext>
+    </p:extLst>
+  </p:cSld>
+  <p:clrMapOvr>
+    <a:masterClrMapping/>
+  </p:clrMapOvr>
+</p:notes>
+</file>
+
+<file path=ppt/notesSlides/notesSlide11.xml><?xml version="1.0" encoding="utf-8"?>
+<p:notes xmlns:a="http://schemas.openxmlformats.org/drawingml/2006/main" xmlns:r="http://schemas.openxmlformats.org/officeDocument/2006/relationships" xmlns:p="http://schemas.openxmlformats.org/presentationml/2006/main">
+  <p:cSld>
+    <p:spTree>
+      <p:nvGrpSpPr>
+        <p:cNvPr id="1" name=""/>
+        <p:cNvGrpSpPr/>
+        <p:nvPr/>
+      </p:nvGrpSpPr>
+      <p:grpSpPr>
+        <a:xfrm>
+          <a:off x="0" y="0"/>
+          <a:ext cx="0" cy="0"/>
+          <a:chOff x="0" y="0"/>
+          <a:chExt cx="0" cy="0"/>
+        </a:xfrm>
+      </p:grpSpPr>
+      <p:sp>
+        <p:nvSpPr>
+          <p:cNvPr id="2" name="Slide Image Placeholder 1"/>
+          <p:cNvSpPr>
+            <a:spLocks noGrp="1" noRot="1" noChangeAspect="1"/>
+          </p:cNvSpPr>
+          <p:nvPr>
+            <p:ph type="sldImg"/>
+          </p:nvPr>
+        </p:nvSpPr>
+        <p:spPr/>
+      </p:sp>
+      <p:sp>
+        <p:nvSpPr>
+          <p:cNvPr id="3" name="Notes Placeholder 2"/>
+          <p:cNvSpPr>
+            <a:spLocks noGrp="1"/>
+          </p:cNvSpPr>
+          <p:nvPr>
+            <p:ph type="body" idx="1"/>
+          </p:nvPr>
+        </p:nvSpPr>
+        <p:spPr/>
+        <p:txBody>
+          <a:bodyPr/>
+          <a:lstStyle/>
+          <a:p>
+            <a:r>
+              <a:rPr lang="en-US" dirty="0"/>
+              <a:t>Honesty rules (docs/research/00_tailoring_decisions.md): say "their public docs describe" or "their engineering blog says", never "they do X internally". Quote no number you cannot show on the linked page.
+Opening line: "Enterpret's site describes the product as Unify, Understand, Act. This service is the Unify step: it gets feedback in from many sources, keeps it safe, and turns it into one standard Feedback Record. Taxonomy, themes and Wisdom are the Understand step, and they would read our records; I did not build them."
+Custom connector: "Their public webhook takes a batch of records with an id, a type, createdAt in epoch seconds and typed metadata. Our custom connector takes that same shape, so the add-a-source story is done against a contract they know. One push is one raw event. Each record upserts on source and record id. The kind comes from the type, and SURVEY needed a new kind, survey. AUDIO_RECORDING is not text, so it is refused and the batch goes dead."
+Auth difference: their docs describe an api-key header per integration. Ours is a per-source URL plus an HMAC signature, so a sender proves itself without holding a tenant key. Same idea: one credential per source.
+202: "Their docs say accepted does not mean processed. That is exactly our 202: the raw row is on disk, and the worker does the rest."
+Duplicates: "Their default skips a repeated id, and replace is an opt-in. We skip a repeated delivery at raw_events. For the record itself we always take a newer or equal version and never an older one, which is close to their opt-in replace plus the version rule."
+Version guard: "Their engineering blog says stale and out-of-order updates are rejected by version. Our upsert does the same with COALESCE(updated, created)."
+Noisy neighbours: "Their engineering blog names queue clogging and noisy neighbours as incidents and describes partitioning by tenant. We have one shared queue, so a burst delays others but loses nothing. Per-tenant claiming is the upgrade."
+Not built, on purpose: PII redaction before storage (their docs say they obfuscate PII before ingestion; we only keep it out of logs and error text), the ClickHouse analytics projection their blog describes, rate limits, users and accounts. Their help center describes a 4-hour poll for support tools and app stores; ours is FI_PULL_INTERVAL_SECONDS, 300 by default.</a:t>
+            </a:r>
+            <a:endParaRPr lang="en-US" dirty="0"/>
+          </a:p>
+        </p:txBody>
+      </p:sp>
+      <p:sp>
+        <p:nvSpPr>
+          <p:cNvPr id="4" name="Slide Number Placeholder 3"/>
+          <p:cNvSpPr>
+            <a:spLocks noGrp="1"/>
+          </p:cNvSpPr>
+          <p:nvPr>
+            <p:ph type="sldNum" sz="quarter" idx="10"/>
+          </p:nvPr>
+        </p:nvSpPr>
+        <p:spPr/>
+        <p:txBody>
+          <a:bodyPr/>
+          <a:lstStyle/>
+          <a:p>
+            <a:fld id="{F7021451-1387-4CA6-816F-3879F97B5CBC}" type="slidenum">
+              <a:rPr lang="en-US"/>
+              <a:t>11</a:t>
             </a:fld>
             <a:endParaRPr lang="en-US"/>
           </a:p>
@@ -731,13 +829,13 @@
             <a:r>
               <a:rPr lang="en-US" dirty="0"/>
               <a:t>Every requirement maps to code and to a test that proves it (00_architecture.md, requirements map):
-- Sources: tests/unit/connectors/test_contract.py, test_registry.py, one test per connector.
-- Push: tests/api/test_push_api.py, tests/e2e/test_push_to_query.py.
+- Sources: tests/unit/connectors/test_contract.py, test_registry.py, one test per connector; the custom webhook in tests/unit/connectors/test_custom.py and tests/api/test_custom_webhook.py.
+- Push: tests/api/test_push_api.py (no API key, signature first, push-only), tests/e2e/test_push_to_query.py.
 - Pull: tests/unit/services/test_pull.py, tests/e2e/test_pull_to_query.py, tests/live/test_discourse_live.py.
-- Multi-tenancy: tests/adapters/contract_stores.py, tests/api/test_records_api.py.
+- Multi-tenancy: tests/adapters/contract_stores.py, tests/api/test_records_api.py, tests/api/test_tenants_api.py.
 - Idempotency: tests/e2e/test_push_to_query.py, tests/adapters/contract_upsert.py.
 - Several sources of one type: tests/e2e/test_multi_source_same_type.py.
-- Beyond the brief: tests/e2e/test_dlq_replay.py, tests/e2e/test_restart_resume.py.
+- Beyond the brief: tests/e2e/test_dlq_replay.py, tests/e2e/test_restart_resume.py, tests/api/test_replay_api.py (bulk replay).
 If asked "did you write this": "I designed it and reviewed every file; AI agents wrote and audited the code. Every decision went through a five-advisor council and is in docs/decisions."</a:t>
             </a:r>
             <a:endParaRPr lang="en-US" dirty="0"/>
@@ -827,10 +925,11 @@
             <a:r>
               <a:rPr lang="en-US" dirty="0"/>
               <a:t>Whiteboard steps 1 to 3 (whiteboard.md).
-Push arrow: "The webhook does three checks and one write. Whose tenant (API key), which source (id must belong to that tenant), is the signature right (HMAC over the raw bytes with that source's secret). Then one insert, then 202. 202 means saved, not processed."
+Push arrow: "The webhook does two checks and one write. The source id in the URL picks the source, and the tenant comes from that source row. Then the signature: an HMAC over the raw bytes with that source's own secret. No API key, because a third-party sender like Intercom cannot add our key. Webhooks are push-only: a pull source answers 409. Then one insert, then 202. 202 means accepted, not processed."
 Pull arrow: "Polling is just another producer. The connector returns pages; every payload goes through the same accept call a webhook uses."
 raw_events: "This table is both the audit log and the work queue. Unique on (source, external event id), so a repeated webhook is stored once."
-Worker: "One SQL statement: update rows that are pending-and-due or whose lease expired, set processing and a lease, return them. Atomic, so two workers never take the same row. A crashed worker's rows come back when the lease expires."
+Worker: "One SQL statement claims a batch: rows that are pending or failed and due, or whose lease expired. It sets processing and a lease and returns them. Atomic, so two workers never take the same row. A crashed worker's rows come back when the lease expires."
+Ops strip: health, the dead list, replay of one event, and bulk replay by source and status.
 Connectors: "Nothing else in the system knows which sources exist."
 If asked "why not a real queue": "A table I can query, replay by id and filter per tenant. It is one process and zero infrastructure for a demo. The adapter boundary is where Kafka or SQS would go, and I would be honest that a broker changes the retry model, not just the adapter."
 Never call raw_events an "outbox". It is an inbox, a durable log.</a:t>
@@ -922,12 +1021,12 @@
             <a:r>
               <a:rPr lang="en-US" dirty="0"/>
               <a:t>Push sequence (00_architecture.md) and demo step 3 (demo_script.md).
-1. "The webhook does three checks and one write." A bad signature is 401 and nothing is stored; the HMAC is checked on the raw bytes before we parse or write.
+1. "The webhook does two checks and one write: the source id picks the source, its HMAC proves the sender." Order: unknown source 404; a pull source 409 (webhooks are push-only); bad signature 401 and nothing is stored; only then a disabled source 409, so state is told only to a caller who proved itself; a body that is not a JSON object 400. Any body over 1 MiB is 413 before all of this. The HMAC is checked on the raw bytes before we parse or write.
 2. "202 means saved, not processed yet. The second copy has the same event id, the review id plus its last-modified time, so it is dropped, and we still answer 202 so the sender stops retrying."
-3. "One SQL statement ... Atomic, so two workers never take the same row. A crashed worker's rows come back when the lease expires."
+3. "One SQL statement claims a batch of due rows ... Atomic, so two workers never take the same row. A crashed worker's rows come back when the lease expires."
 4. "A connector validates the payload with a Pydantic input model, then maps it to our record."
 5. "Unique on (source, external id). The upsert only applies a version that is not older." Outcomes: "Bad payloads die on the first try, they are never retried. Flaky things back off. Marks are fenced on the lease, so a stale worker cannot overwrite a newer claim."
-6. "Every request carries an API key. We store only its hash. Every read is filtered by that tenant; a foreign id is a 404, not a 403, so we do not leak existence."</a:t>
+6. "Every read and admin request carries an API key. We store only its hash. Every read is filtered by that tenant; a foreign id is a 404, not a 403, so we do not leak existence." The webhook and /health are the only routes without one.</a:t>
             </a:r>
             <a:endParaRPr lang="en-US" dirty="0"/>
           </a:p>
@@ -1015,12 +1114,14 @@
           <a:p>
             <a:r>
               <a:rPr lang="en-US" dirty="0"/>
-              <a:t>Pull sequence (00_architecture.md), whiteboard step 1, demo step 7.
+              <a:t>Pull sequence (00_architecture.md), whiteboard step 1, demo step 8.
 "Polling is just another producer. The connector fetches pages from the real forum, and every payload goes through the same accept call as a webhook. The bookmark, the cursor, is saved only after the page's rows are on disk. The seed fixes the window to four days in January 2021, so the demo is repeatable."
-Detail: the cursor is saved as the max of stored and page cursor; for Discourse it moves only on the final page, because Discourse does not promise oldest-first order, to the newest post minus a 60 s overlap.
+Detail: the cursor is saved as the later of the stored and the page cursor. For Discourse it moves only on the final page, because Discourse does not promise oldest-first order. It moves to the newest post minus a 60 s overlap, or to the window end if that is already in the past, so a quiet window still moves forward.
+Bounds on one sync: FI_PULL_DEADLINE_SECONDS (60) is checked before every upstream call; one response is capped at FI_HTTP_MAX_BYTES (2,000,000); redirects are not followed. One sync per source at a time: a second POST sync gets 409 and the scheduler skips that source.
 Overlap (failure_scenarios.md): "We would rather fetch a post twice than miss it: the bookmark is set a minute back and the unique key drops the repeats."
-If asked about rate limits: "The 429 becomes a transient error, the pull stops, saved pages stay saved, and the cursor has not moved, so the next run starts from the same place and repeats are dropped."
-Bounded window (debt ledger #6): at most 20 search pages, about 1000 posts, per window; a busier window raises an error and leaves the cursor where it was. "A hard cap with a loud error beats silently skipping posts."</a:t>
+If asked about rate limits: "The 429 becomes a transient error, the pull stops, saved pages stay saved, and the cursor has not moved past them, so the next run starts from the same place and repeats are dropped." Pull treats permanent and transient upstream errors the same way: stop, keep the cursor, retry next tick.
+Bounded window (debt ledger #6): at most 10 search pages, about 500 posts, per window, so with window_days=1 about 500 posts per day is the hard limit of Discourse search. A busier window raises an error and leaves the cursor where it was; lower window_days with PATCH /v1/sources/{id}. "A hard cap with a loud error beats silently skipping posts."
+A failing source shows on /health as a count, failing_sources, but does not turn /health red: only a dead or stuck worker or scheduler thread does.</a:t>
             </a:r>
             <a:endParaRPr lang="en-US" dirty="0"/>
           </a:p>
@@ -1110,7 +1211,8 @@
               <a:rPr lang="en-US" dirty="0"/>
               <a:t>Whiteboard steps 3 and 4 (whiteboard.md), demo step 4, ADR-002.
 Records: "Unique on (source, external id). The upsert only applies a version that is not older. Deletes are tombstones and always win. Replaying the raw table rebuilds this table."
-Source: "A source is one configured instance, so two Playstore apps are two rows with their own secrets and cursors."
+Source: "A source is one configured instance, so two Play Store apps are two rows with their own secrets and cursors." Re-enable a source with PATCH; a new POST is a new source, and its items ingest again.
+Kind: review, conversation, post, and survey. Survey came with the custom connector: a custom record's kind comes from its type (REVIEW, CONVERSATION, FORUM_CONVERSATION_THREAD as post, SURVEY). The record id is the uuid5 of source id and external id.
 Demo step 4: "Same payload, different source. It is not a duplicate, because both keys include the source id. Two apps can share a review id without colliding."
 Why one table plus JSON (ADR-002 rejected alternatives): a table per source type makes every cross-source query a UNION and a new source needs a migration; content-hash dedupe would turn an edited review into a second record. "The source's id is the real identity."
 Tenancy: the composite foreign key means a record whose tenant does not match its source cannot be written.
@@ -1206,8 +1308,8 @@
 Duplicate webhook (failure_scenarios.md): "Same item, same update time, same key: the second copy is dropped and we still answer 202."
 Edits out of order: draw two arrows into one record with timestamps. "COALESCE(updated, created) must not be older. Equal is accepted, so replay works." Or: "A record only moves forward in time: an older edit that arrives late loses the timestamp check."
 Source deletes: "deleted_at set, hidden by default, never undone by a later edit."
-Transformer bug last week: draw an arrow from raw_events back into the pipeline. "Fix the connector, bump its version, replay the window. No re-fetch, nothing lost." Or: "We keep every raw payload, so a bug costs a replay, not data: fix it, bump the version, replay."
-Demo step 6 shows replay: a malformed Playstore payload goes dead on the first try; replay resets attempts and it dies again because the payload really is bad. "That proves replay re-runs the stored payload. After a real connector fix, the same call brings it back."</a:t>
+Transformer bug last week: draw an arrow from raw_events back into the pipeline. "Fix the connector, bump its version, replay. No re-fetch, nothing lost." Bulk replay: POST /admin/raw-events/replay?source_id=...&amp;status=dead (or failed, or processed), up to 500 rows a call, only the caller's tenant. There is no time-window filter. Replay goes through the same version guard, so an equal version is accepted and the fixed output overwrites the record. Order does not matter: an older version is skipped and a delete, once applied, sticks.
+Demo step 7 shows replay: a malformed Playstore payload goes dead on the first try; replay resets attempts and it dies again because the payload really is bad. "That proves replay re-runs the stored payload. After a real connector fix, the same call brings it back."</a:t>
             </a:r>
             <a:endParaRPr lang="en-US" dirty="0"/>
           </a:p>
@@ -1298,11 +1400,11 @@
               <a:t>One-sentence answers from failure_scenarios.md (10k burst from whiteboard.md).
 DB down on push: "We never say yes before the row is on disk, so the sender gets a 503 and retries, and nothing we accepted is lost."
 Worker crash mid-event: "The lease runs out, the row is picked up again, and the upsert makes doing it twice the same as doing it once."
-Worker thread dies: "Health goes red and the queue grows, but intake keeps working; restart the process and the backlog drains from disk." (Demo step 8: kill -9 with 20 pending, restart, they drain.)
+Worker thread dies: "Health goes red (503) and the queue grows, but intake keeps working; restart the process and the backlog drains from disk." (Demo step 9: kill -9 with 20 pending, restart, they drain.) A failing pull source does not turn health red; it only raises the failing_sources count.
 Poison payload: "A payload that retrying cannot fix goes straight to the dead list with its reason, and waits there for a fix and a replay."
-10k burst: draw a thick arrow into the table. "Inserts are cheap, the 202 stays fast, the backlog drains at the worker's pace. SQLite is one writer; past that, DATABASE_URL points at Postgres."
-Noisy tenant: "Today it is first come, first served, so a burst delays others but loses nothing; the fix is a per-tenant rate limit and fair claiming."
-Two workers: draw a second worker box with the same claim arrow. "Same single UPDATE. On Postgres I add SKIP LOCKED to that one query." Full line: "It is safe because the claim is a single statement and the upsert is idempotent; it only wastes calls on the scheduler side, so in production one scheduler runs."
+10k burst: draw a thick arrow into the table. "Inserts are cheap, the 202 stays fast, the backlog drains at the worker's pace. SQLite is one writer. For Postgres: set FI_DATABASE_URL, add a driver, change three queries (claim, upsert, enqueue), add migrations." A body over 1 MiB is refused with 413.
+Noisy tenant: "Today it is first come, first served, so a burst delays others but loses nothing; the fix is a per-tenant rate limit and fair claiming." Enterpret's engineering blog names queue clogging and noisy neighbours as incidents and describes partitioning by tenant; that is the upgrade here too.
+Two workers: draw a second worker box with the same claim arrow. "Same single UPDATE. On Postgres I add SKIP LOCKED to that one query." Full line: "It is safe because the claim is a single statement and the upsert is idempotent. On the pull side the per-source lock is per process, so two processes can sync one source at once; the unique raw-event key drops the repeats, it only wastes calls." Under uvicorn --workers N every process reads the same environment, so to have exactly one consumer run separate processes.
 Rate-limited pull: "We stop, keep what we already saved, and try again next tick from the same bookmark; the repeats that causes are dropped by the unique key."
 Never say SKIP LOCKED runs today. It is the Postgres upgrade line.</a:t>
             </a:r>
@@ -1392,9 +1494,9 @@
           <a:p>
             <a:r>
               <a:rPr lang="en-US" dirty="0"/>
-              <a:t>Connectors (whiteboard.md step 3): "A connector validates the payload with a Pydantic input model, then maps it to our record. Nothing else in the system knows which sources exist. Adding Zendesk is one file, one metadata model, one registry entry, one fixture; the contract test fails until all four exist."
-(extensions.md recipe 1 also adds SourceType.ZENDESK to domain/enums.py and KIND_BY_SOURCE, reusing a kind: a ticket is a conversation. The completeness test fails right away until it is there.)
-Ports and adapters: "Services only import the ports. The same contract test runs against the SQLite adapter and the in-memory fake, so I know the fake behaves like the real thing. That is how a Postgres or broker swap stays a one-file change."
+              <a:t>Connectors (whiteboard.md step 3): "A connector validates the payload with a Pydantic input model, then maps it to our record. Nothing else in the system knows which sources exist. Adding Zendesk is an enum value and its KIND_BY_SOURCE entry (a ticket is a conversation, so reuse that kind), a metadata model, a connector file with its input model, a registry entry, and fixtures." tests/unit/connectors/test_registry.py and the every-source-has-a-metadata-model test fail until all exist; then the contract tests run every fixture.
+Worked example: the custom connector (connectors/custom.py) was added exactly this way, with one extra: its kind comes from each record's type, so it maps in KIND_BY_RECORD_TYPE instead of KIND_BY_SOURCE.
+Ports and adapters: "Services only import the ports. The same contract test runs against the SQLite adapter and the in-memory fake, so I know the fake behaves like the real thing. That keeps a storage swap inside the adapters: for Postgres, three queries change, not the services."
 Postgres (extensions.md recipe 2): the claim subquery gets with_for_update(skip_locked=True); upsert and enqueue move to INSERT ... ON CONFLICT; add Alembic migrations. Never say SKIP LOCKED runs today.
 Kafka: "Swap the adapter, and change the retry model: visibility timeout instead of leases, no per-message delay." A broker cannot answer "show me tenant X's dead events" or "give me event 42", so the realistic design keeps raw_events as the durable log and puts only event ids on the broker.
 Never say Kafka is a one-adapter swap without adding "and a different retry model".</a:t>
@@ -2259,7 +2361,7 @@
                   <a:schemeClr val="accent4"/>
                 </a:solidFill>
               </a:rPr>
-              <a:t>Push, pull and one durable pipe: Intercom, Play Store, Twitter, Discourse</a:t>
+              <a:t>Push, pull and one durable pipe: Intercom, Play Store, Twitter, Discourse, a custom webhook</a:t>
             </a:r>
             <a:endParaRPr lang="en-US" sz="2000" dirty="0"/>
           </a:p>
@@ -2557,7 +2659,7 @@
       </p:sp>
       <p:sp>
         <p:nvSpPr>
-          <p:cNvPr id="3" name="next-head-135"/>
+          <p:cNvPr id="3" name="next-head-137"/>
           <p:cNvSpPr txBox="1"/>
           <p:nvPr/>
         </p:nvSpPr>
@@ -2596,7 +2698,7 @@
       </p:sp>
       <p:sp>
         <p:nvSpPr>
-          <p:cNvPr id="4" name="step-136"/>
+          <p:cNvPr id="4" name="step-138"/>
           <p:cNvSpPr txBox="1"/>
           <p:nvPr/>
         </p:nvSpPr>
@@ -2638,7 +2740,7 @@
       </p:sp>
       <p:sp>
         <p:nvSpPr>
-          <p:cNvPr id="5" name="next-item-137"/>
+          <p:cNvPr id="5" name="next-item-139"/>
           <p:cNvSpPr txBox="1"/>
           <p:nvPr/>
         </p:nvSpPr>
@@ -2672,7 +2774,7 @@
                 <a:ea typeface="Arial" pitchFamily="34" charset="-122"/>
                 <a:cs typeface="Arial" pitchFamily="34" charset="-120"/>
               </a:rPr>
-              <a:t>Lift the Discourse 20-page cap</a:t>
+              <a:t>Lift the Discourse 10-page cap</a:t>
             </a:r>
             <a:endParaRPr lang="en-US" sz="1900" dirty="0"/>
           </a:p>
@@ -2694,7 +2796,7 @@
       </p:sp>
       <p:sp>
         <p:nvSpPr>
-          <p:cNvPr id="6" name="step-138"/>
+          <p:cNvPr id="6" name="step-140"/>
           <p:cNvSpPr txBox="1"/>
           <p:nvPr/>
         </p:nvSpPr>
@@ -2736,7 +2838,7 @@
       </p:sp>
       <p:sp>
         <p:nvSpPr>
-          <p:cNvPr id="7" name="next-item-139"/>
+          <p:cNvPr id="7" name="next-item-141"/>
           <p:cNvSpPr txBox="1"/>
           <p:nvPr/>
         </p:nvSpPr>
@@ -2792,7 +2894,7 @@
       </p:sp>
       <p:sp>
         <p:nvSpPr>
-          <p:cNvPr id="8" name="step-140"/>
+          <p:cNvPr id="8" name="step-142"/>
           <p:cNvSpPr txBox="1"/>
           <p:nvPr/>
         </p:nvSpPr>
@@ -2834,7 +2936,7 @@
       </p:sp>
       <p:sp>
         <p:nvSpPr>
-          <p:cNvPr id="9" name="next-item-141"/>
+          <p:cNvPr id="9" name="next-item-143"/>
           <p:cNvSpPr txBox="1"/>
           <p:nvPr/>
         </p:nvSpPr>
@@ -2882,7 +2984,7 @@
                   <a:schemeClr val="accent4"/>
                 </a:solidFill>
               </a:rPr>
-              <a:t>The one security gap: a leaked token creates tenants, with no audit trail.</a:t>
+              <a:t>The main security gap: a leaked token creates tenants, with no audit trail.</a:t>
             </a:r>
             <a:endParaRPr lang="en-US" sz="1900" dirty="0"/>
           </a:p>
@@ -2890,7 +2992,7 @@
       </p:sp>
       <p:sp>
         <p:nvSpPr>
-          <p:cNvPr id="10" name="demo-card-142"/>
+          <p:cNvPr id="10" name="demo-card-144"/>
           <p:cNvSpPr/>
           <p:nvPr/>
         </p:nvSpPr>
@@ -2917,7 +3019,7 @@
       </p:sp>
       <p:sp>
         <p:nvSpPr>
-          <p:cNvPr id="11" name="demo-head-143"/>
+          <p:cNvPr id="11" name="demo-head-145"/>
           <p:cNvSpPr txBox="1"/>
           <p:nvPr/>
         </p:nvSpPr>
@@ -2970,14 +3072,14 @@
       </p:sp>
       <p:sp>
         <p:nvSpPr>
-          <p:cNvPr id="12" name="demo-steps-144"/>
+          <p:cNvPr id="12" name="demo-steps-146"/>
           <p:cNvSpPr txBox="1"/>
           <p:nvPr/>
         </p:nvSpPr>
         <p:spPr>
           <a:xfrm>
-            <a:off x="6675120" y="2103120"/>
-            <a:ext cx="4693615" cy="3383280"/>
+            <a:off x="6675120" y="2057400"/>
+            <a:ext cx="4693615" cy="3474720"/>
           </a:xfrm>
           <a:prstGeom prst="rect">
             <a:avLst/>
@@ -2991,173 +3093,192 @@
           <a:p>
             <a:pPr marL="342900" indent="-342900">
               <a:spcAft>
-                <a:spcPts val="900"/>
+                <a:spcPts val="500"/>
               </a:spcAft>
               <a:buSzPct val="100000"/>
               <a:buFont typeface="+mj-lt"/>
               <a:buAutoNum type="arabicPeriod" startAt="1"/>
             </a:pPr>
             <a:r>
-              <a:rPr lang="en-US" sz="1700" dirty="0">
+              <a:rPr lang="en-US" sz="1550" dirty="0">
                 <a:solidFill>
                   <a:schemeClr val="bg1"/>
                 </a:solidFill>
               </a:rPr>
               <a:t>Start the server, show /health</a:t>
             </a:r>
-            <a:endParaRPr lang="en-US" sz="1700" dirty="0"/>
+            <a:endParaRPr lang="en-US" sz="1550" dirty="0"/>
           </a:p>
           <a:p>
             <a:pPr marL="342900" indent="-342900">
               <a:spcAft>
-                <a:spcPts val="900"/>
+                <a:spcPts val="500"/>
               </a:spcAft>
               <a:buSzPct val="100000"/>
               <a:buFont typeface="+mj-lt"/>
               <a:buAutoNum type="arabicPeriod" startAt="1"/>
             </a:pPr>
             <a:r>
-              <a:rPr lang="en-US" sz="1700" dirty="0">
+              <a:rPr lang="en-US" sz="1550" dirty="0">
                 <a:solidFill>
                   <a:schemeClr val="bg1"/>
                 </a:solidFill>
               </a:rPr>
-              <a:t>Seed two tenants: acme and globex</a:t>
-            </a:r>
-            <a:endParaRPr lang="en-US" sz="1700" dirty="0"/>
+              <a:t>Seed two tenants: lumenote and brightwave</a:t>
+            </a:r>
+            <a:endParaRPr lang="en-US" sz="1550" dirty="0"/>
           </a:p>
           <a:p>
             <a:pPr marL="342900" indent="-342900">
               <a:spcAft>
-                <a:spcPts val="900"/>
+                <a:spcPts val="500"/>
               </a:spcAft>
               <a:buSzPct val="100000"/>
               <a:buFont typeface="+mj-lt"/>
               <a:buAutoNum type="arabicPeriod" startAt="1"/>
             </a:pPr>
             <a:r>
-              <a:rPr lang="en-US" sz="1700" dirty="0">
+              <a:rPr lang="en-US" sz="1550" dirty="0">
                 <a:solidFill>
                   <a:schemeClr val="bg1"/>
                 </a:solidFill>
               </a:rPr>
               <a:t>Same review twice: duplicate false, then true</a:t>
             </a:r>
-            <a:endParaRPr lang="en-US" sz="1700" dirty="0"/>
+            <a:endParaRPr lang="en-US" sz="1550" dirty="0"/>
           </a:p>
           <a:p>
             <a:pPr marL="342900" indent="-342900">
               <a:spcAft>
-                <a:spcPts val="900"/>
+                <a:spcPts val="500"/>
               </a:spcAft>
               <a:buSzPct val="100000"/>
               <a:buFont typeface="+mj-lt"/>
               <a:buAutoNum type="arabicPeriod" startAt="1"/>
             </a:pPr>
             <a:r>
-              <a:rPr lang="en-US" sz="1700" dirty="0">
+              <a:rPr lang="en-US" sz="1550" dirty="0">
                 <a:solidFill>
                   <a:schemeClr val="bg1"/>
                 </a:solidFill>
               </a:rPr>
               <a:t>Same review to a second Play Store source</a:t>
             </a:r>
-            <a:endParaRPr lang="en-US" sz="1700" dirty="0"/>
+            <a:endParaRPr lang="en-US" sz="1550" dirty="0"/>
           </a:p>
           <a:p>
             <a:pPr marL="342900" indent="-342900">
               <a:spcAft>
-                <a:spcPts val="900"/>
+                <a:spcPts val="500"/>
               </a:spcAft>
               <a:buSzPct val="100000"/>
               <a:buFont typeface="+mj-lt"/>
               <a:buAutoNum type="arabicPeriod" startAt="1"/>
             </a:pPr>
             <a:r>
-              <a:rPr lang="en-US" sz="1700" dirty="0">
+              <a:rPr lang="en-US" sz="1550" dirty="0">
                 <a:solidFill>
                   <a:schemeClr val="bg1"/>
                 </a:solidFill>
               </a:rPr>
-              <a:t>acme sees two records; globex sees none</a:t>
-            </a:r>
-            <a:endParaRPr lang="en-US" sz="1700" dirty="0"/>
+              <a:t>lumenote sees two records; brightwave none</a:t>
+            </a:r>
+            <a:endParaRPr lang="en-US" sz="1550" dirty="0"/>
           </a:p>
           <a:p>
             <a:pPr marL="342900" indent="-342900">
               <a:spcAft>
-                <a:spcPts val="900"/>
+                <a:spcPts val="500"/>
               </a:spcAft>
               <a:buSzPct val="100000"/>
               <a:buFont typeface="+mj-lt"/>
               <a:buAutoNum type="arabicPeriod" startAt="1"/>
             </a:pPr>
             <a:r>
-              <a:rPr lang="en-US" sz="1700" dirty="0">
+              <a:rPr lang="en-US" sz="1550" dirty="0">
                 <a:solidFill>
                   <a:schemeClr val="bg1"/>
                 </a:solidFill>
               </a:rPr>
-              <a:t>Malformed payload goes dead; replay it</a:t>
-            </a:r>
-            <a:endParaRPr lang="en-US" sz="1700" dirty="0"/>
+              <a:t>Custom webhook: one batch, three kinds</a:t>
+            </a:r>
+            <a:endParaRPr lang="en-US" sz="1550" dirty="0"/>
           </a:p>
           <a:p>
             <a:pPr marL="342900" indent="-342900">
               <a:spcAft>
-                <a:spcPts val="900"/>
+                <a:spcPts val="500"/>
               </a:spcAft>
               <a:buSzPct val="100000"/>
               <a:buFont typeface="+mj-lt"/>
               <a:buAutoNum type="arabicPeriod" startAt="1"/>
             </a:pPr>
             <a:r>
-              <a:rPr lang="en-US" sz="1700" dirty="0">
+              <a:rPr lang="en-US" sz="1550" dirty="0">
                 <a:solidFill>
                   <a:schemeClr val="bg1"/>
                 </a:solidFill>
               </a:rPr>
-              <a:t>Live Discourse sync, then the posts</a:t>
-            </a:r>
-            <a:endParaRPr lang="en-US" sz="1700" dirty="0"/>
+              <a:t>Malformed payload goes dead; replay it</a:t>
+            </a:r>
+            <a:endParaRPr lang="en-US" sz="1550" dirty="0"/>
           </a:p>
           <a:p>
             <a:pPr marL="342900" indent="-342900">
               <a:spcAft>
-                <a:spcPts val="900"/>
+                <a:spcPts val="500"/>
               </a:spcAft>
               <a:buSzPct val="100000"/>
               <a:buFont typeface="+mj-lt"/>
               <a:buAutoNum type="arabicPeriod" startAt="1"/>
             </a:pPr>
             <a:r>
-              <a:rPr lang="en-US" sz="1700" dirty="0">
+              <a:rPr lang="en-US" sz="1550" dirty="0">
                 <a:solidFill>
                   <a:schemeClr val="bg1"/>
                 </a:solidFill>
               </a:rPr>
-              <a:t>20 pushes queued, kill -9, restart: drains</a:t>
-            </a:r>
-            <a:endParaRPr lang="en-US" sz="1700" dirty="0"/>
+              <a:t>Live Discourse sync, then the posts</a:t>
+            </a:r>
+            <a:endParaRPr lang="en-US" sz="1550" dirty="0"/>
           </a:p>
           <a:p>
             <a:pPr marL="342900" indent="-342900">
               <a:spcAft>
-                <a:spcPts val="900"/>
+                <a:spcPts val="500"/>
               </a:spcAft>
               <a:buSzPct val="100000"/>
               <a:buFont typeface="+mj-lt"/>
               <a:buAutoNum type="arabicPeriod" startAt="1"/>
             </a:pPr>
             <a:r>
-              <a:rPr lang="en-US" sz="1700" dirty="0">
+              <a:rPr lang="en-US" sz="1550" dirty="0">
                 <a:solidFill>
                   <a:schemeClr val="bg1"/>
                 </a:solidFill>
               </a:rPr>
+              <a:t>20 pushes queued, kill -9, restart: drains</a:t>
+            </a:r>
+            <a:endParaRPr lang="en-US" sz="1550" dirty="0"/>
+          </a:p>
+          <a:p>
+            <a:pPr marL="342900" indent="-342900">
+              <a:spcAft>
+                <a:spcPts val="500"/>
+              </a:spcAft>
+              <a:buSzPct val="100000"/>
+              <a:buFont typeface="+mj-lt"/>
+              <a:buAutoNum type="arabicPeriod" startAt="1"/>
+            </a:pPr>
+            <a:r>
+              <a:rPr lang="en-US" sz="1550" dirty="0">
+                <a:solidFill>
+                  <a:schemeClr val="bg1"/>
+                </a:solidFill>
+              </a:rPr>
               <a:t>Stop the server: “done”</a:t>
             </a:r>
-            <a:endParaRPr lang="en-US" sz="1700" dirty="0"/>
+            <a:endParaRPr lang="en-US" sz="1550" dirty="0"/>
           </a:p>
         </p:txBody>
       </p:sp>
@@ -3201,6 +3322,1321 @@
             <a:fld id="{F7021451-1387-4CA6-816F-3879F97B5CBC}" type="slidenum">
               <a:rPr b="0" lang="en-US"/>
               <a:t>10</a:t>
+            </a:fld>
+            <a:endParaRPr lang="en-US"/>
+          </a:p>
+        </p:txBody>
+      </p:sp>
+    </p:spTree>
+  </p:cSld>
+  <p:clrMapOvr>
+    <a:masterClrMapping/>
+  </p:clrMapOvr>
+</p:sld>
+</file>
+
+<file path=ppt/slides/slide11.xml><?xml version="1.0" encoding="utf-8"?>
+<p:sld xmlns:a="http://schemas.openxmlformats.org/drawingml/2006/main" xmlns:r="http://schemas.openxmlformats.org/officeDocument/2006/relationships" xmlns:p="http://schemas.openxmlformats.org/presentationml/2006/main">
+  <p:cSld name="Slide 11">
+    <p:spTree>
+      <p:nvGrpSpPr>
+        <p:cNvPr id="1" name=""/>
+        <p:cNvGrpSpPr/>
+        <p:nvPr/>
+      </p:nvGrpSpPr>
+      <p:grpSpPr>
+        <a:xfrm>
+          <a:off x="0" y="0"/>
+          <a:ext cx="0" cy="0"/>
+          <a:chOff x="0" y="0"/>
+          <a:chExt cx="0" cy="0"/>
+        </a:xfrm>
+      </p:grpSpPr>
+      <p:sp>
+        <p:nvSpPr>
+          <p:cNvPr id="2" name="Text 0"/>
+          <p:cNvSpPr/>
+          <p:nvPr>
+            <p:ph idx="100" type="title" hasCustomPrompt="1"/>
+          </p:nvPr>
+        </p:nvSpPr>
+        <p:spPr>
+          <a:xfrm>
+            <a:off x="548640" y="320040"/>
+            <a:ext cx="11094415" cy="777240"/>
+          </a:xfrm>
+          <a:prstGeom prst="rect">
+            <a:avLst/>
+          </a:prstGeom>
+          <a:noFill/>
+          <a:ln/>
+        </p:spPr>
+        <p:txBody>
+          <a:bodyPr wrap="square" lIns="0" tIns="0" rIns="0" bIns="0" rtlCol="0" anchor="ctr"/>
+          <a:lstStyle/>
+          <a:p>
+            <a:pPr indent="0" marL="0">
+              <a:buNone/>
+            </a:pPr>
+            <a:r>
+              <a:rPr lang="en-US" sz="3400" b="1" dirty="0">
+                <a:solidFill>
+                  <a:schemeClr val="tx1"/>
+                </a:solidFill>
+              </a:rPr>
+              <a:t>Where this sits in Enterpret's pipeline</a:t>
+            </a:r>
+            <a:endParaRPr lang="en-US" sz="3400" dirty="0"/>
+          </a:p>
+        </p:txBody>
+      </p:sp>
+      <p:sp>
+        <p:nvSpPr>
+          <p:cNvPr id="3" name="stage-147"/>
+          <p:cNvSpPr txBox="1"/>
+          <p:nvPr/>
+        </p:nvSpPr>
+        <p:spPr>
+          <a:xfrm>
+            <a:off x="548640" y="1280160"/>
+            <a:ext cx="3429000" cy="1325880"/>
+          </a:xfrm>
+          <a:prstGeom prst="roundRect">
+            <a:avLst>
+              <a:gd name="adj" fmla="val 5517"/>
+            </a:avLst>
+          </a:prstGeom>
+          <a:solidFill>
+            <a:schemeClr val="accent5"/>
+          </a:solidFill>
+          <a:ln w="31750">
+            <a:solidFill>
+              <a:schemeClr val="accent1"/>
+            </a:solidFill>
+          </a:ln>
+        </p:spPr>
+        <p:txBody>
+          <a:bodyPr wrap="square" lIns="127000" tIns="127000" rIns="127000" bIns="127000" rtlCol="0" anchor="t"/>
+          <a:lstStyle/>
+          <a:p>
+            <a:pPr algn="l" indent="0" marL="0">
+              <a:spcAft>
+                <a:spcPts val="300"/>
+              </a:spcAft>
+              <a:buNone/>
+            </a:pPr>
+            <a:r>
+              <a:rPr lang="en-US" sz="1800" b="1" dirty="0">
+                <a:solidFill>
+                  <a:schemeClr val="tx1"/>
+                </a:solidFill>
+              </a:rPr>
+              <a:t>Unify</a:t>
+            </a:r>
+            <a:endParaRPr lang="en-US" sz="1800" dirty="0"/>
+          </a:p>
+          <a:p>
+            <a:pPr algn="l" indent="0" marL="0">
+              <a:buNone/>
+            </a:pPr>
+            <a:r>
+              <a:rPr lang="en-US" sz="1250" dirty="0">
+                <a:solidFill>
+                  <a:schemeClr val="tx1"/>
+                </a:solidFill>
+              </a:rPr>
+              <a:t>connectors, webhook, normalised Feedback Records</a:t>
+            </a:r>
+            <a:endParaRPr lang="en-US" sz="1800" dirty="0"/>
+          </a:p>
+          <a:p>
+            <a:pPr algn="l" indent="0" marL="0">
+              <a:buNone/>
+            </a:pPr>
+            <a:r>
+              <a:rPr lang="en-US" sz="1250" b="1" dirty="0">
+                <a:solidFill>
+                  <a:schemeClr val="accent1"/>
+                </a:solidFill>
+              </a:rPr>
+              <a:t>this service</a:t>
+            </a:r>
+            <a:endParaRPr lang="en-US" sz="1800" dirty="0"/>
+          </a:p>
+        </p:txBody>
+      </p:sp>
+      <p:sp>
+        <p:nvSpPr>
+          <p:cNvPr id="4" name="arrow-148"/>
+          <p:cNvSpPr/>
+          <p:nvPr/>
+        </p:nvSpPr>
+        <p:spPr>
+          <a:xfrm>
+            <a:off x="4032504" y="1943100"/>
+            <a:ext cx="292608" cy="0"/>
+          </a:xfrm>
+          <a:prstGeom prst="line">
+            <a:avLst/>
+          </a:prstGeom>
+          <a:noFill/>
+          <a:ln w="25400">
+            <a:solidFill>
+              <a:schemeClr val="tx1"/>
+            </a:solidFill>
+            <a:prstDash val="solid"/>
+            <a:tailEnd type="triangle"/>
+          </a:ln>
+        </p:spPr>
+      </p:sp>
+      <p:sp>
+        <p:nvSpPr>
+          <p:cNvPr id="5" name="stage-149"/>
+          <p:cNvSpPr txBox="1"/>
+          <p:nvPr/>
+        </p:nvSpPr>
+        <p:spPr>
+          <a:xfrm>
+            <a:off x="4379976" y="1280160"/>
+            <a:ext cx="3429000" cy="1325880"/>
+          </a:xfrm>
+          <a:prstGeom prst="roundRect">
+            <a:avLst>
+              <a:gd name="adj" fmla="val 5517"/>
+            </a:avLst>
+          </a:prstGeom>
+          <a:solidFill>
+            <a:schemeClr val="bg2"/>
+          </a:solidFill>
+          <a:ln w="12700">
+            <a:solidFill>
+              <a:schemeClr val="accent4"/>
+            </a:solidFill>
+          </a:ln>
+        </p:spPr>
+        <p:txBody>
+          <a:bodyPr wrap="square" lIns="127000" tIns="127000" rIns="127000" bIns="127000" rtlCol="0" anchor="t"/>
+          <a:lstStyle/>
+          <a:p>
+            <a:pPr algn="l" indent="0" marL="0">
+              <a:spcAft>
+                <a:spcPts val="300"/>
+              </a:spcAft>
+              <a:buNone/>
+            </a:pPr>
+            <a:r>
+              <a:rPr lang="en-US" sz="1800" b="1" dirty="0">
+                <a:solidFill>
+                  <a:schemeClr val="tx1"/>
+                </a:solidFill>
+              </a:rPr>
+              <a:t>Understand</a:t>
+            </a:r>
+            <a:endParaRPr lang="en-US" sz="1800" dirty="0"/>
+          </a:p>
+          <a:p>
+            <a:pPr algn="l" indent="0" marL="0">
+              <a:buNone/>
+            </a:pPr>
+            <a:r>
+              <a:rPr lang="en-US" sz="1250" dirty="0">
+                <a:solidFill>
+                  <a:schemeClr val="tx1"/>
+                </a:solidFill>
+              </a:rPr>
+              <a:t>taxonomy: Keywords, Themes, Categories (Reasons); Wisdom Q&amp;A</a:t>
+            </a:r>
+            <a:endParaRPr lang="en-US" sz="1800" dirty="0"/>
+          </a:p>
+          <a:p>
+            <a:pPr algn="l" indent="0" marL="0">
+              <a:buNone/>
+            </a:pPr>
+            <a:r>
+              <a:rPr lang="en-US" sz="1250" b="1" dirty="0">
+                <a:solidFill>
+                  <a:schemeClr val="tx2"/>
+                </a:solidFill>
+              </a:rPr>
+              <a:t>downstream, not built</a:t>
+            </a:r>
+            <a:endParaRPr lang="en-US" sz="1800" dirty="0"/>
+          </a:p>
+        </p:txBody>
+      </p:sp>
+      <p:sp>
+        <p:nvSpPr>
+          <p:cNvPr id="6" name="arrow-150"/>
+          <p:cNvSpPr/>
+          <p:nvPr/>
+        </p:nvSpPr>
+        <p:spPr>
+          <a:xfrm>
+            <a:off x="7863840" y="1943100"/>
+            <a:ext cx="292608" cy="0"/>
+          </a:xfrm>
+          <a:prstGeom prst="line">
+            <a:avLst/>
+          </a:prstGeom>
+          <a:noFill/>
+          <a:ln w="25400">
+            <a:solidFill>
+              <a:schemeClr val="tx1"/>
+            </a:solidFill>
+            <a:prstDash val="solid"/>
+            <a:tailEnd type="triangle"/>
+          </a:ln>
+        </p:spPr>
+      </p:sp>
+      <p:sp>
+        <p:nvSpPr>
+          <p:cNvPr id="7" name="stage-151"/>
+          <p:cNvSpPr txBox="1"/>
+          <p:nvPr/>
+        </p:nvSpPr>
+        <p:spPr>
+          <a:xfrm>
+            <a:off x="8211312" y="1280160"/>
+            <a:ext cx="3429000" cy="1325880"/>
+          </a:xfrm>
+          <a:prstGeom prst="roundRect">
+            <a:avLst>
+              <a:gd name="adj" fmla="val 5517"/>
+            </a:avLst>
+          </a:prstGeom>
+          <a:solidFill>
+            <a:schemeClr val="bg2"/>
+          </a:solidFill>
+          <a:ln w="12700">
+            <a:solidFill>
+              <a:schemeClr val="accent4"/>
+            </a:solidFill>
+          </a:ln>
+        </p:spPr>
+        <p:txBody>
+          <a:bodyPr wrap="square" lIns="127000" tIns="127000" rIns="127000" bIns="127000" rtlCol="0" anchor="t"/>
+          <a:lstStyle/>
+          <a:p>
+            <a:pPr algn="l" indent="0" marL="0">
+              <a:spcAft>
+                <a:spcPts val="300"/>
+              </a:spcAft>
+              <a:buNone/>
+            </a:pPr>
+            <a:r>
+              <a:rPr lang="en-US" sz="1800" b="1" dirty="0">
+                <a:solidFill>
+                  <a:schemeClr val="tx1"/>
+                </a:solidFill>
+              </a:rPr>
+              <a:t>Act</a:t>
+            </a:r>
+            <a:endParaRPr lang="en-US" sz="1800" dirty="0"/>
+          </a:p>
+          <a:p>
+            <a:pPr algn="l" indent="0" marL="0">
+              <a:buNone/>
+            </a:pPr>
+            <a:r>
+              <a:rPr lang="en-US" sz="1250" dirty="0">
+                <a:solidFill>
+                  <a:schemeClr val="tx1"/>
+                </a:solidFill>
+              </a:rPr>
+              <a:t>Slack, Jira, Linear, reports</a:t>
+            </a:r>
+            <a:endParaRPr lang="en-US" sz="1800" dirty="0"/>
+          </a:p>
+          <a:p>
+            <a:pPr algn="l" indent="0" marL="0">
+              <a:buNone/>
+            </a:pPr>
+            <a:r>
+              <a:rPr lang="en-US" sz="1250" b="1" dirty="0">
+                <a:solidFill>
+                  <a:schemeClr val="tx2"/>
+                </a:solidFill>
+              </a:rPr>
+              <a:t>downstream, not built</a:t>
+            </a:r>
+            <a:endParaRPr lang="en-US" sz="1800" dirty="0"/>
+          </a:p>
+        </p:txBody>
+      </p:sp>
+      <p:graphicFrame>
+        <p:nvGraphicFramePr>
+          <p:cNvPr id="12" name="mapping-152"/>
+          <p:cNvGraphicFramePr>
+            <a:graphicFrameLocks noGrp="1"/>
+          </p:cNvGraphicFramePr>
+          <p:nvPr>
+            <p:extLst>
+              <p:ext uri="{D42A27DB-BD31-4B8C-83A1-F6EECF244321}">
+                <p14:modId xmlns:p14="http://schemas.microsoft.com/office/powerpoint/2010/main" val="1579011935"/>
+              </p:ext>
+            </p:extLst>
+          </p:nvPr>
+        </p:nvGraphicFramePr>
+        <p:xfrm>
+          <a:off x="548640" y="2834640"/>
+          <a:ext cx="11094415" cy="914400"/>
+        </p:xfrm>
+        <a:graphic>
+          <a:graphicData uri="http://schemas.openxmlformats.org/drawingml/2006/table">
+            <a:tbl>
+              <a:tblPr/>
+              <a:tblGrid>
+                <a:gridCol w="5120640"/>
+                <a:gridCol w="5973775"/>
+              </a:tblGrid>
+              <a:tr h="347472">
+                <a:tc>
+                  <a:txBody>
+                    <a:bodyPr/>
+                    <a:lstStyle/>
+                    <a:p>
+                      <a:pPr indent="0" marL="0">
+                        <a:buNone/>
+                      </a:pPr>
+                      <a:r>
+                        <a:rPr lang="en-US" sz="1300" b="1" dirty="0">
+                          <a:solidFill>
+                            <a:schemeClr val="bg1"/>
+                          </a:solidFill>
+                        </a:rPr>
+                        <a:t>Their public docs and engineering blog describe</a:t>
+                      </a:r>
+                      <a:endParaRPr lang="en-US" sz="1300" dirty="0"/>
+                    </a:p>
+                  </a:txBody>
+                  <a:tcPr marL="91440" marR="91440" marT="0" marB="0" anchor="ctr">
+                    <a:lnL w="6350" cap="flat" cmpd="sng" algn="ctr">
+                      <a:solidFill>
+                        <a:srgbClr val="DEE2E6"/>
+                      </a:solidFill>
+                      <a:prstDash val="solid"/>
+                      <a:round/>
+                      <a:headEnd type="none" w="med" len="med"/>
+                      <a:tailEnd type="none" w="med" len="med"/>
+                    </a:lnL>
+                    <a:lnR w="6350" cap="flat" cmpd="sng" algn="ctr">
+                      <a:solidFill>
+                        <a:srgbClr val="DEE2E6"/>
+                      </a:solidFill>
+                      <a:prstDash val="solid"/>
+                      <a:round/>
+                      <a:headEnd type="none" w="med" len="med"/>
+                      <a:tailEnd type="none" w="med" len="med"/>
+                    </a:lnR>
+                    <a:lnT w="6350" cap="flat" cmpd="sng" algn="ctr">
+                      <a:solidFill>
+                        <a:srgbClr val="DEE2E6"/>
+                      </a:solidFill>
+                      <a:prstDash val="solid"/>
+                      <a:round/>
+                      <a:headEnd type="none" w="med" len="med"/>
+                      <a:tailEnd type="none" w="med" len="med"/>
+                    </a:lnT>
+                    <a:lnB w="6350" cap="flat" cmpd="sng" algn="ctr">
+                      <a:solidFill>
+                        <a:srgbClr val="DEE2E6"/>
+                      </a:solidFill>
+                      <a:prstDash val="solid"/>
+                      <a:round/>
+                      <a:headEnd type="none" w="med" len="med"/>
+                      <a:tailEnd type="none" w="med" len="med"/>
+                    </a:lnB>
+                    <a:solidFill>
+                      <a:schemeClr val="tx1"/>
+                    </a:solidFill>
+                  </a:tcPr>
+                </a:tc>
+                <a:tc>
+                  <a:txBody>
+                    <a:bodyPr/>
+                    <a:lstStyle/>
+                    <a:p>
+                      <a:pPr indent="0" marL="0">
+                        <a:buNone/>
+                      </a:pPr>
+                      <a:r>
+                        <a:rPr lang="en-US" sz="1300" b="1" dirty="0">
+                          <a:solidFill>
+                            <a:schemeClr val="bg1"/>
+                          </a:solidFill>
+                        </a:rPr>
+                        <a:t>This service</a:t>
+                      </a:r>
+                      <a:endParaRPr lang="en-US" sz="1300" dirty="0"/>
+                    </a:p>
+                  </a:txBody>
+                  <a:tcPr marL="91440" marR="91440" marT="0" marB="0" anchor="ctr">
+                    <a:lnL w="6350" cap="flat" cmpd="sng" algn="ctr">
+                      <a:solidFill>
+                        <a:srgbClr val="DEE2E6"/>
+                      </a:solidFill>
+                      <a:prstDash val="solid"/>
+                      <a:round/>
+                      <a:headEnd type="none" w="med" len="med"/>
+                      <a:tailEnd type="none" w="med" len="med"/>
+                    </a:lnL>
+                    <a:lnR w="6350" cap="flat" cmpd="sng" algn="ctr">
+                      <a:solidFill>
+                        <a:srgbClr val="DEE2E6"/>
+                      </a:solidFill>
+                      <a:prstDash val="solid"/>
+                      <a:round/>
+                      <a:headEnd type="none" w="med" len="med"/>
+                      <a:tailEnd type="none" w="med" len="med"/>
+                    </a:lnR>
+                    <a:lnT w="6350" cap="flat" cmpd="sng" algn="ctr">
+                      <a:solidFill>
+                        <a:srgbClr val="DEE2E6"/>
+                      </a:solidFill>
+                      <a:prstDash val="solid"/>
+                      <a:round/>
+                      <a:headEnd type="none" w="med" len="med"/>
+                      <a:tailEnd type="none" w="med" len="med"/>
+                    </a:lnT>
+                    <a:lnB w="6350" cap="flat" cmpd="sng" algn="ctr">
+                      <a:solidFill>
+                        <a:srgbClr val="DEE2E6"/>
+                      </a:solidFill>
+                      <a:prstDash val="solid"/>
+                      <a:round/>
+                      <a:headEnd type="none" w="med" len="med"/>
+                      <a:tailEnd type="none" w="med" len="med"/>
+                    </a:lnB>
+                    <a:solidFill>
+                      <a:schemeClr val="tx1"/>
+                    </a:solidFill>
+                  </a:tcPr>
+                </a:tc>
+              </a:tr>
+              <a:tr h="457200">
+                <a:tc>
+                  <a:txBody>
+                    <a:bodyPr/>
+                    <a:lstStyle/>
+                    <a:p>
+                      <a:pPr indent="0" marL="0">
+                        <a:buNone/>
+                      </a:pPr>
+                      <a:r>
+                        <a:rPr lang="en-US" sz="1250" dirty="0">
+                          <a:solidFill>
+                            <a:schemeClr val="tx1"/>
+                          </a:solidFill>
+                        </a:rPr>
+                        <a:t>Public webhook: a batch of records with id, type, createdAt (epoch s), typed metadata</a:t>
+                      </a:r>
+                      <a:endParaRPr lang="en-US" sz="1250" dirty="0"/>
+                    </a:p>
+                  </a:txBody>
+                  <a:tcPr marL="91440" marR="91440" marT="0" marB="0" anchor="ctr">
+                    <a:lnL w="6350" cap="flat" cmpd="sng" algn="ctr">
+                      <a:solidFill>
+                        <a:srgbClr val="DEE2E6"/>
+                      </a:solidFill>
+                      <a:prstDash val="solid"/>
+                      <a:round/>
+                      <a:headEnd type="none" w="med" len="med"/>
+                      <a:tailEnd type="none" w="med" len="med"/>
+                    </a:lnL>
+                    <a:lnR w="6350" cap="flat" cmpd="sng" algn="ctr">
+                      <a:solidFill>
+                        <a:srgbClr val="DEE2E6"/>
+                      </a:solidFill>
+                      <a:prstDash val="solid"/>
+                      <a:round/>
+                      <a:headEnd type="none" w="med" len="med"/>
+                      <a:tailEnd type="none" w="med" len="med"/>
+                    </a:lnR>
+                    <a:lnT w="6350" cap="flat" cmpd="sng" algn="ctr">
+                      <a:solidFill>
+                        <a:srgbClr val="DEE2E6"/>
+                      </a:solidFill>
+                      <a:prstDash val="solid"/>
+                      <a:round/>
+                      <a:headEnd type="none" w="med" len="med"/>
+                      <a:tailEnd type="none" w="med" len="med"/>
+                    </a:lnT>
+                    <a:lnB w="6350" cap="flat" cmpd="sng" algn="ctr">
+                      <a:solidFill>
+                        <a:srgbClr val="DEE2E6"/>
+                      </a:solidFill>
+                      <a:prstDash val="solid"/>
+                      <a:round/>
+                      <a:headEnd type="none" w="med" len="med"/>
+                      <a:tailEnd type="none" w="med" len="med"/>
+                    </a:lnB>
+                    <a:solidFill>
+                      <a:schemeClr val="bg1"/>
+                    </a:solidFill>
+                  </a:tcPr>
+                </a:tc>
+                <a:tc>
+                  <a:txBody>
+                    <a:bodyPr/>
+                    <a:lstStyle/>
+                    <a:p>
+                      <a:pPr indent="0" marL="0">
+                        <a:buNone/>
+                      </a:pPr>
+                      <a:r>
+                        <a:rPr lang="en-US" sz="1250" dirty="0">
+                          <a:solidFill>
+                            <a:schemeClr val="tx1"/>
+                          </a:solidFill>
+                        </a:rPr>
+                        <a:t>custom connector takes that shape; one push = one raw event; kind from type; AUDIO_RECORDING refused</a:t>
+                      </a:r>
+                      <a:endParaRPr lang="en-US" sz="1250" dirty="0"/>
+                    </a:p>
+                  </a:txBody>
+                  <a:tcPr marL="91440" marR="91440" marT="0" marB="0" anchor="ctr">
+                    <a:lnL w="6350" cap="flat" cmpd="sng" algn="ctr">
+                      <a:solidFill>
+                        <a:srgbClr val="DEE2E6"/>
+                      </a:solidFill>
+                      <a:prstDash val="solid"/>
+                      <a:round/>
+                      <a:headEnd type="none" w="med" len="med"/>
+                      <a:tailEnd type="none" w="med" len="med"/>
+                    </a:lnL>
+                    <a:lnR w="6350" cap="flat" cmpd="sng" algn="ctr">
+                      <a:solidFill>
+                        <a:srgbClr val="DEE2E6"/>
+                      </a:solidFill>
+                      <a:prstDash val="solid"/>
+                      <a:round/>
+                      <a:headEnd type="none" w="med" len="med"/>
+                      <a:tailEnd type="none" w="med" len="med"/>
+                    </a:lnR>
+                    <a:lnT w="6350" cap="flat" cmpd="sng" algn="ctr">
+                      <a:solidFill>
+                        <a:srgbClr val="DEE2E6"/>
+                      </a:solidFill>
+                      <a:prstDash val="solid"/>
+                      <a:round/>
+                      <a:headEnd type="none" w="med" len="med"/>
+                      <a:tailEnd type="none" w="med" len="med"/>
+                    </a:lnT>
+                    <a:lnB w="6350" cap="flat" cmpd="sng" algn="ctr">
+                      <a:solidFill>
+                        <a:srgbClr val="DEE2E6"/>
+                      </a:solidFill>
+                      <a:prstDash val="solid"/>
+                      <a:round/>
+                      <a:headEnd type="none" w="med" len="med"/>
+                      <a:tailEnd type="none" w="med" len="med"/>
+                    </a:lnB>
+                    <a:solidFill>
+                      <a:schemeClr val="bg1"/>
+                    </a:solidFill>
+                  </a:tcPr>
+                </a:tc>
+              </a:tr>
+              <a:tr h="402336">
+                <a:tc>
+                  <a:txBody>
+                    <a:bodyPr/>
+                    <a:lstStyle/>
+                    <a:p>
+                      <a:pPr indent="0" marL="0">
+                        <a:buNone/>
+                      </a:pPr>
+                      <a:r>
+                        <a:rPr lang="en-US" sz="1250" dirty="0">
+                          <a:solidFill>
+                            <a:schemeClr val="tx1"/>
+                          </a:solidFill>
+                        </a:rPr>
+                        <a:t>“Accepted does not mean processed”</a:t>
+                      </a:r>
+                      <a:endParaRPr lang="en-US" sz="1250" dirty="0"/>
+                    </a:p>
+                  </a:txBody>
+                  <a:tcPr marL="91440" marR="91440" marT="0" marB="0" anchor="ctr">
+                    <a:lnL w="6350" cap="flat" cmpd="sng" algn="ctr">
+                      <a:solidFill>
+                        <a:srgbClr val="DEE2E6"/>
+                      </a:solidFill>
+                      <a:prstDash val="solid"/>
+                      <a:round/>
+                      <a:headEnd type="none" w="med" len="med"/>
+                      <a:tailEnd type="none" w="med" len="med"/>
+                    </a:lnL>
+                    <a:lnR w="6350" cap="flat" cmpd="sng" algn="ctr">
+                      <a:solidFill>
+                        <a:srgbClr val="DEE2E6"/>
+                      </a:solidFill>
+                      <a:prstDash val="solid"/>
+                      <a:round/>
+                      <a:headEnd type="none" w="med" len="med"/>
+                      <a:tailEnd type="none" w="med" len="med"/>
+                    </a:lnR>
+                    <a:lnT w="6350" cap="flat" cmpd="sng" algn="ctr">
+                      <a:solidFill>
+                        <a:srgbClr val="DEE2E6"/>
+                      </a:solidFill>
+                      <a:prstDash val="solid"/>
+                      <a:round/>
+                      <a:headEnd type="none" w="med" len="med"/>
+                      <a:tailEnd type="none" w="med" len="med"/>
+                    </a:lnT>
+                    <a:lnB w="6350" cap="flat" cmpd="sng" algn="ctr">
+                      <a:solidFill>
+                        <a:srgbClr val="DEE2E6"/>
+                      </a:solidFill>
+                      <a:prstDash val="solid"/>
+                      <a:round/>
+                      <a:headEnd type="none" w="med" len="med"/>
+                      <a:tailEnd type="none" w="med" len="med"/>
+                    </a:lnB>
+                    <a:solidFill>
+                      <a:schemeClr val="bg2"/>
+                    </a:solidFill>
+                  </a:tcPr>
+                </a:tc>
+                <a:tc>
+                  <a:txBody>
+                    <a:bodyPr/>
+                    <a:lstStyle/>
+                    <a:p>
+                      <a:pPr indent="0" marL="0">
+                        <a:buNone/>
+                      </a:pPr>
+                      <a:r>
+                        <a:rPr lang="en-US" sz="1250" dirty="0">
+                          <a:solidFill>
+                            <a:schemeClr val="tx1"/>
+                          </a:solidFill>
+                        </a:rPr>
+                        <a:t>202 only after the raw row commits; the worker processes later</a:t>
+                      </a:r>
+                      <a:endParaRPr lang="en-US" sz="1250" dirty="0"/>
+                    </a:p>
+                  </a:txBody>
+                  <a:tcPr marL="91440" marR="91440" marT="0" marB="0" anchor="ctr">
+                    <a:lnL w="6350" cap="flat" cmpd="sng" algn="ctr">
+                      <a:solidFill>
+                        <a:srgbClr val="DEE2E6"/>
+                      </a:solidFill>
+                      <a:prstDash val="solid"/>
+                      <a:round/>
+                      <a:headEnd type="none" w="med" len="med"/>
+                      <a:tailEnd type="none" w="med" len="med"/>
+                    </a:lnL>
+                    <a:lnR w="6350" cap="flat" cmpd="sng" algn="ctr">
+                      <a:solidFill>
+                        <a:srgbClr val="DEE2E6"/>
+                      </a:solidFill>
+                      <a:prstDash val="solid"/>
+                      <a:round/>
+                      <a:headEnd type="none" w="med" len="med"/>
+                      <a:tailEnd type="none" w="med" len="med"/>
+                    </a:lnR>
+                    <a:lnT w="6350" cap="flat" cmpd="sng" algn="ctr">
+                      <a:solidFill>
+                        <a:srgbClr val="DEE2E6"/>
+                      </a:solidFill>
+                      <a:prstDash val="solid"/>
+                      <a:round/>
+                      <a:headEnd type="none" w="med" len="med"/>
+                      <a:tailEnd type="none" w="med" len="med"/>
+                    </a:lnT>
+                    <a:lnB w="6350" cap="flat" cmpd="sng" algn="ctr">
+                      <a:solidFill>
+                        <a:srgbClr val="DEE2E6"/>
+                      </a:solidFill>
+                      <a:prstDash val="solid"/>
+                      <a:round/>
+                      <a:headEnd type="none" w="med" len="med"/>
+                      <a:tailEnd type="none" w="med" len="med"/>
+                    </a:lnB>
+                    <a:solidFill>
+                      <a:schemeClr val="bg2"/>
+                    </a:solidFill>
+                  </a:tcPr>
+                </a:tc>
+              </a:tr>
+              <a:tr h="457200">
+                <a:tc>
+                  <a:txBody>
+                    <a:bodyPr/>
+                    <a:lstStyle/>
+                    <a:p>
+                      <a:pPr indent="0" marL="0">
+                        <a:buNone/>
+                      </a:pPr>
+                      <a:r>
+                        <a:rPr lang="en-US" sz="1250" dirty="0">
+                          <a:solidFill>
+                            <a:schemeClr val="tx1"/>
+                          </a:solidFill>
+                        </a:rPr>
+                        <a:t>A repeated id is skipped by default; replace is opt-in</a:t>
+                      </a:r>
+                      <a:endParaRPr lang="en-US" sz="1250" dirty="0"/>
+                    </a:p>
+                  </a:txBody>
+                  <a:tcPr marL="91440" marR="91440" marT="0" marB="0" anchor="ctr">
+                    <a:lnL w="6350" cap="flat" cmpd="sng" algn="ctr">
+                      <a:solidFill>
+                        <a:srgbClr val="DEE2E6"/>
+                      </a:solidFill>
+                      <a:prstDash val="solid"/>
+                      <a:round/>
+                      <a:headEnd type="none" w="med" len="med"/>
+                      <a:tailEnd type="none" w="med" len="med"/>
+                    </a:lnL>
+                    <a:lnR w="6350" cap="flat" cmpd="sng" algn="ctr">
+                      <a:solidFill>
+                        <a:srgbClr val="DEE2E6"/>
+                      </a:solidFill>
+                      <a:prstDash val="solid"/>
+                      <a:round/>
+                      <a:headEnd type="none" w="med" len="med"/>
+                      <a:tailEnd type="none" w="med" len="med"/>
+                    </a:lnR>
+                    <a:lnT w="6350" cap="flat" cmpd="sng" algn="ctr">
+                      <a:solidFill>
+                        <a:srgbClr val="DEE2E6"/>
+                      </a:solidFill>
+                      <a:prstDash val="solid"/>
+                      <a:round/>
+                      <a:headEnd type="none" w="med" len="med"/>
+                      <a:tailEnd type="none" w="med" len="med"/>
+                    </a:lnT>
+                    <a:lnB w="6350" cap="flat" cmpd="sng" algn="ctr">
+                      <a:solidFill>
+                        <a:srgbClr val="DEE2E6"/>
+                      </a:solidFill>
+                      <a:prstDash val="solid"/>
+                      <a:round/>
+                      <a:headEnd type="none" w="med" len="med"/>
+                      <a:tailEnd type="none" w="med" len="med"/>
+                    </a:lnB>
+                    <a:solidFill>
+                      <a:schemeClr val="bg1"/>
+                    </a:solidFill>
+                  </a:tcPr>
+                </a:tc>
+                <a:tc>
+                  <a:txBody>
+                    <a:bodyPr/>
+                    <a:lstStyle/>
+                    <a:p>
+                      <a:pPr indent="0" marL="0">
+                        <a:buNone/>
+                      </a:pPr>
+                      <a:r>
+                        <a:rPr lang="en-US" sz="1250" dirty="0">
+                          <a:solidFill>
+                            <a:schemeClr val="tx1"/>
+                          </a:solidFill>
+                        </a:rPr>
+                        <a:t>a repeated delivery is skipped in raw_events; a newer or equal version of a record replaces it, an older one never</a:t>
+                      </a:r>
+                      <a:endParaRPr lang="en-US" sz="1250" dirty="0"/>
+                    </a:p>
+                  </a:txBody>
+                  <a:tcPr marL="91440" marR="91440" marT="0" marB="0" anchor="ctr">
+                    <a:lnL w="6350" cap="flat" cmpd="sng" algn="ctr">
+                      <a:solidFill>
+                        <a:srgbClr val="DEE2E6"/>
+                      </a:solidFill>
+                      <a:prstDash val="solid"/>
+                      <a:round/>
+                      <a:headEnd type="none" w="med" len="med"/>
+                      <a:tailEnd type="none" w="med" len="med"/>
+                    </a:lnL>
+                    <a:lnR w="6350" cap="flat" cmpd="sng" algn="ctr">
+                      <a:solidFill>
+                        <a:srgbClr val="DEE2E6"/>
+                      </a:solidFill>
+                      <a:prstDash val="solid"/>
+                      <a:round/>
+                      <a:headEnd type="none" w="med" len="med"/>
+                      <a:tailEnd type="none" w="med" len="med"/>
+                    </a:lnR>
+                    <a:lnT w="6350" cap="flat" cmpd="sng" algn="ctr">
+                      <a:solidFill>
+                        <a:srgbClr val="DEE2E6"/>
+                      </a:solidFill>
+                      <a:prstDash val="solid"/>
+                      <a:round/>
+                      <a:headEnd type="none" w="med" len="med"/>
+                      <a:tailEnd type="none" w="med" len="med"/>
+                    </a:lnT>
+                    <a:lnB w="6350" cap="flat" cmpd="sng" algn="ctr">
+                      <a:solidFill>
+                        <a:srgbClr val="DEE2E6"/>
+                      </a:solidFill>
+                      <a:prstDash val="solid"/>
+                      <a:round/>
+                      <a:headEnd type="none" w="med" len="med"/>
+                      <a:tailEnd type="none" w="med" len="med"/>
+                    </a:lnB>
+                    <a:solidFill>
+                      <a:schemeClr val="bg1"/>
+                    </a:solidFill>
+                  </a:tcPr>
+                </a:tc>
+              </a:tr>
+              <a:tr h="402336">
+                <a:tc>
+                  <a:txBody>
+                    <a:bodyPr/>
+                    <a:lstStyle/>
+                    <a:p>
+                      <a:pPr indent="0" marL="0">
+                        <a:buNone/>
+                      </a:pPr>
+                      <a:r>
+                        <a:rPr lang="en-US" sz="1250" dirty="0">
+                          <a:solidFill>
+                            <a:schemeClr val="tx1"/>
+                          </a:solidFill>
+                        </a:rPr>
+                        <a:t>Engineering blog: stale, out-of-order updates are rejected by version</a:t>
+                      </a:r>
+                      <a:endParaRPr lang="en-US" sz="1250" dirty="0"/>
+                    </a:p>
+                  </a:txBody>
+                  <a:tcPr marL="91440" marR="91440" marT="0" marB="0" anchor="ctr">
+                    <a:lnL w="6350" cap="flat" cmpd="sng" algn="ctr">
+                      <a:solidFill>
+                        <a:srgbClr val="DEE2E6"/>
+                      </a:solidFill>
+                      <a:prstDash val="solid"/>
+                      <a:round/>
+                      <a:headEnd type="none" w="med" len="med"/>
+                      <a:tailEnd type="none" w="med" len="med"/>
+                    </a:lnL>
+                    <a:lnR w="6350" cap="flat" cmpd="sng" algn="ctr">
+                      <a:solidFill>
+                        <a:srgbClr val="DEE2E6"/>
+                      </a:solidFill>
+                      <a:prstDash val="solid"/>
+                      <a:round/>
+                      <a:headEnd type="none" w="med" len="med"/>
+                      <a:tailEnd type="none" w="med" len="med"/>
+                    </a:lnR>
+                    <a:lnT w="6350" cap="flat" cmpd="sng" algn="ctr">
+                      <a:solidFill>
+                        <a:srgbClr val="DEE2E6"/>
+                      </a:solidFill>
+                      <a:prstDash val="solid"/>
+                      <a:round/>
+                      <a:headEnd type="none" w="med" len="med"/>
+                      <a:tailEnd type="none" w="med" len="med"/>
+                    </a:lnT>
+                    <a:lnB w="6350" cap="flat" cmpd="sng" algn="ctr">
+                      <a:solidFill>
+                        <a:srgbClr val="DEE2E6"/>
+                      </a:solidFill>
+                      <a:prstDash val="solid"/>
+                      <a:round/>
+                      <a:headEnd type="none" w="med" len="med"/>
+                      <a:tailEnd type="none" w="med" len="med"/>
+                    </a:lnB>
+                    <a:solidFill>
+                      <a:schemeClr val="bg2"/>
+                    </a:solidFill>
+                  </a:tcPr>
+                </a:tc>
+                <a:tc>
+                  <a:txBody>
+                    <a:bodyPr/>
+                    <a:lstStyle/>
+                    <a:p>
+                      <a:pPr indent="0" marL="0">
+                        <a:buNone/>
+                      </a:pPr>
+                      <a:r>
+                        <a:rPr lang="en-US" sz="1250" dirty="0">
+                          <a:solidFill>
+                            <a:schemeClr val="tx1"/>
+                          </a:solidFill>
+                        </a:rPr>
+                        <a:t>the upsert's version guard: COALESCE(updated, created) must not be older</a:t>
+                      </a:r>
+                      <a:endParaRPr lang="en-US" sz="1250" dirty="0"/>
+                    </a:p>
+                  </a:txBody>
+                  <a:tcPr marL="91440" marR="91440" marT="0" marB="0" anchor="ctr">
+                    <a:lnL w="6350" cap="flat" cmpd="sng" algn="ctr">
+                      <a:solidFill>
+                        <a:srgbClr val="DEE2E6"/>
+                      </a:solidFill>
+                      <a:prstDash val="solid"/>
+                      <a:round/>
+                      <a:headEnd type="none" w="med" len="med"/>
+                      <a:tailEnd type="none" w="med" len="med"/>
+                    </a:lnL>
+                    <a:lnR w="6350" cap="flat" cmpd="sng" algn="ctr">
+                      <a:solidFill>
+                        <a:srgbClr val="DEE2E6"/>
+                      </a:solidFill>
+                      <a:prstDash val="solid"/>
+                      <a:round/>
+                      <a:headEnd type="none" w="med" len="med"/>
+                      <a:tailEnd type="none" w="med" len="med"/>
+                    </a:lnR>
+                    <a:lnT w="6350" cap="flat" cmpd="sng" algn="ctr">
+                      <a:solidFill>
+                        <a:srgbClr val="DEE2E6"/>
+                      </a:solidFill>
+                      <a:prstDash val="solid"/>
+                      <a:round/>
+                      <a:headEnd type="none" w="med" len="med"/>
+                      <a:tailEnd type="none" w="med" len="med"/>
+                    </a:lnT>
+                    <a:lnB w="6350" cap="flat" cmpd="sng" algn="ctr">
+                      <a:solidFill>
+                        <a:srgbClr val="DEE2E6"/>
+                      </a:solidFill>
+                      <a:prstDash val="solid"/>
+                      <a:round/>
+                      <a:headEnd type="none" w="med" len="med"/>
+                      <a:tailEnd type="none" w="med" len="med"/>
+                    </a:lnB>
+                    <a:solidFill>
+                      <a:schemeClr val="bg2"/>
+                    </a:solidFill>
+                  </a:tcPr>
+                </a:tc>
+              </a:tr>
+              <a:tr h="402336">
+                <a:tc>
+                  <a:txBody>
+                    <a:bodyPr/>
+                    <a:lstStyle/>
+                    <a:p>
+                      <a:pPr indent="0" marL="0">
+                        <a:buNone/>
+                      </a:pPr>
+                      <a:r>
+                        <a:rPr lang="en-US" sz="1250" dirty="0">
+                          <a:solidFill>
+                            <a:schemeClr val="tx1"/>
+                          </a:solidFill>
+                        </a:rPr>
+                        <a:t>Engineering blog: partition by tenant against queue clogging and noisy neighbours</a:t>
+                      </a:r>
+                      <a:endParaRPr lang="en-US" sz="1250" dirty="0"/>
+                    </a:p>
+                  </a:txBody>
+                  <a:tcPr marL="91440" marR="91440" marT="0" marB="0" anchor="ctr">
+                    <a:lnL w="6350" cap="flat" cmpd="sng" algn="ctr">
+                      <a:solidFill>
+                        <a:srgbClr val="DEE2E6"/>
+                      </a:solidFill>
+                      <a:prstDash val="solid"/>
+                      <a:round/>
+                      <a:headEnd type="none" w="med" len="med"/>
+                      <a:tailEnd type="none" w="med" len="med"/>
+                    </a:lnL>
+                    <a:lnR w="6350" cap="flat" cmpd="sng" algn="ctr">
+                      <a:solidFill>
+                        <a:srgbClr val="DEE2E6"/>
+                      </a:solidFill>
+                      <a:prstDash val="solid"/>
+                      <a:round/>
+                      <a:headEnd type="none" w="med" len="med"/>
+                      <a:tailEnd type="none" w="med" len="med"/>
+                    </a:lnR>
+                    <a:lnT w="6350" cap="flat" cmpd="sng" algn="ctr">
+                      <a:solidFill>
+                        <a:srgbClr val="DEE2E6"/>
+                      </a:solidFill>
+                      <a:prstDash val="solid"/>
+                      <a:round/>
+                      <a:headEnd type="none" w="med" len="med"/>
+                      <a:tailEnd type="none" w="med" len="med"/>
+                    </a:lnT>
+                    <a:lnB w="6350" cap="flat" cmpd="sng" algn="ctr">
+                      <a:solidFill>
+                        <a:srgbClr val="DEE2E6"/>
+                      </a:solidFill>
+                      <a:prstDash val="solid"/>
+                      <a:round/>
+                      <a:headEnd type="none" w="med" len="med"/>
+                      <a:tailEnd type="none" w="med" len="med"/>
+                    </a:lnB>
+                    <a:solidFill>
+                      <a:schemeClr val="bg1"/>
+                    </a:solidFill>
+                  </a:tcPr>
+                </a:tc>
+                <a:tc>
+                  <a:txBody>
+                    <a:bodyPr/>
+                    <a:lstStyle/>
+                    <a:p>
+                      <a:pPr indent="0" marL="0">
+                        <a:buNone/>
+                      </a:pPr>
+                      <a:r>
+                        <a:rPr lang="en-US" sz="1250" dirty="0">
+                          <a:solidFill>
+                            <a:schemeClr val="tx1"/>
+                          </a:solidFill>
+                        </a:rPr>
+                        <a:t>gap: one shared queue today; per-tenant claiming is the upgrade</a:t>
+                      </a:r>
+                      <a:endParaRPr lang="en-US" sz="1250" dirty="0"/>
+                    </a:p>
+                  </a:txBody>
+                  <a:tcPr marL="91440" marR="91440" marT="0" marB="0" anchor="ctr">
+                    <a:lnL w="6350" cap="flat" cmpd="sng" algn="ctr">
+                      <a:solidFill>
+                        <a:srgbClr val="DEE2E6"/>
+                      </a:solidFill>
+                      <a:prstDash val="solid"/>
+                      <a:round/>
+                      <a:headEnd type="none" w="med" len="med"/>
+                      <a:tailEnd type="none" w="med" len="med"/>
+                    </a:lnL>
+                    <a:lnR w="6350" cap="flat" cmpd="sng" algn="ctr">
+                      <a:solidFill>
+                        <a:srgbClr val="DEE2E6"/>
+                      </a:solidFill>
+                      <a:prstDash val="solid"/>
+                      <a:round/>
+                      <a:headEnd type="none" w="med" len="med"/>
+                      <a:tailEnd type="none" w="med" len="med"/>
+                    </a:lnR>
+                    <a:lnT w="6350" cap="flat" cmpd="sng" algn="ctr">
+                      <a:solidFill>
+                        <a:srgbClr val="DEE2E6"/>
+                      </a:solidFill>
+                      <a:prstDash val="solid"/>
+                      <a:round/>
+                      <a:headEnd type="none" w="med" len="med"/>
+                      <a:tailEnd type="none" w="med" len="med"/>
+                    </a:lnT>
+                    <a:lnB w="6350" cap="flat" cmpd="sng" algn="ctr">
+                      <a:solidFill>
+                        <a:srgbClr val="DEE2E6"/>
+                      </a:solidFill>
+                      <a:prstDash val="solid"/>
+                      <a:round/>
+                      <a:headEnd type="none" w="med" len="med"/>
+                      <a:tailEnd type="none" w="med" len="med"/>
+                    </a:lnB>
+                    <a:solidFill>
+                      <a:schemeClr val="bg1"/>
+                    </a:solidFill>
+                  </a:tcPr>
+                </a:tc>
+              </a:tr>
+              <a:tr h="402336">
+                <a:tc>
+                  <a:txBody>
+                    <a:bodyPr/>
+                    <a:lstStyle/>
+                    <a:p>
+                      <a:pPr indent="0" marL="0">
+                        <a:buNone/>
+                      </a:pPr>
+                      <a:r>
+                        <a:rPr lang="en-US" sz="1250" dirty="0">
+                          <a:solidFill>
+                            <a:schemeClr val="tx1"/>
+                          </a:solidFill>
+                        </a:rPr>
+                        <a:t>PII obfuscated before ingestion; ClickHouse as the analytics projection</a:t>
+                      </a:r>
+                      <a:endParaRPr lang="en-US" sz="1250" dirty="0"/>
+                    </a:p>
+                  </a:txBody>
+                  <a:tcPr marL="91440" marR="91440" marT="0" marB="0" anchor="ctr">
+                    <a:lnL w="6350" cap="flat" cmpd="sng" algn="ctr">
+                      <a:solidFill>
+                        <a:srgbClr val="DEE2E6"/>
+                      </a:solidFill>
+                      <a:prstDash val="solid"/>
+                      <a:round/>
+                      <a:headEnd type="none" w="med" len="med"/>
+                      <a:tailEnd type="none" w="med" len="med"/>
+                    </a:lnL>
+                    <a:lnR w="6350" cap="flat" cmpd="sng" algn="ctr">
+                      <a:solidFill>
+                        <a:srgbClr val="DEE2E6"/>
+                      </a:solidFill>
+                      <a:prstDash val="solid"/>
+                      <a:round/>
+                      <a:headEnd type="none" w="med" len="med"/>
+                      <a:tailEnd type="none" w="med" len="med"/>
+                    </a:lnR>
+                    <a:lnT w="6350" cap="flat" cmpd="sng" algn="ctr">
+                      <a:solidFill>
+                        <a:srgbClr val="DEE2E6"/>
+                      </a:solidFill>
+                      <a:prstDash val="solid"/>
+                      <a:round/>
+                      <a:headEnd type="none" w="med" len="med"/>
+                      <a:tailEnd type="none" w="med" len="med"/>
+                    </a:lnT>
+                    <a:lnB w="6350" cap="flat" cmpd="sng" algn="ctr">
+                      <a:solidFill>
+                        <a:srgbClr val="DEE2E6"/>
+                      </a:solidFill>
+                      <a:prstDash val="solid"/>
+                      <a:round/>
+                      <a:headEnd type="none" w="med" len="med"/>
+                      <a:tailEnd type="none" w="med" len="med"/>
+                    </a:lnB>
+                    <a:solidFill>
+                      <a:schemeClr val="bg2"/>
+                    </a:solidFill>
+                  </a:tcPr>
+                </a:tc>
+                <a:tc>
+                  <a:txBody>
+                    <a:bodyPr/>
+                    <a:lstStyle/>
+                    <a:p>
+                      <a:pPr indent="0" marL="0">
+                        <a:buNone/>
+                      </a:pPr>
+                      <a:r>
+                        <a:rPr lang="en-US" sz="1250" dirty="0">
+                          <a:solidFill>
+                            <a:schemeClr val="tx1"/>
+                          </a:solidFill>
+                        </a:rPr>
+                        <a:t>not built: the next stages after our records</a:t>
+                      </a:r>
+                      <a:endParaRPr lang="en-US" sz="1250" dirty="0"/>
+                    </a:p>
+                  </a:txBody>
+                  <a:tcPr marL="91440" marR="91440" marT="0" marB="0" anchor="ctr">
+                    <a:lnL w="6350" cap="flat" cmpd="sng" algn="ctr">
+                      <a:solidFill>
+                        <a:srgbClr val="DEE2E6"/>
+                      </a:solidFill>
+                      <a:prstDash val="solid"/>
+                      <a:round/>
+                      <a:headEnd type="none" w="med" len="med"/>
+                      <a:tailEnd type="none" w="med" len="med"/>
+                    </a:lnL>
+                    <a:lnR w="6350" cap="flat" cmpd="sng" algn="ctr">
+                      <a:solidFill>
+                        <a:srgbClr val="DEE2E6"/>
+                      </a:solidFill>
+                      <a:prstDash val="solid"/>
+                      <a:round/>
+                      <a:headEnd type="none" w="med" len="med"/>
+                      <a:tailEnd type="none" w="med" len="med"/>
+                    </a:lnR>
+                    <a:lnT w="6350" cap="flat" cmpd="sng" algn="ctr">
+                      <a:solidFill>
+                        <a:srgbClr val="DEE2E6"/>
+                      </a:solidFill>
+                      <a:prstDash val="solid"/>
+                      <a:round/>
+                      <a:headEnd type="none" w="med" len="med"/>
+                      <a:tailEnd type="none" w="med" len="med"/>
+                    </a:lnT>
+                    <a:lnB w="6350" cap="flat" cmpd="sng" algn="ctr">
+                      <a:solidFill>
+                        <a:srgbClr val="DEE2E6"/>
+                      </a:solidFill>
+                      <a:prstDash val="solid"/>
+                      <a:round/>
+                      <a:headEnd type="none" w="med" len="med"/>
+                      <a:tailEnd type="none" w="med" len="med"/>
+                    </a:lnB>
+                    <a:solidFill>
+                      <a:schemeClr val="bg2"/>
+                    </a:solidFill>
+                  </a:tcPr>
+                </a:tc>
+              </a:tr>
+            </a:tbl>
+          </a:graphicData>
+        </a:graphic>
+      </p:graphicFrame>
+      <p:sp>
+        <p:nvSpPr>
+          <p:cNvPr id="9" name="honesty-153"/>
+          <p:cNvSpPr txBox="1"/>
+          <p:nvPr/>
+        </p:nvSpPr>
+        <p:spPr>
+          <a:xfrm>
+            <a:off x="548640" y="5943600"/>
+            <a:ext cx="11094415" cy="320040"/>
+          </a:xfrm>
+          <a:prstGeom prst="rect">
+            <a:avLst/>
+          </a:prstGeom>
+          <a:noFill/>
+          <a:ln/>
+        </p:spPr>
+        <p:txBody>
+          <a:bodyPr wrap="square" lIns="0" tIns="0" rIns="0" bIns="0" rtlCol="0" anchor="ctr"/>
+          <a:lstStyle/>
+          <a:p>
+            <a:pPr indent="0" marL="0">
+              <a:buNone/>
+            </a:pPr>
+            <a:r>
+              <a:rPr lang="en-US" sz="1200" i="1" dirty="0">
+                <a:solidFill>
+                  <a:schemeClr val="tx2"/>
+                </a:solidFill>
+              </a:rPr>
+              <a:t>From public pages only (docs/research/). No claim about how Enterpret works inside.</a:t>
+            </a:r>
+            <a:endParaRPr lang="en-US" sz="1200" dirty="0"/>
+          </a:p>
+        </p:txBody>
+      </p:sp>
+      <p:sp>
+        <p:nvSpPr>
+          <p:cNvPr id="25" name="Slide Number Placeholder 0"/>
+          <p:cNvSpPr>
+            <a:spLocks noGrp="1"/>
+          </p:cNvSpPr>
+          <p:nvPr>
+            <p:ph type="sldNum" sz="quarter" idx="4294967295"/>
+          </p:nvPr>
+        </p:nvSpPr>
+        <p:spPr>
+          <a:xfrm>
+            <a:off x="11094415" y="6419088"/>
+            <a:ext cx="548640" cy="274320"/>
+          </a:xfrm>
+          <a:prstGeom prst="rect">
+            <a:avLst/>
+          </a:prstGeom>
+          <a:extLst>
+            <a:ext uri="{C572A759-6A51-4108-AA02-DFA0A04FC94B}">
+              <ma14:wrappingTextBoxFlag xmlns:ma14="http://schemas.microsoft.com/office/mac/drawingml/2011/main" val="0"/>
+            </a:ext>
+          </a:extLst>
+        </p:spPr>
+        <p:txBody>
+          <a:bodyPr lIns="0" tIns="0" rIns="0" bIns="0"/>
+          <a:lstStyle>
+            <a:lvl1pPr>
+              <a:defRPr sz="1000">
+                <a:solidFill>
+                  <a:schemeClr val="tx2"/>
+                </a:solidFill>
+              </a:defRPr>
+            </a:lvl1pPr>
+          </a:lstStyle>
+          <a:p>
+            <a:pPr algn="r"/>
+            <a:fld id="{F7021451-1387-4CA6-816F-3879F97B5CBC}" type="slidenum">
+              <a:rPr b="0" lang="en-US"/>
+              <a:t>11</a:t>
             </a:fld>
             <a:endParaRPr lang="en-US"/>
           </a:p>
@@ -3611,7 +5047,7 @@
                             <a:schemeClr val="tx1"/>
                           </a:solidFill>
                         </a:rPr>
-                        <a:t>Heterogeneous sources: Intercom, Play Store, Twitter, Discourse</a:t>
+                        <a:t>Heterogeneous sources: Intercom, Play Store, Twitter, Discourse, custom webhook</a:t>
                       </a:r>
                       <a:endParaRPr lang="en-US" sz="1500" dirty="0"/>
                     </a:p>
@@ -3736,7 +5172,7 @@
                           <a:ea typeface="Courier New" pitchFamily="34" charset="-122"/>
                           <a:cs typeface="Courier New" pitchFamily="34" charset="-120"/>
                         </a:rPr>
-                        <a:t>connectors/*.py, connectors/registry.py</a:t>
+                        <a:t>connectors/*.py (custom.py: Enterpret's public shape)</a:t>
                       </a:r>
                       <a:endParaRPr lang="en-US" sz="1200" dirty="0">
                         <a:latin typeface="Courier New" charset="0"/>
@@ -4876,7 +6312,7 @@
                             <a:schemeClr val="tx1"/>
                           </a:solidFill>
                         </a:rPr>
-                        <a:t>Uniform structure: kind + common attributes</a:t>
+                        <a:t>Uniform structure: kind (review, conversation, post, survey) + common attributes</a:t>
                       </a:r>
                       <a:endParaRPr lang="en-US" sz="1500" dirty="0"/>
                     </a:p>
@@ -5635,7 +7071,7 @@
                             <a:schemeClr val="tx1"/>
                           </a:solidFill>
                         </a:rPr>
-                        <a:t>Beyond the brief: durable ack, retry, dead letter, replay</a:t>
+                        <a:t>Beyond the brief: durable ack, retry, dead letter, single and bulk replay</a:t>
                       </a:r>
                       <a:endParaRPr lang="en-US" sz="1500" dirty="0"/>
                     </a:p>
@@ -5993,7 +7429,7 @@
                   <a:schemeClr val="tx2"/>
                 </a:solidFill>
               </a:rPr>
-              <a:t>Playstore</a:t>
+              <a:t>Play Store</a:t>
             </a:r>
             <a:endParaRPr lang="en-US" sz="1500" dirty="0"/>
           </a:p>
@@ -6022,6 +7458,20 @@
                 </a:solidFill>
               </a:rPr>
               <a:t>Discourse</a:t>
+            </a:r>
+            <a:endParaRPr lang="en-US" sz="1500" dirty="0"/>
+          </a:p>
+          <a:p>
+            <a:pPr algn="l" indent="0" marL="0">
+              <a:buNone/>
+            </a:pPr>
+            <a:r>
+              <a:rPr lang="en-US" sz="1400" dirty="0">
+                <a:solidFill>
+                  <a:schemeClr val="tx2"/>
+                </a:solidFill>
+              </a:rPr>
+              <a:t>Custom</a:t>
             </a:r>
             <a:endParaRPr lang="en-US" sz="1500" dirty="0"/>
           </a:p>
@@ -6099,7 +7549,7 @@
                   <a:schemeClr val="tx2"/>
                 </a:solidFill>
               </a:rPr>
-              <a:t>API key → tenant, source ∈ tenant, HMAC over raw body</a:t>
+              <a:t>source id → source; its HMAC over the raw body; no API key</a:t>
             </a:r>
             <a:endParaRPr lang="en-US" sz="1500" dirty="0"/>
           </a:p>
@@ -6763,7 +8213,7 @@
                   <a:schemeClr val="tx2"/>
                 </a:solidFill>
               </a:rPr>
-              <a:t>newer version wins, tombstones stick</a:t>
+              <a:t>newer or equal version wins, tombstones stick</a:t>
             </a:r>
             <a:endParaRPr lang="en-US" sz="1500" dirty="0"/>
           </a:p>
@@ -7083,7 +8533,7 @@
               <a:buNone/>
             </a:pPr>
             <a:r>
-              <a:rPr lang="en-US" sz="1200" dirty="0">
+              <a:rPr lang="en-US" sz="1100" dirty="0">
                 <a:solidFill>
                   <a:schemeClr val="tx1"/>
                 </a:solidFill>
@@ -7091,7 +8541,7 @@
                 <a:ea typeface="Courier New" pitchFamily="34" charset="-122"/>
                 <a:cs typeface="Courier New" pitchFamily="34" charset="-120"/>
               </a:rPr>
-              <a:t>GET /health    GET /admin/raw-events?status=dead    POST /admin/raw-events/{id}/replay</a:t>
+              <a:t>GET /health   GET /admin/raw-events   POST /admin/raw-events/{id}/replay   POST /admin/raw-events/replay</a:t>
             </a:r>
             <a:endParaRPr lang="en-US" sz="1300" dirty="0"/>
           </a:p>
@@ -7347,7 +8797,7 @@
                   <a:schemeClr val="tx1"/>
                 </a:solidFill>
               </a:rPr>
-              <a:t>API key → tenant (hash lookup)</a:t>
+              <a:t>source id in the URL picks the source</a:t>
             </a:r>
             <a:endParaRPr lang="en-US" sz="1300" dirty="0"/>
           </a:p>
@@ -7365,7 +8815,7 @@
                   <a:schemeClr val="tx1"/>
                 </a:solidFill>
               </a:rPr>
-              <a:t>source must belong to that tenant</a:t>
+              <a:t>push-only: a pull source gets 409</a:t>
             </a:r>
             <a:endParaRPr lang="en-US" sz="1300" dirty="0"/>
           </a:p>
@@ -7401,7 +8851,7 @@
                   <a:schemeClr val="tx1"/>
                 </a:solidFill>
               </a:rPr>
-              <a:t>fails: 401, 404, 409 or 400</a:t>
+              <a:t>fails: 404, 409, 401, 400, 413</a:t>
             </a:r>
             <a:endParaRPr lang="en-US" sz="1300" dirty="0"/>
           </a:p>
@@ -7877,7 +9327,7 @@
                   <a:schemeClr val="tx1"/>
                 </a:solidFill>
               </a:rPr>
-              <a:t>one atomic UPDATE: pending and due, or lease expired</a:t>
+              <a:t>one atomic UPDATE claims a batch</a:t>
             </a:r>
             <a:endParaRPr lang="en-US" sz="1300" dirty="0"/>
           </a:p>
@@ -7895,7 +9345,7 @@
                   <a:schemeClr val="tx1"/>
                 </a:solidFill>
               </a:rPr>
-              <a:t>sets processing and lease_until</a:t>
+              <a:t>due pending or failed rows, or lease expired</a:t>
             </a:r>
             <a:endParaRPr lang="en-US" sz="1300" dirty="0"/>
           </a:p>
@@ -7913,7 +9363,7 @@
                   <a:schemeClr val="tx1"/>
                 </a:solidFill>
               </a:rPr>
-              <a:t>attempts + 1 on every claim</a:t>
+              <a:t>sets processing, lease, attempts + 1</a:t>
             </a:r>
             <a:endParaRPr lang="en-US" sz="1300" dirty="0"/>
           </a:p>
@@ -8612,7 +10062,7 @@
                   <a:schemeClr val="tx1"/>
                 </a:solidFill>
               </a:rPr>
-              <a:t>every read filtered by the key's tenant</a:t>
+              <a:t>API key → tenant; every read filtered by it</a:t>
             </a:r>
             <a:endParaRPr lang="en-US" sz="1300" dirty="0"/>
           </a:p>
@@ -9334,7 +10784,7 @@
                   <a:schemeClr val="tx1"/>
                 </a:solidFill>
               </a:rPr>
-              <a:t>Search pages by date window, then fetch posts 20 ids per call. Every payload goes through the same accept as a webhook.</a:t>
+              <a:t>Search pages by date window, then fetch posts 20 ids per call. A 60 s deadline and a 2 MB response cap bound each sync.</a:t>
             </a:r>
             <a:endParaRPr lang="en-US" sz="1400" dirty="0"/>
           </a:p>
@@ -9622,7 +11072,7 @@
                   <a:schemeClr val="tx1"/>
                 </a:solidFill>
               </a:rPr>
-              <a:t>The cursor is set to the newest post minus 60 s. We would rather fetch a post twice than miss it.</a:t>
+              <a:t>On the final page the cursor goes to the newest post minus 60 s, or to the window end if that is past. Twice beats missed.</a:t>
             </a:r>
             <a:endParaRPr lang="en-US" sz="1400" dirty="0"/>
           </a:p>
@@ -9766,7 +11216,7 @@
                   <a:schemeClr val="tx1"/>
                 </a:solidFill>
               </a:rPr>
-              <a:t>At most 20 search pages per window. A busier window errors loudly and the cursor stays put; a 429 or 5xx stops the run the same way.</a:t>
+              <a:t>At most 10 search pages (about 500 posts) per window. A busier window errors loudly, the cursor stays; lower window_days with PATCH.</a:t>
             </a:r>
             <a:endParaRPr lang="en-US" sz="1400" dirty="0"/>
           </a:p>
@@ -10244,7 +11694,7 @@
                 <a:ea typeface="Courier New" pitchFamily="34" charset="-122"/>
                 <a:cs typeface="Courier New" pitchFamily="34" charset="-120"/>
               </a:rPr>
-              <a:t>kind: review |</a:t>
+              <a:t>kind: review | post</a:t>
             </a:r>
             <a:endParaRPr lang="en-US" sz="1250" dirty="0"/>
           </a:p>
@@ -10264,7 +11714,7 @@
                 <a:ea typeface="Courier New" pitchFamily="34" charset="-122"/>
                 <a:cs typeface="Courier New" pitchFamily="34" charset="-120"/>
               </a:rPr>
-              <a:t>  conversation | post</a:t>
+              <a:t>  conversation | survey</a:t>
             </a:r>
             <a:endParaRPr lang="en-US" sz="1250" dirty="0"/>
           </a:p>
@@ -10502,7 +11952,7 @@
               <a:buNone/>
             </a:pPr>
             <a:r>
-              <a:rPr lang="en-US" sz="1200" b="1" dirty="0">
+              <a:rPr lang="en-US" sz="1100" b="1" dirty="0">
                 <a:solidFill>
                   <a:schemeClr val="accent1"/>
                 </a:solidFill>
@@ -10511,12 +11961,12 @@
             </a:r>
             <a:pPr indent="0" marL="0">
               <a:spcAft>
-                <a:spcPts val="300"/>
+                <a:spcPts val="200"/>
               </a:spcAft>
               <a:buNone/>
             </a:pPr>
             <a:r>
-              <a:rPr lang="en-US" sz="1200" dirty="0">
+              <a:rPr lang="en-US" sz="1100" dirty="0">
                 <a:solidFill>
                   <a:schemeClr val="tx1"/>
                 </a:solidFill>
@@ -10530,7 +11980,7 @@
               <a:buNone/>
             </a:pPr>
             <a:r>
-              <a:rPr lang="en-US" sz="1200" b="1" dirty="0">
+              <a:rPr lang="en-US" sz="1100" b="1" dirty="0">
                 <a:solidFill>
                   <a:schemeClr val="accent1"/>
                 </a:solidFill>
@@ -10539,12 +11989,12 @@
             </a:r>
             <a:pPr indent="0" marL="0">
               <a:spcAft>
-                <a:spcPts val="300"/>
+                <a:spcPts val="200"/>
               </a:spcAft>
               <a:buNone/>
             </a:pPr>
             <a:r>
-              <a:rPr lang="en-US" sz="1200" dirty="0">
+              <a:rPr lang="en-US" sz="1100" dirty="0">
                 <a:solidFill>
                   <a:schemeClr val="tx1"/>
                 </a:solidFill>
@@ -10558,7 +12008,7 @@
               <a:buNone/>
             </a:pPr>
             <a:r>
-              <a:rPr lang="en-US" sz="1200" b="1" dirty="0">
+              <a:rPr lang="en-US" sz="1100" b="1" dirty="0">
                 <a:solidFill>
                   <a:schemeClr val="accent1"/>
                 </a:solidFill>
@@ -10567,12 +12017,12 @@
             </a:r>
             <a:pPr indent="0" marL="0">
               <a:spcAft>
-                <a:spcPts val="300"/>
+                <a:spcPts val="200"/>
               </a:spcAft>
               <a:buNone/>
             </a:pPr>
             <a:r>
-              <a:rPr lang="en-US" sz="1200" dirty="0">
+              <a:rPr lang="en-US" sz="1100" dirty="0">
                 <a:solidFill>
                   <a:schemeClr val="tx1"/>
                 </a:solidFill>
@@ -10586,7 +12036,7 @@
               <a:buNone/>
             </a:pPr>
             <a:r>
-              <a:rPr lang="en-US" sz="1200" b="1" dirty="0">
+              <a:rPr lang="en-US" sz="1100" b="1" dirty="0">
                 <a:solidFill>
                   <a:schemeClr val="accent1"/>
                 </a:solidFill>
@@ -10595,17 +12045,45 @@
             </a:r>
             <a:pPr indent="0" marL="0">
               <a:spcAft>
-                <a:spcPts val="300"/>
+                <a:spcPts val="200"/>
               </a:spcAft>
               <a:buNone/>
             </a:pPr>
             <a:r>
-              <a:rPr lang="en-US" sz="1200" dirty="0">
+              <a:rPr lang="en-US" sz="1100" dirty="0">
                 <a:solidFill>
                   <a:schemeClr val="tx1"/>
                 </a:solidFill>
               </a:rPr>
               <a:t>topic_id, post_number, like_count, url</a:t>
+            </a:r>
+            <a:endParaRPr lang="en-US" sz="1200" dirty="0"/>
+          </a:p>
+          <a:p>
+            <a:pPr indent="0" marL="0">
+              <a:buNone/>
+            </a:pPr>
+            <a:r>
+              <a:rPr lang="en-US" sz="1100" b="1" dirty="0">
+                <a:solidFill>
+                  <a:schemeClr val="accent1"/>
+                </a:solidFill>
+              </a:rPr>
+              <a:t>Custom  </a:t>
+            </a:r>
+            <a:pPr indent="0" marL="0">
+              <a:spcAft>
+                <a:spcPts val="200"/>
+              </a:spcAft>
+              <a:buNone/>
+            </a:pPr>
+            <a:r>
+              <a:rPr lang="en-US" sz="1100" dirty="0">
+                <a:solidFill>
+                  <a:schemeClr val="tx1"/>
+                </a:solidFill>
+              </a:rPr>
+              <a:t>record_type, score, fields</a:t>
             </a:r>
             <a:endParaRPr lang="en-US" sz="1200" dirty="0"/>
           </a:p>
@@ -11582,7 +13060,7 @@
                   <a:schemeClr val="tx1"/>
                 </a:solidFill>
               </a:rPr>
-              <a:t>Fix the connector, bump connector_version, replay the window.</a:t>
+              <a:t>Fix the connector, bump connector_version, replay one event or in bulk.</a:t>
             </a:r>
             <a:endParaRPr lang="en-US" sz="1600" dirty="0"/>
           </a:p>
@@ -11600,7 +13078,7 @@
                   <a:schemeClr val="tx1"/>
                 </a:solidFill>
               </a:rPr>
-              <a:t>Replay runs in raw_events.id order, so deletes are applied again.</a:t>
+              <a:t>Order does not matter: older versions skip, deletes stick.</a:t>
             </a:r>
             <a:endParaRPr lang="en-US" sz="1600" dirty="0"/>
           </a:p>
@@ -12340,7 +13818,7 @@
                             <a:schemeClr val="tx1"/>
                           </a:solidFill>
                         </a:rPr>
-                        <a:t>Inserts are cheap, the 202 stays fast, the backlog drains at the worker's pace. SQLite is one writer; past that, DATABASE_URL points at Postgres.</a:t>
+                        <a:t>Inserts are cheap, the 202 stays fast, the backlog drains at the worker's pace. SQLite is one writer; past that comes Postgres.</a:t>
                       </a:r>
                       <a:endParaRPr lang="en-US" sz="1550" dirty="0"/>
                     </a:p>
@@ -12471,7 +13949,7 @@
                             <a:schemeClr val="tx1"/>
                           </a:solidFill>
                         </a:rPr>
-                        <a:t>It is safe because the claim is a single statement and the upsert is idempotent; in production one scheduler runs.</a:t>
+                        <a:t>It is safe because the claim is a single statement and the upsert is idempotent; two schedulers only waste calls.</a:t>
                       </a:r>
                       <a:endParaRPr lang="en-US" sz="1550" dirty="0"/>
                     </a:p>
@@ -12795,7 +14273,7 @@
                 <a:ea typeface="Arial" pitchFamily="34" charset="-122"/>
                 <a:cs typeface="Arial" pitchFamily="34" charset="-120"/>
               </a:rPr>
-              <a:t>Add Zendesk in four pieces</a:t>
+              <a:t>Add Zendesk in five pieces</a:t>
             </a:r>
             <a:endParaRPr lang="en-US" sz="1900" dirty="0"/>
           </a:p>
@@ -12809,7 +14287,7 @@
         </p:nvSpPr>
         <p:spPr>
           <a:xfrm>
-            <a:off x="548640" y="1965960"/>
+            <a:off x="548640" y="1938528"/>
             <a:ext cx="411480" cy="411480"/>
           </a:xfrm>
           <a:prstGeom prst="ellipse">
@@ -12851,8 +14329,8 @@
         </p:nvSpPr>
         <p:spPr>
           <a:xfrm>
-            <a:off x="1097280" y="1874520"/>
-            <a:ext cx="3200400" cy="731520"/>
+            <a:off x="1097280" y="1828800"/>
+            <a:ext cx="3200400" cy="640080"/>
           </a:xfrm>
           <a:prstGeom prst="rect">
             <a:avLst/>
@@ -12868,7 +14346,7 @@
               <a:buNone/>
             </a:pPr>
             <a:r>
-              <a:rPr lang="en-US" sz="1300" b="1" dirty="0">
+              <a:rPr lang="en-US" sz="1250" b="1" dirty="0">
                 <a:solidFill>
                   <a:schemeClr val="tx1"/>
                 </a:solidFill>
@@ -12876,23 +14354,23 @@
                 <a:ea typeface="Courier New" pitchFamily="34" charset="-122"/>
                 <a:cs typeface="Courier New" pitchFamily="34" charset="-120"/>
               </a:rPr>
-              <a:t>connectors/zendesk.py</a:t>
-            </a:r>
-            <a:endParaRPr lang="en-US" sz="1300" dirty="0"/>
+              <a:t>domain/enums.py, models.py</a:t>
+            </a:r>
+            <a:endParaRPr lang="en-US" sz="1250" dirty="0"/>
           </a:p>
           <a:p>
             <a:pPr indent="0" marL="0">
               <a:buNone/>
             </a:pPr>
             <a:r>
-              <a:rPr lang="en-US" sz="1300" dirty="0">
+              <a:rPr lang="en-US" sz="1250" dirty="0">
                 <a:solidFill>
                   <a:schemeClr val="tx2"/>
                 </a:solidFill>
               </a:rPr>
-              <a:t>input model, external_event_id, transform, signature</a:t>
-            </a:r>
-            <a:endParaRPr lang="en-US" sz="1300" dirty="0"/>
+              <a:t>SourceType.ZENDESK, KIND_BY_SOURCE entry</a:t>
+            </a:r>
+            <a:endParaRPr lang="en-US" sz="1250" dirty="0"/>
           </a:p>
         </p:txBody>
       </p:sp>
@@ -12904,7 +14382,7 @@
         </p:nvSpPr>
         <p:spPr>
           <a:xfrm>
-            <a:off x="548640" y="2834640"/>
+            <a:off x="548640" y="2651760"/>
             <a:ext cx="411480" cy="411480"/>
           </a:xfrm>
           <a:prstGeom prst="ellipse">
@@ -12946,8 +14424,8 @@
         </p:nvSpPr>
         <p:spPr>
           <a:xfrm>
-            <a:off x="1097280" y="2743200"/>
-            <a:ext cx="3200400" cy="731520"/>
+            <a:off x="1097280" y="2542032"/>
+            <a:ext cx="3200400" cy="640080"/>
           </a:xfrm>
           <a:prstGeom prst="rect">
             <a:avLst/>
@@ -12963,7 +14441,7 @@
               <a:buNone/>
             </a:pPr>
             <a:r>
-              <a:rPr lang="en-US" sz="1300" b="1" dirty="0">
+              <a:rPr lang="en-US" sz="1250" b="1" dirty="0">
                 <a:solidFill>
                   <a:schemeClr val="tx1"/>
                 </a:solidFill>
@@ -12973,21 +14451,21 @@
               </a:rPr>
               <a:t>domain/metadata.py</a:t>
             </a:r>
-            <a:endParaRPr lang="en-US" sz="1300" dirty="0"/>
+            <a:endParaRPr lang="en-US" sz="1250" dirty="0"/>
           </a:p>
           <a:p>
             <a:pPr indent="0" marL="0">
               <a:buNone/>
             </a:pPr>
             <a:r>
-              <a:rPr lang="en-US" sz="1300" dirty="0">
+              <a:rPr lang="en-US" sz="1250" dirty="0">
                 <a:solidFill>
                   <a:schemeClr val="tx2"/>
                 </a:solidFill>
               </a:rPr>
               <a:t>ZendeskMetadata in the union</a:t>
             </a:r>
-            <a:endParaRPr lang="en-US" sz="1300" dirty="0"/>
+            <a:endParaRPr lang="en-US" sz="1250" dirty="0"/>
           </a:p>
         </p:txBody>
       </p:sp>
@@ -12999,7 +14477,7 @@
         </p:nvSpPr>
         <p:spPr>
           <a:xfrm>
-            <a:off x="548640" y="3703320"/>
+            <a:off x="548640" y="3364992"/>
             <a:ext cx="411480" cy="411480"/>
           </a:xfrm>
           <a:prstGeom prst="ellipse">
@@ -13041,8 +14519,8 @@
         </p:nvSpPr>
         <p:spPr>
           <a:xfrm>
-            <a:off x="1097280" y="3611880"/>
-            <a:ext cx="3200400" cy="731520"/>
+            <a:off x="1097280" y="3255264"/>
+            <a:ext cx="3200400" cy="640080"/>
           </a:xfrm>
           <a:prstGeom prst="rect">
             <a:avLst/>
@@ -13058,7 +14536,7 @@
               <a:buNone/>
             </a:pPr>
             <a:r>
-              <a:rPr lang="en-US" sz="1300" b="1" dirty="0">
+              <a:rPr lang="en-US" sz="1250" b="1" dirty="0">
                 <a:solidFill>
                   <a:schemeClr val="tx1"/>
                 </a:solidFill>
@@ -13066,23 +14544,23 @@
                 <a:ea typeface="Courier New" pitchFamily="34" charset="-122"/>
                 <a:cs typeface="Courier New" pitchFamily="34" charset="-120"/>
               </a:rPr>
-              <a:t>connectors/registry.py</a:t>
-            </a:r>
-            <a:endParaRPr lang="en-US" sz="1300" dirty="0"/>
+              <a:t>connectors/zendesk.py</a:t>
+            </a:r>
+            <a:endParaRPr lang="en-US" sz="1250" dirty="0"/>
           </a:p>
           <a:p>
             <a:pPr indent="0" marL="0">
               <a:buNone/>
             </a:pPr>
             <a:r>
-              <a:rPr lang="en-US" sz="1300" dirty="0">
+              <a:rPr lang="en-US" sz="1250" dirty="0">
                 <a:solidFill>
                   <a:schemeClr val="tx2"/>
                 </a:solidFill>
               </a:rPr>
-              <a:t>one ZendeskConnector() entry</a:t>
-            </a:r>
-            <a:endParaRPr lang="en-US" sz="1300" dirty="0"/>
+              <a:t>input model, event id, transform, signature</a:t>
+            </a:r>
+            <a:endParaRPr lang="en-US" sz="1250" dirty="0"/>
           </a:p>
         </p:txBody>
       </p:sp>
@@ -13094,7 +14572,7 @@
         </p:nvSpPr>
         <p:spPr>
           <a:xfrm>
-            <a:off x="548640" y="4572000"/>
+            <a:off x="548640" y="4078224"/>
             <a:ext cx="411480" cy="411480"/>
           </a:xfrm>
           <a:prstGeom prst="ellipse">
@@ -13136,8 +14614,8 @@
         </p:nvSpPr>
         <p:spPr>
           <a:xfrm>
-            <a:off x="1097280" y="4480560"/>
-            <a:ext cx="3200400" cy="731520"/>
+            <a:off x="1097280" y="3968496"/>
+            <a:ext cx="3200400" cy="640080"/>
           </a:xfrm>
           <a:prstGeom prst="rect">
             <a:avLst/>
@@ -13153,7 +14631,7 @@
               <a:buNone/>
             </a:pPr>
             <a:r>
-              <a:rPr lang="en-US" sz="1300" b="1" dirty="0">
+              <a:rPr lang="en-US" sz="1250" b="1" dirty="0">
                 <a:solidFill>
                   <a:schemeClr val="tx1"/>
                 </a:solidFill>
@@ -13161,34 +14639,129 @@
                 <a:ea typeface="Courier New" pitchFamily="34" charset="-122"/>
                 <a:cs typeface="Courier New" pitchFamily="34" charset="-120"/>
               </a:rPr>
-              <a:t>tests/fixtures/zendesk/</a:t>
-            </a:r>
-            <a:endParaRPr lang="en-US" sz="1300" dirty="0"/>
+              <a:t>connectors/registry.py</a:t>
+            </a:r>
+            <a:endParaRPr lang="en-US" sz="1250" dirty="0"/>
           </a:p>
           <a:p>
             <a:pPr indent="0" marL="0">
               <a:buNone/>
             </a:pPr>
             <a:r>
-              <a:rPr lang="en-US" sz="1300" dirty="0">
+              <a:rPr lang="en-US" sz="1250" dirty="0">
                 <a:solidFill>
                   <a:schemeClr val="tx2"/>
                 </a:solidFill>
               </a:rPr>
-              <a:t>ticket, edited ticket, malformed</a:t>
-            </a:r>
-            <a:endParaRPr lang="en-US" sz="1300" dirty="0"/>
-          </a:p>
-        </p:txBody>
-      </p:sp>
-      <p:sp>
-        <p:nvSpPr>
-          <p:cNvPr id="12" name="zendesk-foot-124"/>
+              <a:t>one entry in the CONNECTORS tuple</a:t>
+            </a:r>
+            <a:endParaRPr lang="en-US" sz="1250" dirty="0"/>
+          </a:p>
+        </p:txBody>
+      </p:sp>
+      <p:sp>
+        <p:nvSpPr>
+          <p:cNvPr id="12" name="step-124"/>
           <p:cNvSpPr txBox="1"/>
           <p:nvPr/>
         </p:nvSpPr>
         <p:spPr>
           <a:xfrm>
+            <a:off x="548640" y="4791456"/>
+            <a:ext cx="411480" cy="411480"/>
+          </a:xfrm>
+          <a:prstGeom prst="ellipse">
+            <a:avLst/>
+          </a:prstGeom>
+          <a:solidFill>
+            <a:schemeClr val="accent1"/>
+          </a:solidFill>
+          <a:ln w="9525">
+            <a:solidFill>
+              <a:schemeClr val="accent1"/>
+            </a:solidFill>
+          </a:ln>
+        </p:spPr>
+        <p:txBody>
+          <a:bodyPr wrap="square" lIns="0" tIns="0" rIns="0" bIns="0" rtlCol="0" anchor="ctr"/>
+          <a:lstStyle/>
+          <a:p>
+            <a:pPr algn="ctr" indent="0" marL="0">
+              <a:buNone/>
+            </a:pPr>
+            <a:r>
+              <a:rPr lang="en-US" sz="1400" b="1" dirty="0">
+                <a:solidFill>
+                  <a:schemeClr val="bg1"/>
+                </a:solidFill>
+              </a:rPr>
+              <a:t>5</a:t>
+            </a:r>
+            <a:endParaRPr lang="en-US" sz="1400" dirty="0"/>
+          </a:p>
+        </p:txBody>
+      </p:sp>
+      <p:sp>
+        <p:nvSpPr>
+          <p:cNvPr id="13" name="zendesk-step-125"/>
+          <p:cNvSpPr txBox="1"/>
+          <p:nvPr/>
+        </p:nvSpPr>
+        <p:spPr>
+          <a:xfrm>
+            <a:off x="1097280" y="4681728"/>
+            <a:ext cx="3200400" cy="640080"/>
+          </a:xfrm>
+          <a:prstGeom prst="rect">
+            <a:avLst/>
+          </a:prstGeom>
+          <a:noFill/>
+          <a:ln/>
+        </p:spPr>
+        <p:txBody>
+          <a:bodyPr wrap="square" lIns="0" tIns="0" rIns="0" bIns="0" rtlCol="0" anchor="ctr"/>
+          <a:lstStyle/>
+          <a:p>
+            <a:pPr indent="0" marL="0">
+              <a:buNone/>
+            </a:pPr>
+            <a:r>
+              <a:rPr lang="en-US" sz="1250" b="1" dirty="0">
+                <a:solidFill>
+                  <a:schemeClr val="tx1"/>
+                </a:solidFill>
+                <a:latin typeface="Courier New" pitchFamily="34" charset="0"/>
+                <a:ea typeface="Courier New" pitchFamily="34" charset="-122"/>
+                <a:cs typeface="Courier New" pitchFamily="34" charset="-120"/>
+              </a:rPr>
+              <a:t>tests/fixtures/zendesk/</a:t>
+            </a:r>
+            <a:endParaRPr lang="en-US" sz="1250" dirty="0"/>
+          </a:p>
+          <a:p>
+            <a:pPr indent="0" marL="0">
+              <a:buNone/>
+            </a:pPr>
+            <a:r>
+              <a:rPr lang="en-US" sz="1250" dirty="0">
+                <a:solidFill>
+                  <a:schemeClr val="tx2"/>
+                </a:solidFill>
+              </a:rPr>
+              <a:t>ticket, edited ticket, malformed</a:t>
+            </a:r>
+            <a:endParaRPr lang="en-US" sz="1250" dirty="0"/>
+          </a:p>
+        </p:txBody>
+      </p:sp>
+      <p:sp>
+        <p:nvSpPr>
+          <p:cNvPr id="14" name="zendesk-foot-126"/>
+          <p:cNvSpPr txBox="1"/>
+          <p:nvPr/>
+        </p:nvSpPr>
+        <p:spPr>
+          <a:xfrm>
             <a:off x="548640" y="5440680"/>
             <a:ext cx="3749040" cy="777240"/>
           </a:xfrm>
@@ -13206,20 +14779,20 @@
               <a:buNone/>
             </a:pPr>
             <a:r>
-              <a:rPr lang="en-US" sz="1400" i="1" dirty="0">
+              <a:rPr lang="en-US" sz="1300" i="1" dirty="0">
                 <a:solidFill>
                   <a:schemeClr val="tx1"/>
                 </a:solidFill>
               </a:rPr>
-              <a:t>The contract test fails until all four exist. No service, route, worker or table changes.</a:t>
-            </a:r>
-            <a:endParaRPr lang="en-US" sz="1400" dirty="0"/>
-          </a:p>
-        </p:txBody>
-      </p:sp>
-      <p:sp>
-        <p:nvSpPr>
-          <p:cNvPr id="13" name="ports-head-125"/>
+              <a:t>Registry and metadata tests fail until all five exist. No service, route, worker or table changes. Worked example: custom.py.</a:t>
+            </a:r>
+            <a:endParaRPr lang="en-US" sz="1300" dirty="0"/>
+          </a:p>
+        </p:txBody>
+      </p:sp>
+      <p:sp>
+        <p:nvSpPr>
+          <p:cNvPr id="15" name="ports-head-127"/>
           <p:cNvSpPr txBox="1"/>
           <p:nvPr/>
         </p:nvSpPr>
@@ -13258,7 +14831,7 @@
       </p:sp>
       <p:sp>
         <p:nvSpPr>
-          <p:cNvPr id="14" name="svc-126"/>
+          <p:cNvPr id="16" name="svc-128"/>
           <p:cNvSpPr txBox="1"/>
           <p:nvPr/>
         </p:nvSpPr>
@@ -13322,7 +14895,7 @@
       </p:sp>
       <p:sp>
         <p:nvSpPr>
-          <p:cNvPr id="15" name="ports-127"/>
+          <p:cNvPr id="17" name="ports-129"/>
           <p:cNvSpPr txBox="1"/>
           <p:nvPr/>
         </p:nvSpPr>
@@ -13386,7 +14959,7 @@
       </p:sp>
       <p:sp>
         <p:nvSpPr>
-          <p:cNvPr id="16" name="adapters-128"/>
+          <p:cNvPr id="18" name="adapters-130"/>
           <p:cNvSpPr txBox="1"/>
           <p:nvPr/>
         </p:nvSpPr>
@@ -13450,7 +15023,7 @@
       </p:sp>
       <p:sp>
         <p:nvSpPr>
-          <p:cNvPr id="17" name="arrow-129"/>
+          <p:cNvPr id="19" name="arrow-131"/>
           <p:cNvSpPr/>
           <p:nvPr/>
         </p:nvSpPr>
@@ -13474,7 +15047,7 @@
       </p:sp>
       <p:sp>
         <p:nvSpPr>
-          <p:cNvPr id="18" name="arrow-130"/>
+          <p:cNvPr id="20" name="arrow-132"/>
           <p:cNvSpPr/>
           <p:nvPr/>
         </p:nvSpPr>
@@ -13498,7 +15071,7 @@
       </p:sp>
       <p:sp>
         <p:nvSpPr>
-          <p:cNvPr id="19" name="ports-foot-131"/>
+          <p:cNvPr id="21" name="ports-foot-133"/>
           <p:cNvSpPr txBox="1"/>
           <p:nvPr/>
         </p:nvSpPr>
@@ -13534,7 +15107,7 @@
       </p:sp>
       <p:sp>
         <p:nvSpPr>
-          <p:cNvPr id="20" name="swap-head-132"/>
+          <p:cNvPr id="22" name="swap-head-134"/>
           <p:cNvSpPr txBox="1"/>
           <p:nvPr/>
         </p:nvSpPr>
@@ -13573,7 +15146,7 @@
       </p:sp>
       <p:sp>
         <p:nvSpPr>
-          <p:cNvPr id="21" name="pg-133"/>
+          <p:cNvPr id="23" name="pg-135"/>
           <p:cNvSpPr txBox="1"/>
           <p:nvPr/>
         </p:nvSpPr>
@@ -13662,7 +15235,7 @@
       </p:sp>
       <p:sp>
         <p:nvSpPr>
-          <p:cNvPr id="22" name="broker-134"/>
+          <p:cNvPr id="24" name="broker-136"/>
           <p:cNvSpPr txBox="1"/>
           <p:nvPr/>
         </p:nvSpPr>

</xml_diff>

<commit_message>
docs: final submission pass (reading order, accuracy, deck)
- README: reading order under the intro, reference list, design cut to the three guarantees
- internal process jargon out of the interview pack and architecture doc
- one canonical copy of the add-a-source recipe (ADR-003) and the Postgres swap (extensions recipe 2)
- whiteboard: five things to know before you walk in
- wording fixes from the docs-vs-code audit (parsed JSON storage, health, Kafka/SQS, kind, language)
- deck: pull arrow reversed, next-steps order, demo step list, slide 11 cells re-verified

Co-Authored-By: Claude Opus 5.5 <noreply@anthropic.com>
</commit_message>
<xml_diff>
--- a/docs/slides/deck.pptx
+++ b/docs/slides/deck.pptx
@@ -117,13 +117,13 @@
   <p:extLst>
     <p:ext uri="{521415D9-36F7-43E2-AB2F-B90AF26B5E84}">
       <p14:sectionLst xmlns:p14="http://schemas.microsoft.com/office/powerpoint/2010/main">
-        <p14:section name="Opening" id="{5cea408e-413f-b61f-541e-a987395f5bdd}">
+        <p14:section name="Opening" id="{5c842010-d20f-8443-8e60-acef96b2392b}">
           <p14:sldIdLst>
             <p14:sldId id="256"/>
             <p14:sldId id="257"/>
           </p14:sldIdLst>
         </p14:section>
-        <p14:section name="How it works" id="{cde8d2a2-4d86-a82f-5d6f-a03e900c2833}">
+        <p14:section name="How it works" id="{7f5518da-97cd-13a1-3d3e-2bb3468887a7}">
           <p14:sldIdLst>
             <p14:sldId id="258"/>
             <p14:sldId id="259"/>
@@ -131,13 +131,13 @@
             <p14:sldId id="261"/>
           </p14:sldIdLst>
         </p14:section>
-        <p14:section name="Why it holds" id="{44ab143d-80ac-fa99-d46b-669844a8a6ef}">
+        <p14:section name="Why it holds" id="{acc0fe8a-c306-f207-4c2a-599d1c74292c}">
           <p14:sldIdLst>
             <p14:sldId id="262"/>
             <p14:sldId id="263"/>
           </p14:sldIdLst>
         </p14:section>
-        <p14:section name="Where it goes" id="{11980304-0878-4d1f-d510-a88cd1c9bbdf}">
+        <p14:section name="Where it goes" id="{064718c5-b37e-6c83-11ed-977b488ed487}">
           <p14:sldIdLst>
             <p14:sldId id="264"/>
             <p14:sldId id="265"/>
@@ -640,10 +640,10 @@
             <a:r>
               <a:rPr lang="en-US" dirty="0"/>
               <a:t>Debt ledger, top three (debt_ledger.md):
-1. #6, the Discourse 10-page cap (discourse_pull.py:29). About 500 posts per day is the hard limit of Discourse search. "A hard cap with a loud error beats silently skipping posts, but a forum busier than about 500 posts a day would need date slicing." Today a person lowers window_days with PATCH. Upgrade: split the window by date and page through each slice, or shrink the window on its own when the cap is hit.
-2. #1, migrations (db.py:39). "We fail fast on schema drift today; the first schema change on real data is when I add Alembic migrations."
-3. #12, the shared bootstrap token (tenants.py:18). "A shared token is enough to bootstrap a take-home; production admin needs per-person identity and an audit trail."
-Demo (demo_script.md): ten steps, about two minutes. demo.sh exports a random FI_BOOTSTRAP_TOKEN first, because the default token is refused. Two synthetic tenants: lumenote (a consumer app) and brightwave (B2B SaaS). Watch for five things: a duplicate that is stored once, two apps of the same type, a tenant that sees nothing, one custom batch that becomes three records of three kinds, and a kill -9 that loses nothing. Step 8 needs network (meta.discourse.org); without it run uv run pytest tests/e2e/test_pull_to_query.py -q.
+1. #1, migrations (db.py:39). "We fail fast on schema drift today; the first schema change on real data is when I add Alembic migrations."
+2. #12, the shared bootstrap token (tenants.py:18). "A shared token is enough to bootstrap a take-home; production admin needs per-person identity and an audit trail."
+3. #6, the Discourse 10-page cap (discourse_pull.py:29). About 500 posts per day is the hard limit of Discourse search. "A hard cap with a loud error beats silently skipping posts, but a forum busier than about 500 posts a day would need date slicing." Mitigation today: lower window_days with PATCH /v1/sources/{id}. Upgrade: split the window by date and page through each slice, or shrink the window on its own when the cap is hit.
+Demo (demo_script.md): eleven steps, about two minutes. demo.sh exports a random FI_BOOTSTRAP_TOKEN first, because the default token is refused. Two synthetic tenants: lumenote (a consumer app) and brightwave (B2B SaaS). Watch for five things: a duplicate that is stored once, two apps of the same type, a tenant that sees nothing, one custom batch that becomes three records of three kinds, an Intercom conversation and a tweet in the same record shape, and a kill -9 that loses nothing. Step 9 needs network (meta.discourse.org); without it run uv run pytest tests/e2e/test_pull_to_query.py -q.
 30-second close: "So, the four things: a duplicate stored once, two apps of the same type kept apart, a tenant that sees nothing of another, and a hard kill that lost nothing. Plus a bad payload parked with its reason and replayed, and a live pull through the same pipeline. All of it rests on one rule: save the raw payload before we say yes, then everything is a retry or a replay. Adding a new source is an enum value, a metadata model, one connector file, one registry entry and fixtures, and the custom connector shows it. Happy to add a field live, or to break something and show you where it lands."</a:t>
             </a:r>
             <a:endParaRPr lang="en-US" dirty="0"/>
@@ -736,11 +736,12 @@
 Opening line: "Enterpret's site describes the product as Unify, Understand, Act. This service is the Unify step: it gets feedback in from many sources, keeps it safe, and turns it into one standard Feedback Record. Taxonomy, themes and Wisdom are the Understand step, and they would read our records; I did not build them."
 Custom connector: "Their public webhook takes a batch of records with an id, a type, createdAt in epoch seconds and typed metadata. Our custom connector takes that same shape, so the add-a-source story is done against a contract they know. One push is one raw event. Each record upserts on source and record id. The kind comes from the type, and SURVEY needed a new kind, survey. AUDIO_RECORDING is not text, so it is refused and the batch goes dead."
 Auth difference: their docs describe an api-key header per integration. Ours is a per-source URL plus an HMAC signature, so a sender proves itself without holding a tenant key. Same idea: one credential per source.
-202: "Their docs say accepted does not mean processed. That is exactly our 202: the raw row is on disk, and the worker does the rest."
+202: "Their webhook docs warn that a 200 does not guarantee the records appear. Our 202 is the same promise: the raw row is on disk and the worker does the rest, and a bad payload shows on the dead list instead of vanishing."
 Duplicates: "Their default skips a repeated id, and replace is an opt-in. We skip a repeated delivery at raw_events. For the record itself we always take a newer or equal version and never an older one, which is close to their opt-in replace plus the version rule."
 Version guard: "Their engineering blog says stale and out-of-order updates are rejected by version. Our upsert does the same with COALESCE(updated, created)."
 Noisy neighbours: "Their engineering blog names queue clogging and noisy neighbours as incidents and describes partitioning by tenant. We have one shared queue, so a burst delays others but loses nothing. Per-tenant claiming is the upgrade."
-Not built, on purpose: PII redaction before storage (their docs say they obfuscate PII before ingestion; we only keep it out of logs and error text), the ClickHouse analytics projection their blog describes, rate limits, users and accounts. Their help center describes a 4-hour poll for support tools and app stores; ours is FI_PULL_INTERVAL_SECONDS, 300 by default.</a:t>
+Not built, on purpose: PII redaction before storage (we only keep it out of logs and error text), the ClickHouse analytics projection their blog describes, rate limits, users and accounts. Their help center describes a 4-hour poll for support tools and app stores; ours is FI_PULL_INTERVAL_SECONDS, 300 by default.
+Verified on 2026-10-03 against the help-center pages cited in docs/research/01: the webhook article (12131693: record types incl. AUDIO_RECORDING, createdAt as epoch seconds, typed metadata, duplicate ids skipped by default with replace opt-in via support, a 200 that does not guarantee records appear, api-key header) and the Google Play (6331595) and Intercom (6320475) articles (new data every 4 hours). Dropped: the "PII obfuscated before ingestion" cell, which is not on those pages. The engineering-blog rows quote the blog and were not re-checked here.</a:t>
             </a:r>
             <a:endParaRPr lang="en-US" dirty="0"/>
           </a:p>
@@ -836,7 +837,7 @@
 - Idempotency: tests/e2e/test_push_to_query.py, tests/adapters/contract_upsert.py.
 - Several sources of one type: tests/e2e/test_multi_source_same_type.py.
 - Beyond the brief: tests/e2e/test_dlq_replay.py, tests/e2e/test_restart_resume.py, tests/api/test_replay_api.py (bulk replay).
-If asked "did you write this": "I designed it and reviewed every file; AI agents wrote and audited the code. Every decision went through a five-advisor council and is in docs/decisions."</a:t>
+If asked "did you write this": "I designed it and reviewed every file; AI agents wrote and audited the code. Every big decision was argued by five independent advisor agents and is written up in docs/decisions."</a:t>
             </a:r>
             <a:endParaRPr lang="en-US" dirty="0"/>
           </a:p>
@@ -926,7 +927,7 @@
               <a:rPr lang="en-US" dirty="0"/>
               <a:t>Whiteboard steps 1 to 3 (whiteboard.md).
 Push arrow: "The webhook does two checks and one write. The source id in the URL picks the source, and the tenant comes from that source row. Then the signature: an HMAC over the raw bytes with that source's own secret. No API key, because a third-party sender like Intercom cannot add our key. Webhooks are push-only: a pull source answers 409. Then one insert, then 202. 202 means accepted, not processed."
-Pull arrow: "Polling is just another producer. The connector returns pages; every payload goes through the same accept call a webhook uses."
+Pull arrow (it points from the service to the source: we fetch): "Polling is just another producer. The connector returns pages; every payload goes through the same accept call a webhook uses."
 raw_events: "This table is both the audit log and the work queue. Unique on (source, external event id), so a repeated webhook is stored once."
 Worker: "One SQL statement claims a batch: rows that are pending or failed and due, or whose lease expired. It sets processing and a lease and returns them. Atomic, so two workers never take the same row. A crashed worker's rows come back when the lease expires."
 Ops strip: health, the dead list, replay of one event, and bulk replay by source and status.
@@ -1026,7 +1027,7 @@
 3. "One SQL statement claims a batch of due rows ... Atomic, so two workers never take the same row. A crashed worker's rows come back when the lease expires."
 4. "A connector validates the payload with a Pydantic input model, then maps it to our record."
 5. "Unique on (source, external id). The upsert only applies a version that is not older." Outcomes: "Bad payloads die on the first try, they are never retried. Flaky things back off. Marks are fenced on the lease, so a stale worker cannot overwrite a newer claim."
-6. "Every read and admin request carries an API key. We store only its hash. Every read is filtered by that tenant; a foreign id is a 404, not a 403, so we do not leak existence." The webhook and /health are the only routes without one.</a:t>
+6. "Every read and admin request carries an API key. We store only its hash. Every read is filtered by that tenant; a foreign id is a 404, not a 403, so we do not leak existence." Three routes take no API key: /health, the webhook, and POST /admin/tenants (the bootstrap token instead).</a:t>
             </a:r>
             <a:endParaRPr lang="en-US" dirty="0"/>
           </a:p>
@@ -1114,14 +1115,14 @@
           <a:p>
             <a:r>
               <a:rPr lang="en-US" dirty="0"/>
-              <a:t>Pull sequence (00_architecture.md), whiteboard step 1, demo step 8.
+              <a:t>Pull sequence (00_architecture.md), whiteboard step 1, demo step 9.
 "Polling is just another producer. The connector fetches pages from the real forum, and every payload goes through the same accept call as a webhook. The bookmark, the cursor, is saved only after the page's rows are on disk. The seed fixes the window to four days in January 2021, so the demo is repeatable."
 Detail: the cursor is saved as the later of the stored and the page cursor. For Discourse it moves only on the final page, because Discourse does not promise oldest-first order. It moves to the newest post minus a 60 s overlap, or to the window end if that is already in the past, so a quiet window still moves forward.
 Bounds on one sync: FI_PULL_DEADLINE_SECONDS (60) is checked before every upstream call; one response is capped at FI_HTTP_MAX_BYTES (2,000,000); redirects are not followed. One sync per source at a time: a second POST sync gets 409 and the scheduler skips that source.
 Overlap (failure_scenarios.md): "We would rather fetch a post twice than miss it: the bookmark is set a minute back and the unique key drops the repeats."
 If asked about rate limits: "The 429 becomes a transient error, the pull stops, saved pages stay saved, and the cursor has not moved past them, so the next run starts from the same place and repeats are dropped." Pull treats permanent and transient upstream errors the same way: stop, keep the cursor, retry next tick.
 Bounded window (debt ledger #6): at most 10 search pages, about 500 posts, per window, so with window_days=1 about 500 posts per day is the hard limit of Discourse search. A busier window raises an error and leaves the cursor where it was; lower window_days with PATCH /v1/sources/{id}. "A hard cap with a loud error beats silently skipping posts."
-A failing source shows on /health as a count, failing_sources, but does not turn /health red: only a dead or stuck worker or scheduler thread, or storage being down, does.</a:t>
+A failing source shows on /health as a count, failing_sources, but does not turn /health red. /health is 503 when either thread is dead, or the worker has made no progress for about 10 s, or storage is down; the scheduler is only checked for being alive.</a:t>
             </a:r>
             <a:endParaRPr lang="en-US" dirty="0"/>
           </a:p>
@@ -1309,7 +1310,8 @@
 Edits out of order: draw two arrows into one record with timestamps. "COALESCE(updated, created) must not be older. Equal is accepted, so replay works." That is the COALESCE rule, applied in Python today (merge in domain/models.py) inside BEGIN IMMEDIATE; the SQL ON CONFLICT … WHERE form is the Postgres upgrade (extensions recipe 2). Or: "A record only moves forward in time: an older edit that arrives late loses the timestamp check."
 Source deletes: "Only Discourse push payloads carry a delete today and it becomes a tombstone; Twitter and Intercom deletes go dead on purpose; pull-side Discourse deletes are invisible (README, not built)."
 Transformer bug last week: draw an arrow from raw_events back into the pipeline. "Fix the connector, bump its version, replay. No re-fetch, nothing lost." Bulk replay: POST /admin/raw-events/replay?source_id=...&amp;status=dead (or failed, or processed), up to 500 rows a call, only the caller's tenant. There is no time-window filter. Replay goes through the same version guard, so an equal version is accepted and the fixed output overwrites the record. Order does not matter: an older version is skipped and a delete, once applied, sticks.
-Demo step 7 shows replay: a malformed Playstore payload goes dead on the first try; replay resets attempts to 0 (the claim bumps them to 1) and it dies again because the payload really is bad. "That proves replay re-runs the stored payload. After a real connector fix, the same call brings it back."</a:t>
+The stored payload is the parsed JSON, not the raw bytes, so the signature cannot be re-checked from storage; a pulled Discourse post also carries the topic title we add.
+Demo step 8 shows replay: a malformed Playstore payload goes dead on the first try; replay resets attempts to 0 (the claim bumps them to 1) and it dies again because the payload really is bad. "That proves replay re-runs the stored payload. After a real connector fix, the same call brings it back."</a:t>
             </a:r>
             <a:endParaRPr lang="en-US" dirty="0"/>
           </a:p>
@@ -1400,9 +1402,9 @@
               <a:t>One-sentence answers from failure_scenarios.md (10k burst from whiteboard.md).
 DB down on push: "We never say yes before the row is on disk, so the sender gets a 503 and retries, and nothing we accepted is lost."
 Worker crash mid-event: "The lease runs out, the row is picked up again, and the upsert makes doing it twice the same as doing it once."
-Worker thread dies: "Health goes red (503) and the queue grows, but intake keeps working; restart the process and the backlog drains from disk." (Demo step 9: kill -9 with 20 pending, restart, they drain.) A failing pull source does not turn health red; it only raises the failing_sources count.
+Worker thread dies: "Health goes red (503) and the queue grows, but intake keeps working; restart the process and the backlog drains from disk." (Demo step 10: kill -9 with 20 pending, restart, they drain.) A failing pull source does not turn health red; it only raises the failing_sources count.
 Poison payload: "A payload that retrying cannot fix goes straight to the dead list with its reason, and waits there for a fix and a replay."
-10k burst: draw a thick arrow into the table. "Inserts are cheap, the 202 stays fast, the backlog drains at the worker's pace. SQLite is one writer. For Postgres: set FI_DATABASE_URL, add a driver, change three queries (claim, upsert, enqueue), add migrations." A body over 1 MiB is refused with 413.
+10k burst: draw a thick arrow into the table. "Inserts are cheap, the 202 stays fast, the backlog drains at the worker's pace. SQLite is one writer; past that comes Postgres (extensions recipe 2)." A body over 1 MiB is refused with 413.
 Noisy tenant: "Today it is first come, first served, so a burst delays others but loses nothing; the fix is a per-tenant rate limit and fair claiming." Enterpret's engineering blog names queue clogging and noisy neighbours as incidents and describes partitioning by tenant; that is the upgrade here too.
 Two workers: draw a second worker box with the same claim arrow. "Same single UPDATE. On Postgres I add SKIP LOCKED to that one query." Full line: "It is safe because the claim is a single statement and the upsert is idempotent. On the pull side the per-source lock is per process, so two processes can sync one source at once; the unique raw-event key drops the repeats, it only wastes calls." Under uvicorn --workers N every process reads the same environment, so to have exactly one consumer run separate processes.
 Rate-limited pull: "We stop, keep what we already saved, and try again next tick from the same bookmark; the repeats that causes are dropped by the unique key."
@@ -1494,11 +1496,11 @@
           <a:p>
             <a:r>
               <a:rPr lang="en-US" dirty="0"/>
-              <a:t>Connectors (whiteboard.md step 3): "A connector validates the payload with a Pydantic input model, then maps it to our record. Nothing else in the system knows which sources exist. Adding a source is five steps: (1) a SourceType value and its KIND_BY_SOURCE entry in domain/enums.py; (2) a metadata model in the SourceMetadata union in domain/metadata.py; (3) a connector file with its input model in connectors/; (4) its entry in CONNECTORS (and PULLERS if it pulls) in connectors/registry.py; (5) fixtures under tests/fixtures/&lt;type&gt;/. The contract test fails until all five exist." For Zendesk, a ticket is a conversation, so reuse that kind. tests/unit/connectors/test_registry.py and the every-source-has-a-metadata-model test fail first; then the contract tests run every fixture.
+              <a:t>Connectors (whiteboard.md step 3): "A connector validates the payload with a Pydantic input model, then maps it to our record. Nothing else in the system knows which sources exist. Adding a source is five steps: an enum value, a metadata model, a connector file, a registry entry and fixtures. The contract test fails until all five exist." (Full recipe: ADR-003 "How to add a new source".) For Zendesk, a ticket is a conversation, so reuse that kind. tests/unit/connectors/test_registry.py and the every-source-has-a-metadata-model test fail first; then the contract tests run every fixture.
 Worked example: the custom connector (connectors/custom.py) was added exactly this way, with one extra: its kind comes from each record's type, so it maps in KIND_BY_RECORD_TYPE instead of KIND_BY_SOURCE.
 Ports and adapters: "Services only import the ports. The same contract test runs against the SQLite adapter and the in-memory fake, so I know the fake behaves like the real thing. That keeps a storage swap inside the adapters: for Postgres, three queries change, not the services."
 Postgres (extensions.md recipe 2): the claim subquery gets with_for_update(skip_locked=True); upsert and enqueue move to INSERT ... ON CONFLICT; add Alembic migrations. Never say SKIP LOCKED runs today.
-Kafka: "Swap the adapter, and change the retry model: visibility timeout instead of leases, no per-message delay." A broker cannot answer "show me tenant X's dead events" or "give me event 42", so the realistic design keeps raw_events as the durable log and puts only event ids on the broker.
+Kafka: "Swap the adapter, and change the retry model. Kafka: consumer offsets instead of leases, and retry topics because there is no per-message delay. SQS would use a visibility timeout." A broker cannot answer "show me tenant X's dead events" or "give me event 42", so the realistic design keeps raw_events as the durable log and puts only event ids on the broker.
 Never say Kafka is a one-adapter swap without adding "and a different retry model".</a:t>
             </a:r>
             <a:endParaRPr lang="en-US" dirty="0"/>
@@ -2659,7 +2661,7 @@
       </p:sp>
       <p:sp>
         <p:nvSpPr>
-          <p:cNvPr id="3" name="next-head-137"/>
+          <p:cNvPr id="3" name="next-head-138"/>
           <p:cNvSpPr txBox="1"/>
           <p:nvPr/>
         </p:nvSpPr>
@@ -2698,7 +2700,7 @@
       </p:sp>
       <p:sp>
         <p:nvSpPr>
-          <p:cNvPr id="4" name="step-138"/>
+          <p:cNvPr id="4" name="step-139"/>
           <p:cNvSpPr txBox="1"/>
           <p:nvPr/>
         </p:nvSpPr>
@@ -2740,7 +2742,7 @@
       </p:sp>
       <p:sp>
         <p:nvSpPr>
-          <p:cNvPr id="5" name="next-item-139"/>
+          <p:cNvPr id="5" name="next-item-140"/>
           <p:cNvSpPr txBox="1"/>
           <p:nvPr/>
         </p:nvSpPr>
@@ -2774,7 +2776,7 @@
                 <a:ea typeface="Arial" pitchFamily="34" charset="-122"/>
                 <a:cs typeface="Arial" pitchFamily="34" charset="-120"/>
               </a:rPr>
-              <a:t>Lift the Discourse 10-page cap</a:t>
+              <a:t>Add migrations (Alembic)</a:t>
             </a:r>
             <a:endParaRPr lang="en-US" sz="1900" dirty="0"/>
           </a:p>
@@ -2788,7 +2790,7 @@
                   <a:schemeClr val="accent4"/>
                 </a:solidFill>
               </a:rPr>
-              <a:t>The only shortcut that can leave a source stuck failing until a person steps in.</a:t>
+              <a:t>The first schema change on real data turns “delete the db file” into data loss.</a:t>
             </a:r>
             <a:endParaRPr lang="en-US" sz="1900" dirty="0"/>
           </a:p>
@@ -2796,7 +2798,7 @@
       </p:sp>
       <p:sp>
         <p:nvSpPr>
-          <p:cNvPr id="6" name="step-140"/>
+          <p:cNvPr id="6" name="step-141"/>
           <p:cNvSpPr txBox="1"/>
           <p:nvPr/>
         </p:nvSpPr>
@@ -2838,7 +2840,7 @@
       </p:sp>
       <p:sp>
         <p:nvSpPr>
-          <p:cNvPr id="7" name="next-item-141"/>
+          <p:cNvPr id="7" name="next-item-142"/>
           <p:cNvSpPr txBox="1"/>
           <p:nvPr/>
         </p:nvSpPr>
@@ -2872,7 +2874,7 @@
                 <a:ea typeface="Arial" pitchFamily="34" charset="-122"/>
                 <a:cs typeface="Arial" pitchFamily="34" charset="-120"/>
               </a:rPr>
-              <a:t>Add migrations (Alembic)</a:t>
+              <a:t>Replace the shared bootstrap token</a:t>
             </a:r>
             <a:endParaRPr lang="en-US" sz="1900" dirty="0"/>
           </a:p>
@@ -2886,7 +2888,7 @@
                   <a:schemeClr val="accent4"/>
                 </a:solidFill>
               </a:rPr>
-              <a:t>The first schema change on real data turns “delete the db file” into data loss.</a:t>
+              <a:t>The main security gap: a leaked token creates tenants, with no audit trail.</a:t>
             </a:r>
             <a:endParaRPr lang="en-US" sz="1900" dirty="0"/>
           </a:p>
@@ -2894,7 +2896,7 @@
       </p:sp>
       <p:sp>
         <p:nvSpPr>
-          <p:cNvPr id="8" name="step-142"/>
+          <p:cNvPr id="8" name="step-143"/>
           <p:cNvSpPr txBox="1"/>
           <p:nvPr/>
         </p:nvSpPr>
@@ -2936,7 +2938,7 @@
       </p:sp>
       <p:sp>
         <p:nvSpPr>
-          <p:cNvPr id="9" name="next-item-143"/>
+          <p:cNvPr id="9" name="next-item-144"/>
           <p:cNvSpPr txBox="1"/>
           <p:nvPr/>
         </p:nvSpPr>
@@ -2970,7 +2972,7 @@
                 <a:ea typeface="Arial" pitchFamily="34" charset="-122"/>
                 <a:cs typeface="Arial" pitchFamily="34" charset="-120"/>
               </a:rPr>
-              <a:t>Replace the shared bootstrap token</a:t>
+              <a:t>Lift the Discourse 10-page cap</a:t>
             </a:r>
             <a:endParaRPr lang="en-US" sz="1900" dirty="0"/>
           </a:p>
@@ -2984,7 +2986,7 @@
                   <a:schemeClr val="accent4"/>
                 </a:solidFill>
               </a:rPr>
-              <a:t>The main security gap: a leaked token creates tenants, with no audit trail.</a:t>
+              <a:t>A busy forum stalls the source; today PATCH window_days lowers the window.</a:t>
             </a:r>
             <a:endParaRPr lang="en-US" sz="1900" dirty="0"/>
           </a:p>
@@ -2992,7 +2994,7 @@
       </p:sp>
       <p:sp>
         <p:nvSpPr>
-          <p:cNvPr id="10" name="demo-card-144"/>
+          <p:cNvPr id="10" name="demo-card-145"/>
           <p:cNvSpPr/>
           <p:nvPr/>
         </p:nvSpPr>
@@ -3019,7 +3021,7 @@
       </p:sp>
       <p:sp>
         <p:nvSpPr>
-          <p:cNvPr id="11" name="demo-head-145"/>
+          <p:cNvPr id="11" name="demo-head-146"/>
           <p:cNvSpPr txBox="1"/>
           <p:nvPr/>
         </p:nvSpPr>
@@ -3072,7 +3074,7 @@
       </p:sp>
       <p:sp>
         <p:nvSpPr>
-          <p:cNvPr id="12" name="demo-steps-146"/>
+          <p:cNvPr id="12" name="demo-steps-147"/>
           <p:cNvSpPr txBox="1"/>
           <p:nvPr/>
         </p:nvSpPr>
@@ -3201,6 +3203,25 @@
                 </a:solidFill>
               </a:rPr>
               <a:t>Custom webhook: one batch, three kinds</a:t>
+            </a:r>
+            <a:endParaRPr lang="en-US" sz="1550" dirty="0"/>
+          </a:p>
+          <a:p>
+            <a:pPr marL="342900" indent="-342900">
+              <a:spcAft>
+                <a:spcPts val="500"/>
+              </a:spcAft>
+              <a:buSzPct val="100000"/>
+              <a:buFont typeface="+mj-lt"/>
+              <a:buAutoNum type="arabicPeriod" startAt="1"/>
+            </a:pPr>
+            <a:r>
+              <a:rPr lang="en-US" sz="1550" dirty="0">
+                <a:solidFill>
+                  <a:schemeClr val="bg1"/>
+                </a:solidFill>
+              </a:rPr>
+              <a:t>Intercom and a tweet: one record shape</a:t>
             </a:r>
             <a:endParaRPr lang="en-US" sz="1550" dirty="0"/>
           </a:p>
@@ -3392,7 +3413,7 @@
       </p:sp>
       <p:sp>
         <p:nvSpPr>
-          <p:cNvPr id="3" name="stage-147"/>
+          <p:cNvPr id="3" name="stage-148"/>
           <p:cNvSpPr txBox="1"/>
           <p:nvPr/>
         </p:nvSpPr>
@@ -3467,7 +3488,7 @@
       </p:sp>
       <p:sp>
         <p:nvSpPr>
-          <p:cNvPr id="4" name="arrow-148"/>
+          <p:cNvPr id="4" name="arrow-149"/>
           <p:cNvSpPr/>
           <p:nvPr/>
         </p:nvSpPr>
@@ -3491,7 +3512,7 @@
       </p:sp>
       <p:sp>
         <p:nvSpPr>
-          <p:cNvPr id="5" name="stage-149"/>
+          <p:cNvPr id="5" name="stage-150"/>
           <p:cNvSpPr txBox="1"/>
           <p:nvPr/>
         </p:nvSpPr>
@@ -3566,7 +3587,7 @@
       </p:sp>
       <p:sp>
         <p:nvSpPr>
-          <p:cNvPr id="6" name="arrow-150"/>
+          <p:cNvPr id="6" name="arrow-151"/>
           <p:cNvSpPr/>
           <p:nvPr/>
         </p:nvSpPr>
@@ -3590,7 +3611,7 @@
       </p:sp>
       <p:sp>
         <p:nvSpPr>
-          <p:cNvPr id="7" name="stage-151"/>
+          <p:cNvPr id="7" name="stage-152"/>
           <p:cNvSpPr txBox="1"/>
           <p:nvPr/>
         </p:nvSpPr>
@@ -3665,7 +3686,7 @@
       </p:sp>
       <p:graphicFrame>
         <p:nvGraphicFramePr>
-          <p:cNvPr id="12" name="mapping-152"/>
+          <p:cNvPr id="12" name="mapping-153"/>
           <p:cNvGraphicFramePr>
             <a:graphicFrameLocks noGrp="1"/>
           </p:cNvGraphicFramePr>
@@ -3952,7 +3973,7 @@
                             <a:schemeClr val="tx1"/>
                           </a:solidFill>
                         </a:rPr>
-                        <a:t>“Accepted does not mean processed”</a:t>
+                        <a:t>A 200 does not guarantee the records appear</a:t>
                       </a:r>
                       <a:endParaRPr lang="en-US" sz="1250" dirty="0"/>
                     </a:p>
@@ -4013,7 +4034,7 @@
                             <a:schemeClr val="tx1"/>
                           </a:solidFill>
                         </a:rPr>
-                        <a:t>202 only after the raw row commits; the worker processes later</a:t>
+                        <a:t>202 only after the raw row commits; the worker processes later; a bad payload is listed dead</a:t>
                       </a:r>
                       <a:endParaRPr lang="en-US" sz="1250" dirty="0"/>
                     </a:p>
@@ -4076,7 +4097,7 @@
                             <a:schemeClr val="tx1"/>
                           </a:solidFill>
                         </a:rPr>
-                        <a:t>A repeated id is skipped by default; replace is opt-in</a:t>
+                        <a:t>A repeated id is skipped by default; replace is opt-in (via support)</a:t>
                       </a:r>
                       <a:endParaRPr lang="en-US" sz="1250" dirty="0"/>
                     </a:p>
@@ -4448,7 +4469,7 @@
                             <a:schemeClr val="tx1"/>
                           </a:solidFill>
                         </a:rPr>
-                        <a:t>PII obfuscated before ingestion; ClickHouse as the analytics projection</a:t>
+                        <a:t>Engineering blog: ClickHouse as the analytics projection</a:t>
                       </a:r>
                       <a:endParaRPr lang="en-US" sz="1250" dirty="0"/>
                     </a:p>
@@ -4509,7 +4530,7 @@
                             <a:schemeClr val="tx1"/>
                           </a:solidFill>
                         </a:rPr>
-                        <a:t>not built: the next stages after our records</a:t>
+                        <a:t>not built: a projection fed from our records</a:t>
                       </a:r>
                       <a:endParaRPr lang="en-US" sz="1250" dirty="0"/>
                     </a:p>
@@ -4563,7 +4584,7 @@
       </p:graphicFrame>
       <p:sp>
         <p:nvSpPr>
-          <p:cNvPr id="9" name="honesty-153"/>
+          <p:cNvPr id="9" name="honesty-154"/>
           <p:cNvSpPr txBox="1"/>
           <p:nvPr/>
         </p:nvSpPr>
@@ -7896,7 +7917,7 @@
           <p:nvPr/>
         </p:nvSpPr>
         <p:spPr>
-          <a:xfrm>
+          <a:xfrm flipH="1">
             <a:off x="2377440" y="3154680"/>
             <a:ext cx="365760" cy="0"/>
           </a:xfrm>
@@ -7915,7 +7936,43 @@
       </p:sp>
       <p:sp>
         <p:nvSpPr>
-          <p:cNvPr id="10" name="arrow-14"/>
+          <p:cNvPr id="10" name="fetch-label-14"/>
+          <p:cNvSpPr txBox="1"/>
+          <p:nvPr/>
+        </p:nvSpPr>
+        <p:spPr>
+          <a:xfrm>
+            <a:off x="2331720" y="2816352"/>
+            <a:ext cx="457200" cy="256032"/>
+          </a:xfrm>
+          <a:prstGeom prst="rect">
+            <a:avLst/>
+          </a:prstGeom>
+          <a:noFill/>
+          <a:ln/>
+        </p:spPr>
+        <p:txBody>
+          <a:bodyPr wrap="square" lIns="0" tIns="0" rIns="0" bIns="0" rtlCol="0" anchor="ctr"/>
+          <a:lstStyle/>
+          <a:p>
+            <a:pPr algn="ctr" indent="0" marL="0">
+              <a:buNone/>
+            </a:pPr>
+            <a:r>
+              <a:rPr lang="en-US" sz="1000" b="1" dirty="0">
+                <a:solidFill>
+                  <a:schemeClr val="tx2"/>
+                </a:solidFill>
+              </a:rPr>
+              <a:t>fetch</a:t>
+            </a:r>
+            <a:endParaRPr lang="en-US" sz="1000" dirty="0"/>
+          </a:p>
+        </p:txBody>
+      </p:sp>
+      <p:sp>
+        <p:nvSpPr>
+          <p:cNvPr id="11" name="arrow-15"/>
           <p:cNvSpPr/>
           <p:nvPr/>
         </p:nvSpPr>
@@ -7939,7 +7996,7 @@
       </p:sp>
       <p:sp>
         <p:nvSpPr>
-          <p:cNvPr id="11" name="arrow-15"/>
+          <p:cNvPr id="12" name="arrow-16"/>
           <p:cNvSpPr/>
           <p:nvPr/>
         </p:nvSpPr>
@@ -7963,7 +8020,7 @@
       </p:sp>
       <p:sp>
         <p:nvSpPr>
-          <p:cNvPr id="12" name="arrow-16"/>
+          <p:cNvPr id="13" name="arrow-17"/>
           <p:cNvSpPr/>
           <p:nvPr/>
         </p:nvSpPr>
@@ -7987,7 +8044,7 @@
       </p:sp>
       <p:sp>
         <p:nvSpPr>
-          <p:cNvPr id="13" name="worker-17"/>
+          <p:cNvPr id="14" name="worker-18"/>
           <p:cNvSpPr txBox="1"/>
           <p:nvPr/>
         </p:nvSpPr>
@@ -8065,7 +8122,7 @@
       </p:sp>
       <p:sp>
         <p:nvSpPr>
-          <p:cNvPr id="14" name="pipeline-18"/>
+          <p:cNvPr id="15" name="pipeline-19"/>
           <p:cNvSpPr txBox="1"/>
           <p:nvPr/>
         </p:nvSpPr>
@@ -8143,7 +8200,7 @@
       </p:sp>
       <p:sp>
         <p:nvSpPr>
-          <p:cNvPr id="15" name="upsert-19"/>
+          <p:cNvPr id="16" name="upsert-20"/>
           <p:cNvSpPr txBox="1"/>
           <p:nvPr/>
         </p:nvSpPr>
@@ -8221,7 +8278,7 @@
       </p:sp>
       <p:sp>
         <p:nvSpPr>
-          <p:cNvPr id="16" name="query-20"/>
+          <p:cNvPr id="17" name="query-21"/>
           <p:cNvSpPr txBox="1"/>
           <p:nvPr/>
         </p:nvSpPr>
@@ -8299,7 +8356,7 @@
       </p:sp>
       <p:sp>
         <p:nvSpPr>
-          <p:cNvPr id="17" name="arrow-21"/>
+          <p:cNvPr id="18" name="arrow-22"/>
           <p:cNvSpPr/>
           <p:nvPr/>
         </p:nvSpPr>
@@ -8323,7 +8380,7 @@
       </p:sp>
       <p:sp>
         <p:nvSpPr>
-          <p:cNvPr id="18" name="arrow-22"/>
+          <p:cNvPr id="19" name="arrow-23"/>
           <p:cNvSpPr/>
           <p:nvPr/>
         </p:nvSpPr>
@@ -8347,7 +8404,7 @@
       </p:sp>
       <p:sp>
         <p:nvSpPr>
-          <p:cNvPr id="19" name="arrow-23"/>
+          <p:cNvPr id="20" name="arrow-24"/>
           <p:cNvSpPr/>
           <p:nvPr/>
         </p:nvSpPr>
@@ -8371,7 +8428,7 @@
       </p:sp>
       <p:sp>
         <p:nvSpPr>
-          <p:cNvPr id="20" name="arrow-24"/>
+          <p:cNvPr id="21" name="arrow-25"/>
           <p:cNvSpPr/>
           <p:nvPr/>
         </p:nvSpPr>
@@ -8395,7 +8452,7 @@
       </p:sp>
       <p:sp>
         <p:nvSpPr>
-          <p:cNvPr id="21" name="arrow-25"/>
+          <p:cNvPr id="22" name="arrow-26"/>
           <p:cNvSpPr/>
           <p:nvPr/>
         </p:nvSpPr>
@@ -8419,7 +8476,7 @@
       </p:sp>
       <p:sp>
         <p:nvSpPr>
-          <p:cNvPr id="22" name="claim-label-26"/>
+          <p:cNvPr id="23" name="claim-label-27"/>
           <p:cNvSpPr txBox="1"/>
           <p:nvPr/>
         </p:nvSpPr>
@@ -8455,7 +8512,7 @@
       </p:sp>
       <p:sp>
         <p:nvSpPr>
-          <p:cNvPr id="23" name="mark-label-27"/>
+          <p:cNvPr id="24" name="mark-label-28"/>
           <p:cNvSpPr txBox="1"/>
           <p:nvPr/>
         </p:nvSpPr>
@@ -8491,7 +8548,7 @@
       </p:sp>
       <p:sp>
         <p:nvSpPr>
-          <p:cNvPr id="24" name="ops-28"/>
+          <p:cNvPr id="25" name="ops-29"/>
           <p:cNvSpPr txBox="1"/>
           <p:nvPr/>
         </p:nvSpPr>
@@ -8657,7 +8714,7 @@
       </p:sp>
       <p:sp>
         <p:nvSpPr>
-          <p:cNvPr id="3" name="card-29"/>
+          <p:cNvPr id="3" name="card-30"/>
           <p:cNvSpPr/>
           <p:nvPr/>
         </p:nvSpPr>
@@ -8684,7 +8741,7 @@
       </p:sp>
       <p:sp>
         <p:nvSpPr>
-          <p:cNvPr id="4" name="step-30"/>
+          <p:cNvPr id="4" name="step-31"/>
           <p:cNvSpPr txBox="1"/>
           <p:nvPr/>
         </p:nvSpPr>
@@ -8726,7 +8783,7 @@
       </p:sp>
       <p:sp>
         <p:nvSpPr>
-          <p:cNvPr id="5" name="card-title-31"/>
+          <p:cNvPr id="5" name="card-title-32"/>
           <p:cNvSpPr txBox="1"/>
           <p:nvPr/>
         </p:nvSpPr>
@@ -8765,7 +8822,7 @@
       </p:sp>
       <p:sp>
         <p:nvSpPr>
-          <p:cNvPr id="6" name="card-body-32"/>
+          <p:cNvPr id="6" name="card-body-33"/>
           <p:cNvSpPr txBox="1"/>
           <p:nvPr/>
         </p:nvSpPr>
@@ -8859,7 +8916,7 @@
       </p:sp>
       <p:sp>
         <p:nvSpPr>
-          <p:cNvPr id="7" name="card-path-33"/>
+          <p:cNvPr id="7" name="card-path-34"/>
           <p:cNvSpPr txBox="1"/>
           <p:nvPr/>
         </p:nvSpPr>
@@ -8898,7 +8955,7 @@
       </p:sp>
       <p:sp>
         <p:nvSpPr>
-          <p:cNvPr id="8" name="arrow-34"/>
+          <p:cNvPr id="8" name="arrow-35"/>
           <p:cNvSpPr/>
           <p:nvPr/>
         </p:nvSpPr>
@@ -8922,7 +8979,7 @@
       </p:sp>
       <p:sp>
         <p:nvSpPr>
-          <p:cNvPr id="9" name="card-35"/>
+          <p:cNvPr id="9" name="card-36"/>
           <p:cNvSpPr/>
           <p:nvPr/>
         </p:nvSpPr>
@@ -8949,7 +9006,7 @@
       </p:sp>
       <p:sp>
         <p:nvSpPr>
-          <p:cNvPr id="10" name="step-36"/>
+          <p:cNvPr id="10" name="step-37"/>
           <p:cNvSpPr txBox="1"/>
           <p:nvPr/>
         </p:nvSpPr>
@@ -8991,7 +9048,7 @@
       </p:sp>
       <p:sp>
         <p:nvSpPr>
-          <p:cNvPr id="11" name="card-title-37"/>
+          <p:cNvPr id="11" name="card-title-38"/>
           <p:cNvSpPr txBox="1"/>
           <p:nvPr/>
         </p:nvSpPr>
@@ -9030,7 +9087,7 @@
       </p:sp>
       <p:sp>
         <p:nvSpPr>
-          <p:cNvPr id="12" name="card-body-38"/>
+          <p:cNvPr id="12" name="card-body-39"/>
           <p:cNvSpPr txBox="1"/>
           <p:nvPr/>
         </p:nvSpPr>
@@ -9124,7 +9181,7 @@
       </p:sp>
       <p:sp>
         <p:nvSpPr>
-          <p:cNvPr id="13" name="card-path-39"/>
+          <p:cNvPr id="13" name="card-path-40"/>
           <p:cNvSpPr txBox="1"/>
           <p:nvPr/>
         </p:nvSpPr>
@@ -9163,7 +9220,7 @@
       </p:sp>
       <p:sp>
         <p:nvSpPr>
-          <p:cNvPr id="14" name="arrow-40"/>
+          <p:cNvPr id="14" name="arrow-41"/>
           <p:cNvSpPr/>
           <p:nvPr/>
         </p:nvSpPr>
@@ -9187,7 +9244,7 @@
       </p:sp>
       <p:sp>
         <p:nvSpPr>
-          <p:cNvPr id="15" name="card-41"/>
+          <p:cNvPr id="15" name="card-42"/>
           <p:cNvSpPr/>
           <p:nvPr/>
         </p:nvSpPr>
@@ -9214,7 +9271,7 @@
       </p:sp>
       <p:sp>
         <p:nvSpPr>
-          <p:cNvPr id="16" name="step-42"/>
+          <p:cNvPr id="16" name="step-43"/>
           <p:cNvSpPr txBox="1"/>
           <p:nvPr/>
         </p:nvSpPr>
@@ -9256,7 +9313,7 @@
       </p:sp>
       <p:sp>
         <p:nvSpPr>
-          <p:cNvPr id="17" name="card-title-43"/>
+          <p:cNvPr id="17" name="card-title-44"/>
           <p:cNvSpPr txBox="1"/>
           <p:nvPr/>
         </p:nvSpPr>
@@ -9295,7 +9352,7 @@
       </p:sp>
       <p:sp>
         <p:nvSpPr>
-          <p:cNvPr id="18" name="card-body-44"/>
+          <p:cNvPr id="18" name="card-body-45"/>
           <p:cNvSpPr txBox="1"/>
           <p:nvPr/>
         </p:nvSpPr>
@@ -9371,7 +9428,7 @@
       </p:sp>
       <p:sp>
         <p:nvSpPr>
-          <p:cNvPr id="19" name="card-path-45"/>
+          <p:cNvPr id="19" name="card-path-46"/>
           <p:cNvSpPr txBox="1"/>
           <p:nvPr/>
         </p:nvSpPr>
@@ -9410,7 +9467,7 @@
       </p:sp>
       <p:sp>
         <p:nvSpPr>
-          <p:cNvPr id="20" name="card-46"/>
+          <p:cNvPr id="20" name="card-47"/>
           <p:cNvSpPr/>
           <p:nvPr/>
         </p:nvSpPr>
@@ -9437,7 +9494,7 @@
       </p:sp>
       <p:sp>
         <p:nvSpPr>
-          <p:cNvPr id="21" name="step-47"/>
+          <p:cNvPr id="21" name="step-48"/>
           <p:cNvSpPr txBox="1"/>
           <p:nvPr/>
         </p:nvSpPr>
@@ -9479,7 +9536,7 @@
       </p:sp>
       <p:sp>
         <p:nvSpPr>
-          <p:cNvPr id="22" name="card-title-48"/>
+          <p:cNvPr id="22" name="card-title-49"/>
           <p:cNvSpPr txBox="1"/>
           <p:nvPr/>
         </p:nvSpPr>
@@ -9518,7 +9575,7 @@
       </p:sp>
       <p:sp>
         <p:nvSpPr>
-          <p:cNvPr id="23" name="card-body-49"/>
+          <p:cNvPr id="23" name="card-body-50"/>
           <p:cNvSpPr txBox="1"/>
           <p:nvPr/>
         </p:nvSpPr>
@@ -9594,7 +9651,7 @@
       </p:sp>
       <p:sp>
         <p:nvSpPr>
-          <p:cNvPr id="24" name="card-path-50"/>
+          <p:cNvPr id="24" name="card-path-51"/>
           <p:cNvSpPr txBox="1"/>
           <p:nvPr/>
         </p:nvSpPr>
@@ -9633,7 +9690,7 @@
       </p:sp>
       <p:sp>
         <p:nvSpPr>
-          <p:cNvPr id="25" name="arrow-51"/>
+          <p:cNvPr id="25" name="arrow-52"/>
           <p:cNvSpPr/>
           <p:nvPr/>
         </p:nvSpPr>
@@ -9657,7 +9714,7 @@
       </p:sp>
       <p:sp>
         <p:nvSpPr>
-          <p:cNvPr id="26" name="card-52"/>
+          <p:cNvPr id="26" name="card-53"/>
           <p:cNvSpPr/>
           <p:nvPr/>
         </p:nvSpPr>
@@ -9684,7 +9741,7 @@
       </p:sp>
       <p:sp>
         <p:nvSpPr>
-          <p:cNvPr id="27" name="step-53"/>
+          <p:cNvPr id="27" name="step-54"/>
           <p:cNvSpPr txBox="1"/>
           <p:nvPr/>
         </p:nvSpPr>
@@ -9726,7 +9783,7 @@
       </p:sp>
       <p:sp>
         <p:nvSpPr>
-          <p:cNvPr id="28" name="card-title-54"/>
+          <p:cNvPr id="28" name="card-title-55"/>
           <p:cNvSpPr txBox="1"/>
           <p:nvPr/>
         </p:nvSpPr>
@@ -9765,7 +9822,7 @@
       </p:sp>
       <p:sp>
         <p:nvSpPr>
-          <p:cNvPr id="29" name="card-body-55"/>
+          <p:cNvPr id="29" name="card-body-56"/>
           <p:cNvSpPr txBox="1"/>
           <p:nvPr/>
         </p:nvSpPr>
@@ -9841,7 +9898,7 @@
       </p:sp>
       <p:sp>
         <p:nvSpPr>
-          <p:cNvPr id="30" name="card-path-56"/>
+          <p:cNvPr id="30" name="card-path-57"/>
           <p:cNvSpPr txBox="1"/>
           <p:nvPr/>
         </p:nvSpPr>
@@ -9880,7 +9937,7 @@
       </p:sp>
       <p:sp>
         <p:nvSpPr>
-          <p:cNvPr id="31" name="arrow-57"/>
+          <p:cNvPr id="31" name="arrow-58"/>
           <p:cNvSpPr/>
           <p:nvPr/>
         </p:nvSpPr>
@@ -9904,7 +9961,7 @@
       </p:sp>
       <p:sp>
         <p:nvSpPr>
-          <p:cNvPr id="32" name="card-58"/>
+          <p:cNvPr id="32" name="card-59"/>
           <p:cNvSpPr/>
           <p:nvPr/>
         </p:nvSpPr>
@@ -9931,7 +9988,7 @@
       </p:sp>
       <p:sp>
         <p:nvSpPr>
-          <p:cNvPr id="33" name="step-59"/>
+          <p:cNvPr id="33" name="step-60"/>
           <p:cNvSpPr txBox="1"/>
           <p:nvPr/>
         </p:nvSpPr>
@@ -9973,7 +10030,7 @@
       </p:sp>
       <p:sp>
         <p:nvSpPr>
-          <p:cNvPr id="34" name="card-title-60"/>
+          <p:cNvPr id="34" name="card-title-61"/>
           <p:cNvSpPr txBox="1"/>
           <p:nvPr/>
         </p:nvSpPr>
@@ -10012,7 +10069,7 @@
       </p:sp>
       <p:sp>
         <p:nvSpPr>
-          <p:cNvPr id="35" name="card-body-61"/>
+          <p:cNvPr id="35" name="card-body-62"/>
           <p:cNvSpPr txBox="1"/>
           <p:nvPr/>
         </p:nvSpPr>
@@ -10088,7 +10145,7 @@
       </p:sp>
       <p:sp>
         <p:nvSpPr>
-          <p:cNvPr id="36" name="card-path-62"/>
+          <p:cNvPr id="36" name="card-path-63"/>
           <p:cNvSpPr txBox="1"/>
           <p:nvPr/>
         </p:nvSpPr>
@@ -10235,7 +10292,7 @@
       </p:sp>
       <p:sp>
         <p:nvSpPr>
-          <p:cNvPr id="3" name="pull-flow-63"/>
+          <p:cNvPr id="3" name="pull-flow-64"/>
           <p:cNvSpPr txBox="1"/>
           <p:nvPr/>
         </p:nvSpPr>
@@ -10299,7 +10356,7 @@
       </p:sp>
       <p:sp>
         <p:nvSpPr>
-          <p:cNvPr id="4" name="arrow-64"/>
+          <p:cNvPr id="4" name="arrow-65"/>
           <p:cNvSpPr/>
           <p:nvPr/>
         </p:nvSpPr>
@@ -10323,7 +10380,7 @@
       </p:sp>
       <p:sp>
         <p:nvSpPr>
-          <p:cNvPr id="5" name="pull-flow-65"/>
+          <p:cNvPr id="5" name="pull-flow-66"/>
           <p:cNvSpPr txBox="1"/>
           <p:nvPr/>
         </p:nvSpPr>
@@ -10387,7 +10444,7 @@
       </p:sp>
       <p:sp>
         <p:nvSpPr>
-          <p:cNvPr id="6" name="arrow-66"/>
+          <p:cNvPr id="6" name="arrow-67"/>
           <p:cNvSpPr/>
           <p:nvPr/>
         </p:nvSpPr>
@@ -10411,7 +10468,7 @@
       </p:sp>
       <p:sp>
         <p:nvSpPr>
-          <p:cNvPr id="7" name="pull-flow-67"/>
+          <p:cNvPr id="7" name="pull-flow-68"/>
           <p:cNvSpPr txBox="1"/>
           <p:nvPr/>
         </p:nvSpPr>
@@ -10475,7 +10532,7 @@
       </p:sp>
       <p:sp>
         <p:nvSpPr>
-          <p:cNvPr id="8" name="arrow-68"/>
+          <p:cNvPr id="8" name="arrow-69"/>
           <p:cNvSpPr/>
           <p:nvPr/>
         </p:nvSpPr>
@@ -10499,7 +10556,7 @@
       </p:sp>
       <p:sp>
         <p:nvSpPr>
-          <p:cNvPr id="9" name="pull-flow-69"/>
+          <p:cNvPr id="9" name="pull-flow-70"/>
           <p:cNvSpPr txBox="1"/>
           <p:nvPr/>
         </p:nvSpPr>
@@ -10560,7 +10617,7 @@
       </p:sp>
       <p:sp>
         <p:nvSpPr>
-          <p:cNvPr id="10" name="arrow-70"/>
+          <p:cNvPr id="10" name="arrow-71"/>
           <p:cNvSpPr/>
           <p:nvPr/>
         </p:nvSpPr>
@@ -10584,7 +10641,7 @@
       </p:sp>
       <p:sp>
         <p:nvSpPr>
-          <p:cNvPr id="11" name="pull-flow-71"/>
+          <p:cNvPr id="11" name="pull-flow-72"/>
           <p:cNvSpPr txBox="1"/>
           <p:nvPr/>
         </p:nvSpPr>
@@ -10648,7 +10705,7 @@
       </p:sp>
       <p:sp>
         <p:nvSpPr>
-          <p:cNvPr id="12" name="pull-row-72"/>
+          <p:cNvPr id="12" name="pull-row-73"/>
           <p:cNvSpPr/>
           <p:nvPr/>
         </p:nvSpPr>
@@ -10675,7 +10732,7 @@
       </p:sp>
       <p:sp>
         <p:nvSpPr>
-          <p:cNvPr id="13" name="step-73"/>
+          <p:cNvPr id="13" name="step-74"/>
           <p:cNvSpPr txBox="1"/>
           <p:nvPr/>
         </p:nvSpPr>
@@ -10717,7 +10774,7 @@
       </p:sp>
       <p:sp>
         <p:nvSpPr>
-          <p:cNvPr id="14" name="pull-row-title-74"/>
+          <p:cNvPr id="14" name="pull-row-title-75"/>
           <p:cNvSpPr txBox="1"/>
           <p:nvPr/>
         </p:nvSpPr>
@@ -10756,7 +10813,7 @@
       </p:sp>
       <p:sp>
         <p:nvSpPr>
-          <p:cNvPr id="15" name="pull-row-body-75"/>
+          <p:cNvPr id="15" name="pull-row-body-76"/>
           <p:cNvSpPr txBox="1"/>
           <p:nvPr/>
         </p:nvSpPr>
@@ -10792,7 +10849,7 @@
       </p:sp>
       <p:sp>
         <p:nvSpPr>
-          <p:cNvPr id="16" name="pull-row-76"/>
+          <p:cNvPr id="16" name="pull-row-77"/>
           <p:cNvSpPr/>
           <p:nvPr/>
         </p:nvSpPr>
@@ -10819,7 +10876,7 @@
       </p:sp>
       <p:sp>
         <p:nvSpPr>
-          <p:cNvPr id="17" name="step-77"/>
+          <p:cNvPr id="17" name="step-78"/>
           <p:cNvSpPr txBox="1"/>
           <p:nvPr/>
         </p:nvSpPr>
@@ -10861,7 +10918,7 @@
       </p:sp>
       <p:sp>
         <p:nvSpPr>
-          <p:cNvPr id="18" name="pull-row-title-78"/>
+          <p:cNvPr id="18" name="pull-row-title-79"/>
           <p:cNvSpPr txBox="1"/>
           <p:nvPr/>
         </p:nvSpPr>
@@ -10900,7 +10957,7 @@
       </p:sp>
       <p:sp>
         <p:nvSpPr>
-          <p:cNvPr id="19" name="pull-row-body-79"/>
+          <p:cNvPr id="19" name="pull-row-body-80"/>
           <p:cNvSpPr txBox="1"/>
           <p:nvPr/>
         </p:nvSpPr>
@@ -10936,7 +10993,7 @@
       </p:sp>
       <p:sp>
         <p:nvSpPr>
-          <p:cNvPr id="20" name="pull-row-80"/>
+          <p:cNvPr id="20" name="pull-row-81"/>
           <p:cNvSpPr/>
           <p:nvPr/>
         </p:nvSpPr>
@@ -10963,7 +11020,7 @@
       </p:sp>
       <p:sp>
         <p:nvSpPr>
-          <p:cNvPr id="21" name="step-81"/>
+          <p:cNvPr id="21" name="step-82"/>
           <p:cNvSpPr txBox="1"/>
           <p:nvPr/>
         </p:nvSpPr>
@@ -11005,7 +11062,7 @@
       </p:sp>
       <p:sp>
         <p:nvSpPr>
-          <p:cNvPr id="22" name="pull-row-title-82"/>
+          <p:cNvPr id="22" name="pull-row-title-83"/>
           <p:cNvSpPr txBox="1"/>
           <p:nvPr/>
         </p:nvSpPr>
@@ -11044,7 +11101,7 @@
       </p:sp>
       <p:sp>
         <p:nvSpPr>
-          <p:cNvPr id="23" name="pull-row-body-83"/>
+          <p:cNvPr id="23" name="pull-row-body-84"/>
           <p:cNvSpPr txBox="1"/>
           <p:nvPr/>
         </p:nvSpPr>
@@ -11080,7 +11137,7 @@
       </p:sp>
       <p:sp>
         <p:nvSpPr>
-          <p:cNvPr id="24" name="pull-row-84"/>
+          <p:cNvPr id="24" name="pull-row-85"/>
           <p:cNvSpPr/>
           <p:nvPr/>
         </p:nvSpPr>
@@ -11107,7 +11164,7 @@
       </p:sp>
       <p:sp>
         <p:nvSpPr>
-          <p:cNvPr id="25" name="step-85"/>
+          <p:cNvPr id="25" name="step-86"/>
           <p:cNvSpPr txBox="1"/>
           <p:nvPr/>
         </p:nvSpPr>
@@ -11149,7 +11206,7 @@
       </p:sp>
       <p:sp>
         <p:nvSpPr>
-          <p:cNvPr id="26" name="pull-row-title-86"/>
+          <p:cNvPr id="26" name="pull-row-title-87"/>
           <p:cNvSpPr txBox="1"/>
           <p:nvPr/>
         </p:nvSpPr>
@@ -11188,7 +11245,7 @@
       </p:sp>
       <p:sp>
         <p:nvSpPr>
-          <p:cNvPr id="27" name="pull-row-body-87"/>
+          <p:cNvPr id="27" name="pull-row-body-88"/>
           <p:cNvSpPr txBox="1"/>
           <p:nvPr/>
         </p:nvSpPr>
@@ -11332,7 +11389,7 @@
       </p:sp>
       <p:sp>
         <p:nvSpPr>
-          <p:cNvPr id="3" name="source-model-88"/>
+          <p:cNvPr id="3" name="source-model-89"/>
           <p:cNvSpPr txBox="1"/>
           <p:nvPr/>
         </p:nvSpPr>
@@ -11503,7 +11560,7 @@
       </p:sp>
       <p:sp>
         <p:nvSpPr>
-          <p:cNvPr id="4" name="records-card-89"/>
+          <p:cNvPr id="4" name="records-card-90"/>
           <p:cNvSpPr/>
           <p:nvPr/>
         </p:nvSpPr>
@@ -11530,7 +11587,7 @@
       </p:sp>
       <p:sp>
         <p:nvSpPr>
-          <p:cNvPr id="5" name="records-title-90"/>
+          <p:cNvPr id="5" name="records-title-91"/>
           <p:cNvSpPr txBox="1"/>
           <p:nvPr/>
         </p:nvSpPr>
@@ -11580,7 +11637,7 @@
       </p:sp>
       <p:sp>
         <p:nvSpPr>
-          <p:cNvPr id="6" name="cols-a-91"/>
+          <p:cNvPr id="6" name="cols-a-92"/>
           <p:cNvSpPr txBox="1"/>
           <p:nvPr/>
         </p:nvSpPr>
@@ -11742,7 +11799,7 @@
       </p:sp>
       <p:sp>
         <p:nvSpPr>
-          <p:cNvPr id="7" name="cols-b-92"/>
+          <p:cNvPr id="7" name="cols-b-93"/>
           <p:cNvSpPr txBox="1"/>
           <p:nvPr/>
         </p:nvSpPr>
@@ -11904,7 +11961,7 @@
       </p:sp>
       <p:sp>
         <p:nvSpPr>
-          <p:cNvPr id="8" name="metadata-93"/>
+          <p:cNvPr id="8" name="metadata-94"/>
           <p:cNvSpPr txBox="1"/>
           <p:nvPr/>
         </p:nvSpPr>
@@ -12091,7 +12148,7 @@
       </p:sp>
       <p:sp>
         <p:nvSpPr>
-          <p:cNvPr id="9" name="keys-94"/>
+          <p:cNvPr id="9" name="keys-95"/>
           <p:cNvSpPr txBox="1"/>
           <p:nvPr/>
         </p:nvSpPr>
@@ -12189,7 +12246,7 @@
       </p:sp>
       <p:sp>
         <p:nvSpPr>
-          <p:cNvPr id="10" name="tombstones-95"/>
+          <p:cNvPr id="10" name="tombstones-96"/>
           <p:cNvSpPr txBox="1"/>
           <p:nvPr/>
         </p:nvSpPr>
@@ -12372,7 +12429,7 @@
       </p:sp>
       <p:sp>
         <p:nvSpPr>
-          <p:cNvPr id="3" name="idem-card-96"/>
+          <p:cNvPr id="3" name="idem-card-97"/>
           <p:cNvSpPr/>
           <p:nvPr/>
         </p:nvSpPr>
@@ -12399,7 +12456,7 @@
       </p:sp>
       <p:sp>
         <p:nvSpPr>
-          <p:cNvPr id="4" name="callout-bg-97"/>
+          <p:cNvPr id="4" name="callout-bg-98"/>
           <p:cNvSpPr/>
           <p:nvPr/>
         </p:nvSpPr>
@@ -12426,7 +12483,7 @@
       </p:sp>
       <p:sp>
         <p:nvSpPr>
-          <p:cNvPr id="5" name="callout-98"/>
+          <p:cNvPr id="5" name="callout-99"/>
           <p:cNvSpPr txBox="1"/>
           <p:nvPr/>
         </p:nvSpPr>
@@ -12465,7 +12522,7 @@
       </p:sp>
       <p:sp>
         <p:nvSpPr>
-          <p:cNvPr id="6" name="callout-label-99"/>
+          <p:cNvPr id="6" name="callout-label-100"/>
           <p:cNvSpPr txBox="1"/>
           <p:nvPr/>
         </p:nvSpPr>
@@ -12501,7 +12558,7 @@
       </p:sp>
       <p:sp>
         <p:nvSpPr>
-          <p:cNvPr id="7" name="idem-head-100"/>
+          <p:cNvPr id="7" name="idem-head-101"/>
           <p:cNvSpPr txBox="1"/>
           <p:nvPr/>
         </p:nvSpPr>
@@ -12540,7 +12597,7 @@
       </p:sp>
       <p:sp>
         <p:nvSpPr>
-          <p:cNvPr id="8" name="idem-body-101"/>
+          <p:cNvPr id="8" name="idem-body-102"/>
           <p:cNvSpPr txBox="1"/>
           <p:nvPr/>
         </p:nvSpPr>
@@ -12616,7 +12673,7 @@
       </p:sp>
       <p:sp>
         <p:nvSpPr>
-          <p:cNvPr id="9" name="idem-card-102"/>
+          <p:cNvPr id="9" name="idem-card-103"/>
           <p:cNvSpPr/>
           <p:nvPr/>
         </p:nvSpPr>
@@ -12643,7 +12700,7 @@
       </p:sp>
       <p:sp>
         <p:nvSpPr>
-          <p:cNvPr id="10" name="callout-bg-103"/>
+          <p:cNvPr id="10" name="callout-bg-104"/>
           <p:cNvSpPr/>
           <p:nvPr/>
         </p:nvSpPr>
@@ -12670,7 +12727,7 @@
       </p:sp>
       <p:sp>
         <p:nvSpPr>
-          <p:cNvPr id="11" name="callout-104"/>
+          <p:cNvPr id="11" name="callout-105"/>
           <p:cNvSpPr txBox="1"/>
           <p:nvPr/>
         </p:nvSpPr>
@@ -12709,7 +12766,7 @@
       </p:sp>
       <p:sp>
         <p:nvSpPr>
-          <p:cNvPr id="12" name="callout-label-105"/>
+          <p:cNvPr id="12" name="callout-label-106"/>
           <p:cNvSpPr txBox="1"/>
           <p:nvPr/>
         </p:nvSpPr>
@@ -12745,7 +12802,7 @@
       </p:sp>
       <p:sp>
         <p:nvSpPr>
-          <p:cNvPr id="13" name="idem-head-106"/>
+          <p:cNvPr id="13" name="idem-head-107"/>
           <p:cNvSpPr txBox="1"/>
           <p:nvPr/>
         </p:nvSpPr>
@@ -12784,7 +12841,7 @@
       </p:sp>
       <p:sp>
         <p:nvSpPr>
-          <p:cNvPr id="14" name="idem-body-107"/>
+          <p:cNvPr id="14" name="idem-body-108"/>
           <p:cNvSpPr txBox="1"/>
           <p:nvPr/>
         </p:nvSpPr>
@@ -12860,7 +12917,7 @@
       </p:sp>
       <p:sp>
         <p:nvSpPr>
-          <p:cNvPr id="15" name="idem-card-108"/>
+          <p:cNvPr id="15" name="idem-card-109"/>
           <p:cNvSpPr/>
           <p:nvPr/>
         </p:nvSpPr>
@@ -12887,7 +12944,7 @@
       </p:sp>
       <p:sp>
         <p:nvSpPr>
-          <p:cNvPr id="16" name="callout-bg-109"/>
+          <p:cNvPr id="16" name="callout-bg-110"/>
           <p:cNvSpPr/>
           <p:nvPr/>
         </p:nvSpPr>
@@ -12914,7 +12971,7 @@
       </p:sp>
       <p:sp>
         <p:nvSpPr>
-          <p:cNvPr id="17" name="callout-110"/>
+          <p:cNvPr id="17" name="callout-111"/>
           <p:cNvSpPr txBox="1"/>
           <p:nvPr/>
         </p:nvSpPr>
@@ -12953,7 +13010,7 @@
       </p:sp>
       <p:sp>
         <p:nvSpPr>
-          <p:cNvPr id="18" name="callout-label-111"/>
+          <p:cNvPr id="18" name="callout-label-112"/>
           <p:cNvSpPr txBox="1"/>
           <p:nvPr/>
         </p:nvSpPr>
@@ -12989,7 +13046,7 @@
       </p:sp>
       <p:sp>
         <p:nvSpPr>
-          <p:cNvPr id="19" name="idem-head-112"/>
+          <p:cNvPr id="19" name="idem-head-113"/>
           <p:cNvSpPr txBox="1"/>
           <p:nvPr/>
         </p:nvSpPr>
@@ -13028,7 +13085,7 @@
       </p:sp>
       <p:sp>
         <p:nvSpPr>
-          <p:cNvPr id="20" name="idem-body-113"/>
+          <p:cNvPr id="20" name="idem-body-114"/>
           <p:cNvSpPr txBox="1"/>
           <p:nvPr/>
         </p:nvSpPr>
@@ -13060,7 +13117,7 @@
                   <a:schemeClr val="tx1"/>
                 </a:solidFill>
               </a:rPr>
-              <a:t>Raw payloads are kept verbatim.</a:t>
+              <a:t>The parsed JSON payload is saved before we answer.</a:t>
             </a:r>
             <a:endParaRPr lang="en-US" sz="1600" dirty="0"/>
           </a:p>
@@ -13212,7 +13269,7 @@
       </p:sp>
       <p:graphicFrame>
         <p:nvGraphicFramePr>
-          <p:cNvPr id="9" name="failures-114"/>
+          <p:cNvPr id="9" name="failures-115"/>
           <p:cNvGraphicFramePr>
             <a:graphicFrameLocks noGrp="1"/>
           </p:cNvGraphicFramePr>
@@ -14260,7 +14317,7 @@
       </p:sp>
       <p:sp>
         <p:nvSpPr>
-          <p:cNvPr id="3" name="zendesk-head-115"/>
+          <p:cNvPr id="3" name="zendesk-head-116"/>
           <p:cNvSpPr txBox="1"/>
           <p:nvPr/>
         </p:nvSpPr>
@@ -14299,7 +14356,7 @@
       </p:sp>
       <p:sp>
         <p:nvSpPr>
-          <p:cNvPr id="4" name="step-116"/>
+          <p:cNvPr id="4" name="step-117"/>
           <p:cNvSpPr txBox="1"/>
           <p:nvPr/>
         </p:nvSpPr>
@@ -14341,7 +14398,7 @@
       </p:sp>
       <p:sp>
         <p:nvSpPr>
-          <p:cNvPr id="5" name="zendesk-step-117"/>
+          <p:cNvPr id="5" name="zendesk-step-118"/>
           <p:cNvSpPr txBox="1"/>
           <p:nvPr/>
         </p:nvSpPr>
@@ -14394,7 +14451,7 @@
       </p:sp>
       <p:sp>
         <p:nvSpPr>
-          <p:cNvPr id="6" name="step-118"/>
+          <p:cNvPr id="6" name="step-119"/>
           <p:cNvSpPr txBox="1"/>
           <p:nvPr/>
         </p:nvSpPr>
@@ -14436,7 +14493,7 @@
       </p:sp>
       <p:sp>
         <p:nvSpPr>
-          <p:cNvPr id="7" name="zendesk-step-119"/>
+          <p:cNvPr id="7" name="zendesk-step-120"/>
           <p:cNvSpPr txBox="1"/>
           <p:nvPr/>
         </p:nvSpPr>
@@ -14489,7 +14546,7 @@
       </p:sp>
       <p:sp>
         <p:nvSpPr>
-          <p:cNvPr id="8" name="step-120"/>
+          <p:cNvPr id="8" name="step-121"/>
           <p:cNvSpPr txBox="1"/>
           <p:nvPr/>
         </p:nvSpPr>
@@ -14531,7 +14588,7 @@
       </p:sp>
       <p:sp>
         <p:nvSpPr>
-          <p:cNvPr id="9" name="zendesk-step-121"/>
+          <p:cNvPr id="9" name="zendesk-step-122"/>
           <p:cNvSpPr txBox="1"/>
           <p:nvPr/>
         </p:nvSpPr>
@@ -14584,7 +14641,7 @@
       </p:sp>
       <p:sp>
         <p:nvSpPr>
-          <p:cNvPr id="10" name="step-122"/>
+          <p:cNvPr id="10" name="step-123"/>
           <p:cNvSpPr txBox="1"/>
           <p:nvPr/>
         </p:nvSpPr>
@@ -14626,7 +14683,7 @@
       </p:sp>
       <p:sp>
         <p:nvSpPr>
-          <p:cNvPr id="11" name="zendesk-step-123"/>
+          <p:cNvPr id="11" name="zendesk-step-124"/>
           <p:cNvSpPr txBox="1"/>
           <p:nvPr/>
         </p:nvSpPr>
@@ -14679,7 +14736,7 @@
       </p:sp>
       <p:sp>
         <p:nvSpPr>
-          <p:cNvPr id="12" name="step-124"/>
+          <p:cNvPr id="12" name="step-125"/>
           <p:cNvSpPr txBox="1"/>
           <p:nvPr/>
         </p:nvSpPr>
@@ -14721,7 +14778,7 @@
       </p:sp>
       <p:sp>
         <p:nvSpPr>
-          <p:cNvPr id="13" name="zendesk-step-125"/>
+          <p:cNvPr id="13" name="zendesk-step-126"/>
           <p:cNvSpPr txBox="1"/>
           <p:nvPr/>
         </p:nvSpPr>
@@ -14774,7 +14831,7 @@
       </p:sp>
       <p:sp>
         <p:nvSpPr>
-          <p:cNvPr id="14" name="zendesk-foot-126"/>
+          <p:cNvPr id="14" name="zendesk-foot-127"/>
           <p:cNvSpPr txBox="1"/>
           <p:nvPr/>
         </p:nvSpPr>
@@ -14810,7 +14867,7 @@
       </p:sp>
       <p:sp>
         <p:nvSpPr>
-          <p:cNvPr id="15" name="ports-head-127"/>
+          <p:cNvPr id="15" name="ports-head-128"/>
           <p:cNvSpPr txBox="1"/>
           <p:nvPr/>
         </p:nvSpPr>
@@ -14849,7 +14906,7 @@
       </p:sp>
       <p:sp>
         <p:nvSpPr>
-          <p:cNvPr id="16" name="svc-128"/>
+          <p:cNvPr id="16" name="svc-129"/>
           <p:cNvSpPr txBox="1"/>
           <p:nvPr/>
         </p:nvSpPr>
@@ -14913,7 +14970,7 @@
       </p:sp>
       <p:sp>
         <p:nvSpPr>
-          <p:cNvPr id="17" name="ports-129"/>
+          <p:cNvPr id="17" name="ports-130"/>
           <p:cNvSpPr txBox="1"/>
           <p:nvPr/>
         </p:nvSpPr>
@@ -14977,7 +15034,7 @@
       </p:sp>
       <p:sp>
         <p:nvSpPr>
-          <p:cNvPr id="18" name="adapters-130"/>
+          <p:cNvPr id="18" name="adapters-131"/>
           <p:cNvSpPr txBox="1"/>
           <p:nvPr/>
         </p:nvSpPr>
@@ -15041,7 +15098,7 @@
       </p:sp>
       <p:sp>
         <p:nvSpPr>
-          <p:cNvPr id="19" name="arrow-131"/>
+          <p:cNvPr id="19" name="arrow-132"/>
           <p:cNvSpPr/>
           <p:nvPr/>
         </p:nvSpPr>
@@ -15065,7 +15122,7 @@
       </p:sp>
       <p:sp>
         <p:nvSpPr>
-          <p:cNvPr id="20" name="arrow-132"/>
+          <p:cNvPr id="20" name="arrow-133"/>
           <p:cNvSpPr/>
           <p:nvPr/>
         </p:nvSpPr>
@@ -15089,7 +15146,7 @@
       </p:sp>
       <p:sp>
         <p:nvSpPr>
-          <p:cNvPr id="21" name="ports-foot-133"/>
+          <p:cNvPr id="21" name="ports-foot-134"/>
           <p:cNvSpPr txBox="1"/>
           <p:nvPr/>
         </p:nvSpPr>
@@ -15125,7 +15182,7 @@
       </p:sp>
       <p:sp>
         <p:nvSpPr>
-          <p:cNvPr id="22" name="swap-head-134"/>
+          <p:cNvPr id="22" name="swap-head-135"/>
           <p:cNvSpPr txBox="1"/>
           <p:nvPr/>
         </p:nvSpPr>
@@ -15164,7 +15221,7 @@
       </p:sp>
       <p:sp>
         <p:nvSpPr>
-          <p:cNvPr id="23" name="pg-135"/>
+          <p:cNvPr id="23" name="pg-136"/>
           <p:cNvSpPr txBox="1"/>
           <p:nvPr/>
         </p:nvSpPr>
@@ -15253,7 +15310,7 @@
       </p:sp>
       <p:sp>
         <p:nvSpPr>
-          <p:cNvPr id="24" name="broker-136"/>
+          <p:cNvPr id="24" name="broker-137"/>
           <p:cNvSpPr txBox="1"/>
           <p:nvPr/>
         </p:nvSpPr>

</xml_diff>

<commit_message>
docs: review round 3 accuracy pass
- Content-blind duplicate gap stated in README, qa_bank and failure_scenarios
- 200-vs-202 claim cites their troubleshooting section; no longer quoted as their words
- PII claim cites their platform page with one canonical sentence
- One sentence each for layering, deletes, dedup; deck notes match
- Deck slide 10: top three in ledger order, demo watch list matches demo_script
- Small fixes: step numbers, phase status, ledger line, section names, ADR-002 types
- Ignore .idea/

Co-Authored-By: Claude Opus 5.5 <noreply@anthropic.com>
</commit_message>
<xml_diff>
--- a/docs/slides/deck.pptx
+++ b/docs/slides/deck.pptx
@@ -640,10 +640,10 @@
             <a:r>
               <a:rPr lang="en-US" dirty="0"/>
               <a:t>Debt ledger, top three (debt_ledger.md):
-1. #1, migrations (db.py:39). "We fail fast on schema drift today; the first schema change on real data is when I add Alembic migrations."
-2. #12, the shared bootstrap token (tenants.py:18). "A shared token is enough to bootstrap a take-home; production admin needs per-person identity and an audit trail."
-3. #6, the Discourse 10-page cap (discourse_pull.py:29). About 500 posts per day is the hard limit of Discourse search. "A hard cap with a loud error beats silently skipping posts, but a forum busier than about 500 posts a day would need date slicing." Mitigation today: lower window_days with PATCH /v1/sources/{id}. Upgrade: split the window by date and page through each slice, or shrink the window on its own when the cap is hit.
-Demo (demo_script.md): eleven steps, about two minutes. demo.sh exports a random FI_BOOTSTRAP_TOKEN first, because the default token is refused. Two synthetic tenants: lumenote (a consumer app) and brightwave (B2B SaaS). Watch for five things: a duplicate that is stored once, two apps of the same type, a tenant that sees nothing, one custom batch that becomes three records of three kinds, an Intercom conversation and a tweet in the same record shape, and a kill -9 that loses nothing. Step 9 needs network (meta.discourse.org); without it run uv run pytest tests/e2e/test_pull_to_query.py -q.
+1. #6, the Discourse 10-page cap (discourse_pull.py:29). About 500 posts per day is the hard limit of Discourse search. "A hard cap with a loud error beats silently skipping posts, but a forum busier than about 500 posts a day would need date slicing." Mitigation today: lower window_days with PATCH /v1/sources/{id}. Upgrade: split the window by date and page through each slice, or shrink the window on its own when the cap is hit.
+2. #1, migrations (db.py:39). "We fail fast on schema drift today; the first schema change on real data is when I add Alembic migrations."
+3. #12, the shared bootstrap token (tenants.py:18). "A shared token is enough to bootstrap a take-home; production admin needs per-person identity and an audit trail."
+Demo (demo_script.md): eleven steps, about two minutes. demo.sh exports a random FI_BOOTSTRAP_TOKEN first, because the default token is refused. Two synthetic tenants: lumenote (a consumer app) and brightwave (B2B SaaS). Watch for four things: a duplicate that is stored once, two apps of the same type, a tenant that sees nothing, and a kill -9 that loses nothing. Plus one batch from the custom webhook that becomes three records of three kinds, and an Intercom conversation and a tweet in the same record shape. Step 9 needs network (meta.discourse.org); without it run uv run pytest tests/e2e/test_pull_to_query.py -q.
 30-second close: "So, the four things: a duplicate stored once, two apps of the same type kept apart, a tenant that sees nothing of another, and a hard kill that lost nothing. Plus a bad payload parked with its reason and replayed, and a live pull through the same pipeline. All of it rests on one rule: save the raw payload before we say yes, then everything is a retry or a replay. Adding a new source is an enum value, a metadata model, one connector file, one registry entry and fixtures, and the custom connector shows it. Happy to add a field live, or to break something and show you where it lands."</a:t>
             </a:r>
             <a:endParaRPr lang="en-US" dirty="0"/>
@@ -736,12 +736,12 @@
 Opening line: "Enterpret's site describes the product as Unify, Understand, Act. This service is the Unify step: it gets feedback in from many sources, keeps it safe, and turns it into one standard Feedback Record. Taxonomy, themes and Wisdom are the Understand step, and they would read our records; I did not build them."
 Custom connector: "Their public webhook takes a batch of records with an id, a type, createdAt in epoch seconds and typed metadata. Our custom connector takes that same shape, so the add-a-source story is done against a contract they know. One push is one raw event. Each record upserts on source and record id. The kind comes from the type, and SURVEY needed a new kind, survey. AUDIO_RECORDING is not text, so it is refused and the batch goes dead."
 Auth difference: their docs describe an api-key header per integration. Ours is a per-source URL plus an HMAC signature, so a sender proves itself without holding a tenant key. Same idea: one credential per source.
-202: "Their webhook docs warn that a 200 does not guarantee the records appear. Our 202 is the same promise: the raw row is on disk and the worker does the rest, and a bad payload shows on the dead list instead of vanishing."
+202: "Their webhook article has a section on a 200 OK whose records still do not appear in the dashboard; our 202 draws the same line: saved on disk, processed later. The raw row is on disk and the worker does the rest, and a bad payload shows on the dead list instead of vanishing."
 Duplicates: "Their default skips a repeated id, and replace is an opt-in. We skip a repeated delivery at raw_events. For the record itself we always take a newer or equal version and never an older one, which is close to their opt-in replace plus the version rule."
 Version guard: "Their engineering blog says stale and out-of-order updates are rejected by version. Our upsert does the same with COALESCE(updated, created)."
 Noisy neighbours: "Their engineering blog names queue clogging and noisy neighbours as incidents and describes partitioning by tenant. We have one shared queue, so a burst delays others but loses nothing. Per-tenant claiming is the upgrade."
 Not built, on purpose: PII redaction before storage (we only keep it out of logs and error text), the ClickHouse analytics projection their blog describes, rate limits, users and accounts. Their help center describes a 4-hour poll for support tools and app stores; ours is FI_PULL_INTERVAL_SECONDS, 300 by default.
-Verified on 2026-10-03 against the help-center pages cited in docs/research/01: the webhook article (12131693: record types incl. AUDIO_RECORDING, createdAt as epoch seconds, typed metadata, duplicate ids skipped by default with replace opt-in via support, a 200 that does not guarantee records appear, api-key header) and the Google Play (6331595) and Intercom (6320475) articles (new data every 4 hours). Dropped: the "PII obfuscated before ingestion" cell, which is not on those pages. The engineering-blog rows quote the blog and were not re-checked here.</a:t>
+Verified on 2026-10-03 against the help-center pages cited in docs/research/01: the webhook article (12131693: record types incl. AUDIO_RECORDING, createdAt as epoch seconds, typed metadata, duplicate ids skipped by default with replace opt-in via support, a troubleshooting section on a 200 OK whose records do not appear, api-key header) and the Google Play (6331595) and Intercom (6320475) articles (new data every 4 hours). Dropped: the "PII obfuscated before ingestion" cell, which is not on those pages. The engineering-blog rows quote the blog and were not re-checked here.</a:t>
             </a:r>
             <a:endParaRPr lang="en-US" dirty="0"/>
           </a:p>
@@ -1308,7 +1308,7 @@
               <a:t>What to draw when they push (whiteboard.md):
 Duplicate webhook (failure_scenarios.md): "Same item, same update time, same key: the second copy is dropped and we still answer 202."
 Edits out of order: draw two arrows into one record with timestamps. "COALESCE(updated, created) must not be older. Equal is accepted, so replay works." That is the COALESCE rule, applied in Python today (merge in domain/models.py) inside BEGIN IMMEDIATE; the SQL ON CONFLICT … WHERE form is the Postgres upgrade (extensions recipe 2). Or: "A record only moves forward in time: an older edit that arrives late loses the timestamp check."
-Source deletes: "Only Discourse push payloads carry a delete today and it becomes a tombstone; Twitter and Intercom deletes go dead on purpose; pull-side Discourse deletes are invisible (README, not built)."
+Source deletes: "Only Discourse push payloads carry a delete today and it becomes a tombstone. Twitter deletes and Intercom redactions go dead on purpose; an Intercom `conversation.deleted` is not special-cased (dead on validation, or an upsert if it carries a full conversation); pull-side Discourse deletes are invisible (README, not built)."
 Transformer bug last week: draw an arrow from raw_events back into the pipeline. "Fix the connector, bump its version, replay. No re-fetch, nothing lost." Bulk replay: POST /admin/raw-events/replay?source_id=...&amp;status=dead (or failed, or processed), up to 500 rows a call, only the caller's tenant. There is no time-window filter. Replay goes through the same version guard, so an equal version is accepted and the fixed output overwrites the record. Order does not matter: an older version is skipped and a delete, once applied, sticks.
 The stored payload is the parsed JSON, not the raw bytes, so the signature cannot be re-checked from storage; a pulled Discourse post also carries the topic title we add.
 Demo step 8 shows replay: a malformed Playstore payload goes dead on the first try; replay resets attempts to 0 (the claim bumps them to 1) and it dies again because the payload really is bad. "That proves replay re-runs the stored payload. After a real connector fix, the same call brings it back."</a:t>
@@ -1498,7 +1498,7 @@
               <a:rPr lang="en-US" dirty="0"/>
               <a:t>Connectors (whiteboard.md step 3): "A connector validates the payload with a Pydantic input model, then maps it to our record. Nothing else in the system knows which sources exist. Adding a source is five steps: an enum value, a metadata model, a connector file, a registry entry and fixtures. The contract test fails until all five exist." (Full recipe: ADR-003 "How to add a new source".) For Zendesk, a ticket is a conversation, so reuse that kind. tests/unit/connectors/test_registry.py and the every-source-has-a-metadata-model test fail first; then the contract tests run every fixture.
 Worked example: the custom connector (connectors/custom.py) was added exactly this way, with one extra: its kind comes from each record's type, so it maps in KIND_BY_RECORD_TYPE instead of KIND_BY_SOURCE.
-Ports and adapters: "Services only import the ports. The same contract test runs against the SQLite adapter and the in-memory fake, so I know the fake behaves like the real thing. That keeps a storage swap inside the adapters: for Postgres, three queries change, not the services."
+Ports and adapters: "Services import ports, the domain and the connector registry; never adapters, SQLAlchemy or httpx. The same contract test runs against the SQLite adapter and the in-memory fake, so I know the fake behaves like the real thing. That keeps a storage swap inside the adapters: for Postgres, three queries change, not the services."
 Postgres (extensions.md recipe 2): the claim subquery gets with_for_update(skip_locked=True); upsert and enqueue move to INSERT ... ON CONFLICT; add Alembic migrations. Never say SKIP LOCKED runs today.
 Kafka: "Swap the adapter, and change the retry model. Kafka: consumer offsets instead of leases, and retry topics because there is no per-message delay. SQS would use a visibility timeout." A broker cannot answer "show me tenant X's dead events" or "give me event 42", so the realistic design keeps raw_events as the durable log and puts only event ids on the broker.
 Never say Kafka is a one-adapter swap without adding "and a different retry model".</a:t>

</xml_diff>